<commit_message>
slides: them slide 17 cam on, cap nhat so trang
</commit_message>
<xml_diff>
--- a/docs/slides/Nhom08_XLNNTN_BaoCao.pptx
+++ b/docs/slides/Nhom08_XLNNTN_BaoCao.pptx
@@ -24,6 +24,7 @@
     <p:sldId id="269" r:id="rId15"/>
     <p:sldId id="270" r:id="rId16"/>
     <p:sldId id="271" r:id="rId17"/>
+    <p:sldId id="272" r:id="rId23"/>
   </p:sldIdLst>
   <p:sldSz cx="12192000" cy="6858000"/>
   <p:notesSz cx="6858000" cy="12192000"/>
@@ -3574,6 +3575,58 @@
         <p14:creationId xmlns:p14="http://schemas.microsoft.com/office/powerpoint/2010/main" val="1024086991"/>
       </p:ext>
     </p:extLst>
+  </p:cSld>
+  <p:clrMapOvr>
+    <a:masterClrMapping/>
+  </p:clrMapOvr>
+</p:notes>
+</file>
+
+<file path=ppt/notesSlides/notesSlide17.xml><?xml version="1.0" encoding="utf-8"?>
+<p:notes xmlns:a="http://schemas.openxmlformats.org/drawingml/2006/main" xmlns:p="http://schemas.openxmlformats.org/presentationml/2006/main" xmlns:r="http://schemas.openxmlformats.org/officeDocument/2006/relationships">
+  <p:cSld>
+    <p:spTree>
+      <p:nvGrpSpPr>
+        <p:cNvPr id="1" name=""/>
+        <p:cNvGrpSpPr/>
+        <p:nvPr/>
+      </p:nvGrpSpPr>
+      <p:grpSpPr>
+        <a:xfrm>
+          <a:off x="0" y="0"/>
+          <a:ext cx="0" cy="0"/>
+          <a:chOff x="0" y="0"/>
+          <a:chExt cx="0" cy="0"/>
+        </a:xfrm>
+      </p:grpSpPr>
+      <p:sp>
+        <p:nvSpPr>
+          <p:cNvPr id="3" name="Notes Placeholder 2"/>
+          <p:cNvSpPr>
+            <a:spLocks noGrp="1"/>
+          </p:cNvSpPr>
+          <p:nvPr>
+            <p:ph type="body" idx="1"/>
+          </p:nvPr>
+        </p:nvSpPr>
+        <p:spPr/>
+        <p:txBody>
+          <a:bodyPr/>
+          <a:lstStyle/>
+          <a:p>
+            <a:r>
+              <a:t>Cả nhóm  ·  khoảng 5 giây</a:t>
+            </a:r>
+          </a:p>
+          <a:p/>
+          <a:p>
+            <a:r>
+              <a:t>Nhóm em xin cảm ơn thầy và các bạn đã lắng nghe.</a:t>
+            </a:r>
+          </a:p>
+        </p:txBody>
+      </p:sp>
+    </p:spTree>
   </p:cSld>
   <p:clrMapOvr>
     <a:masterClrMapping/>
@@ -5177,7 +5230,7 @@
                 <a:ea typeface="Consolas" pitchFamily="34" charset="-122"/>
                 <a:cs typeface="Consolas" pitchFamily="34" charset="-120"/>
               </a:rPr>
-              <a:t>10 / 16</a:t>
+              <a:t>10 / 17</a:t>
             </a:r>
             <a:endParaRPr lang="en-US" sz="1000" dirty="0"/>
           </a:p>
@@ -5580,7 +5633,7 @@
                 <a:ea typeface="Consolas" pitchFamily="34" charset="-122"/>
                 <a:cs typeface="Consolas" pitchFamily="34" charset="-120"/>
               </a:rPr>
-              <a:t>11 / 16</a:t>
+              <a:t>11 / 17</a:t>
             </a:r>
             <a:endParaRPr lang="en-US" sz="1000" dirty="0"/>
           </a:p>
@@ -6503,7 +6556,7 @@
                 <a:ea typeface="Consolas" pitchFamily="34" charset="-122"/>
                 <a:cs typeface="Consolas" pitchFamily="34" charset="-120"/>
               </a:rPr>
-              <a:t>12 / 16</a:t>
+              <a:t>12 / 17</a:t>
             </a:r>
             <a:endParaRPr lang="en-US" sz="1000" dirty="0"/>
           </a:p>
@@ -6911,7 +6964,7 @@
                 <a:ea typeface="Consolas" pitchFamily="34" charset="-122"/>
                 <a:cs typeface="Consolas" pitchFamily="34" charset="-120"/>
               </a:rPr>
-              <a:t>13 / 16</a:t>
+              <a:t>13 / 17</a:t>
             </a:r>
             <a:endParaRPr lang="en-US" sz="1000" dirty="0"/>
           </a:p>
@@ -7672,7 +7725,7 @@
                 <a:ea typeface="Consolas" pitchFamily="34" charset="-122"/>
                 <a:cs typeface="Consolas" pitchFamily="34" charset="-120"/>
               </a:rPr>
-              <a:t>14 / 16</a:t>
+              <a:t>14 / 17</a:t>
             </a:r>
             <a:endParaRPr lang="en-US" sz="1000" dirty="0"/>
           </a:p>
@@ -8774,7 +8827,7 @@
                 <a:ea typeface="Consolas" pitchFamily="34" charset="-122"/>
                 <a:cs typeface="Consolas" pitchFamily="34" charset="-120"/>
               </a:rPr>
-              <a:t>15 / 16</a:t>
+              <a:t>15 / 17</a:t>
             </a:r>
             <a:endParaRPr lang="en-US" sz="1000" dirty="0"/>
           </a:p>
@@ -8966,7 +9019,7 @@
                 <a:ea typeface="Consolas" pitchFamily="34" charset="-122"/>
                 <a:cs typeface="Consolas" pitchFamily="34" charset="-120"/>
               </a:rPr>
-              <a:t>16 / 16</a:t>
+              <a:t>17 / 17</a:t>
             </a:r>
             <a:endParaRPr lang="en-US" sz="1000" dirty="0"/>
           </a:p>
@@ -9553,6 +9606,224 @@
               <a:t>[27] GreenNode. zalo-ai-legal-text-retrieval-vn (dataset card). https://huggingface.co/datasets/GreenNode/zalo-ai-legal-text-retrieval-vn</a:t>
             </a:r>
             <a:endParaRPr lang="en-US" sz="950" dirty="0"/>
+          </a:p>
+        </p:txBody>
+      </p:sp>
+    </p:spTree>
+  </p:cSld>
+  <p:clrMapOvr>
+    <a:masterClrMapping/>
+  </p:clrMapOvr>
+</p:sld>
+</file>
+
+<file path=ppt/slides/slide17.xml><?xml version="1.0" encoding="utf-8"?>
+<p:sld xmlns:a="http://schemas.openxmlformats.org/drawingml/2006/main" xmlns:r="http://schemas.openxmlformats.org/officeDocument/2006/relationships" xmlns:p="http://schemas.openxmlformats.org/presentationml/2006/main">
+  <p:cSld name="Slide 1">
+    <p:bg>
+      <p:bgPr>
+        <a:blipFill dpi="0" rotWithShape="1">
+          <a:blip r:embed="rId3">
+            <a:lum/>
+          </a:blip>
+          <a:srcRect/>
+          <a:stretch>
+            <a:fillRect/>
+          </a:stretch>
+        </a:blipFill>
+        <a:effectLst/>
+      </p:bgPr>
+    </p:bg>
+    <p:spTree>
+      <p:nvGrpSpPr>
+        <p:cNvPr id="1" name=""/>
+        <p:cNvGrpSpPr/>
+        <p:nvPr/>
+      </p:nvGrpSpPr>
+      <p:grpSpPr>
+        <a:xfrm>
+          <a:off x="0" y="0"/>
+          <a:ext cx="0" cy="0"/>
+          <a:chOff x="0" y="0"/>
+          <a:chExt cx="0" cy="0"/>
+        </a:xfrm>
+      </p:grpSpPr>
+      <p:sp>
+        <p:nvSpPr>
+          <p:cNvPr id="2" name="Text 0"/>
+          <p:cNvSpPr txBox="1"/>
+          <p:nvPr/>
+        </p:nvSpPr>
+        <p:spPr>
+          <a:xfrm>
+            <a:off x="594360" y="502920"/>
+            <a:ext cx="7315200" cy="320040"/>
+          </a:xfrm>
+          <a:prstGeom prst="rect">
+            <a:avLst/>
+          </a:prstGeom>
+          <a:noFill/>
+          <a:ln/>
+        </p:spPr>
+        <p:txBody>
+          <a:bodyPr wrap="square" lIns="0" tIns="0" rIns="0" bIns="0" rtlCol="0" anchor="ctr"/>
+          <a:lstStyle/>
+          <a:p>
+            <a:pPr marL="0" indent="0">
+              <a:buNone/>
+            </a:pPr>
+            <a:r>
+              <a:rPr lang="en-US" sz="1400" b="1" dirty="0">
+                <a:solidFill>
+                  <a:srgbClr val="FFFFFF"/>
+                </a:solidFill>
+                <a:latin typeface="Calibri" pitchFamily="34" charset="0"/>
+                <a:ea typeface="Calibri" pitchFamily="34" charset="-122"/>
+                <a:cs typeface="Calibri" pitchFamily="34" charset="-120"/>
+              </a:rPr>
+              <a:t>Trường Đại học Công nghệ Thông tin, ĐHQG-HCM</a:t>
+            </a:r>
+            <a:endParaRPr lang="en-US" sz="1400" dirty="0"/>
+          </a:p>
+        </p:txBody>
+      </p:sp>
+      <p:sp>
+        <p:nvSpPr>
+          <p:cNvPr id="3" name="Text 1"/>
+          <p:cNvSpPr txBox="1"/>
+          <p:nvPr/>
+        </p:nvSpPr>
+        <p:spPr>
+          <a:xfrm>
+            <a:off x="594360" y="1874520"/>
+            <a:ext cx="7315200" cy="274320"/>
+          </a:xfrm>
+          <a:prstGeom prst="rect">
+            <a:avLst/>
+          </a:prstGeom>
+          <a:noFill/>
+          <a:ln/>
+        </p:spPr>
+        <p:txBody>
+          <a:bodyPr wrap="square" lIns="0" tIns="0" rIns="0" bIns="0" rtlCol="0" anchor="ctr"/>
+          <a:lstStyle/>
+          <a:p>
+            <a:pPr marL="0" indent="0">
+              <a:buNone/>
+            </a:pPr>
+            <a:r>
+              <a:rPr lang="en-US" sz="1200" kern="0" spc="200" dirty="0">
+                <a:solidFill>
+                  <a:srgbClr val="9FC2DB"/>
+                </a:solidFill>
+                <a:latin typeface="Consolas" pitchFamily="34" charset="0"/>
+                <a:ea typeface="Consolas" pitchFamily="34" charset="-122"/>
+                <a:cs typeface="Consolas" pitchFamily="34" charset="-120"/>
+              </a:rPr>
+              <a:t>BÁO CÁO ĐỒ ÁN  ·  XỬ LÝ NGÔN NGỮ TỰ NHIÊN</a:t>
+            </a:r>
+            <a:endParaRPr lang="en-US" sz="1200" dirty="0"/>
+          </a:p>
+        </p:txBody>
+      </p:sp>
+      <p:sp>
+        <p:nvSpPr>
+          <p:cNvPr id="4" name="Text 2"/>
+          <p:cNvSpPr txBox="1"/>
+          <p:nvPr/>
+        </p:nvSpPr>
+        <p:spPr>
+          <a:xfrm>
+            <a:off x="594360" y="2240280"/>
+            <a:ext cx="6766560" cy="1600200"/>
+          </a:xfrm>
+          <a:prstGeom prst="rect">
+            <a:avLst/>
+          </a:prstGeom>
+          <a:noFill/>
+          <a:ln/>
+        </p:spPr>
+        <p:txBody>
+          <a:bodyPr wrap="square" lIns="0" tIns="0" rIns="0" bIns="0" rtlCol="0" anchor="t"/>
+          <a:lstStyle/>
+          <a:p>
+            <a:pPr marL="0" indent="0">
+              <a:lnSpc>
+                <a:spcPct val="95000"/>
+              </a:lnSpc>
+              <a:buNone/>
+            </a:pPr>
+            <a:r>
+              <a:rPr lang="en-US" sz="4000" b="1" dirty="0">
+                <a:solidFill>
+                  <a:srgbClr val="FFFFFF"/>
+                </a:solidFill>
+                <a:latin typeface="Cambria" pitchFamily="34" charset="0"/>
+                <a:ea typeface="Cambria" pitchFamily="34" charset="-122"/>
+                <a:cs typeface="Cambria" pitchFamily="34" charset="-120"/>
+              </a:rPr>
+              <a:t>Cảm ơn thầy và các bạn</a:t>
+            </a:r>
+            <a:endParaRPr lang="en-US" sz="4000" dirty="0"/>
+          </a:p>
+          <a:p>
+            <a:pPr marL="0" indent="0">
+              <a:lnSpc>
+                <a:spcPct val="95000"/>
+              </a:lnSpc>
+              <a:buNone/>
+            </a:pPr>
+            <a:r>
+              <a:rPr lang="en-US" sz="4000" b="1" dirty="0">
+                <a:solidFill>
+                  <a:srgbClr val="FFFFFF"/>
+                </a:solidFill>
+                <a:latin typeface="Cambria" pitchFamily="34" charset="0"/>
+                <a:ea typeface="Cambria" pitchFamily="34" charset="-122"/>
+                <a:cs typeface="Cambria" pitchFamily="34" charset="-120"/>
+              </a:rPr>
+              <a:t>đã lắng nghe</a:t>
+            </a:r>
+            <a:endParaRPr lang="en-US" sz="4000" dirty="0"/>
+          </a:p>
+        </p:txBody>
+      </p:sp>
+      <p:sp>
+        <p:nvSpPr>
+          <p:cNvPr id="7" name="Text 5"/>
+          <p:cNvSpPr txBox="1"/>
+          <p:nvPr/>
+        </p:nvSpPr>
+        <p:spPr>
+          <a:xfrm>
+            <a:off x="594360" y="6355080"/>
+            <a:ext cx="5486400" cy="274320"/>
+          </a:xfrm>
+          <a:prstGeom prst="rect">
+            <a:avLst/>
+          </a:prstGeom>
+          <a:noFill/>
+          <a:ln/>
+        </p:spPr>
+        <p:txBody>
+          <a:bodyPr wrap="square" lIns="0" tIns="0" rIns="0" bIns="0" rtlCol="0" anchor="ctr"/>
+          <a:lstStyle/>
+          <a:p>
+            <a:pPr marL="0" indent="0">
+              <a:buNone/>
+            </a:pPr>
+            <a:r>
+              <a:rPr lang="en-US" sz="1100" dirty="0">
+                <a:solidFill>
+                  <a:srgbClr val="9AA8B2"/>
+                </a:solidFill>
+                <a:latin typeface="Calibri" pitchFamily="34" charset="0"/>
+                <a:ea typeface="Calibri" pitchFamily="34" charset="-122"/>
+                <a:cs typeface="Calibri" pitchFamily="34" charset="-120"/>
+              </a:rPr>
+              <a:t>TP. Hồ Chí Minh, tháng 9 năm 2026</a:t>
+            </a:r>
+            <a:endParaRPr lang="en-US" sz="1100" dirty="0"/>
           </a:p>
         </p:txBody>
       </p:sp>
@@ -9742,7 +10013,7 @@
                 <a:ea typeface="Consolas" pitchFamily="34" charset="-122"/>
                 <a:cs typeface="Consolas" pitchFamily="34" charset="-120"/>
               </a:rPr>
-              <a:t>02 / 16</a:t>
+              <a:t>02 / 17</a:t>
             </a:r>
             <a:endParaRPr lang="en-US" sz="1000" dirty="0"/>
           </a:p>
@@ -10495,7 +10766,7 @@
                 <a:ea typeface="Consolas" pitchFamily="34" charset="-122"/>
                 <a:cs typeface="Consolas" pitchFamily="34" charset="-120"/>
               </a:rPr>
-              <a:t>03 / 16</a:t>
+              <a:t>03 / 17</a:t>
             </a:r>
             <a:endParaRPr lang="en-US" sz="1000" dirty="0"/>
           </a:p>
@@ -12041,7 +12312,7 @@
                 <a:ea typeface="Consolas" pitchFamily="34" charset="-122"/>
                 <a:cs typeface="Consolas" pitchFamily="34" charset="-120"/>
               </a:rPr>
-              <a:t>04 / 16</a:t>
+              <a:t>04 / 17</a:t>
             </a:r>
             <a:endParaRPr lang="en-US" sz="1000" dirty="0"/>
           </a:p>
@@ -13013,7 +13284,7 @@
                 <a:ea typeface="Consolas" pitchFamily="34" charset="-122"/>
                 <a:cs typeface="Consolas" pitchFamily="34" charset="-120"/>
               </a:rPr>
-              <a:t>05 / 16</a:t>
+              <a:t>05 / 17</a:t>
             </a:r>
             <a:endParaRPr lang="en-US" sz="1000" dirty="0"/>
           </a:p>
@@ -13572,7 +13843,7 @@
                 <a:ea typeface="Consolas" pitchFamily="34" charset="-122"/>
                 <a:cs typeface="Consolas" pitchFamily="34" charset="-120"/>
               </a:rPr>
-              <a:t>06 / 16</a:t>
+              <a:t>06 / 17</a:t>
             </a:r>
             <a:endParaRPr lang="en-US" sz="1000" dirty="0"/>
           </a:p>
@@ -14804,7 +15075,7 @@
                 <a:ea typeface="Consolas" pitchFamily="34" charset="-122"/>
                 <a:cs typeface="Consolas" pitchFamily="34" charset="-120"/>
               </a:rPr>
-              <a:t>07 / 16</a:t>
+              <a:t>07 / 17</a:t>
             </a:r>
             <a:endParaRPr lang="en-US" sz="1000" dirty="0"/>
           </a:p>
@@ -15722,7 +15993,7 @@
                 <a:ea typeface="Consolas" pitchFamily="34" charset="-122"/>
                 <a:cs typeface="Consolas" pitchFamily="34" charset="-120"/>
               </a:rPr>
-              <a:t>08 / 16</a:t>
+              <a:t>08 / 17</a:t>
             </a:r>
             <a:endParaRPr lang="en-US" sz="1000" dirty="0"/>
           </a:p>
@@ -16996,7 +17267,7 @@
                 <a:ea typeface="Consolas" pitchFamily="34" charset="-122"/>
                 <a:cs typeface="Consolas" pitchFamily="34" charset="-120"/>
               </a:rPr>
-              <a:t>09 / 16</a:t>
+              <a:t>09 / 17</a:t>
             </a:r>
             <a:endParaRPr lang="en-US" sz="1000" dirty="0"/>
           </a:p>

</xml_diff>

<commit_message>
slides: them slide bo cuc, nhan phan o goc phai, danh lai so trang
</commit_message>
<xml_diff>
--- a/docs/slides/Nhom08_XLNNTN_BaoCao.pptx
+++ b/docs/slides/Nhom08_XLNNTN_BaoCao.pptx
@@ -9,6 +9,7 @@
   </p:notesMasterIdLst>
   <p:sldIdLst>
     <p:sldId id="256" r:id="rId2"/>
+    <p:sldId id="273" r:id="rId24"/>
     <p:sldId id="257" r:id="rId3"/>
     <p:sldId id="258" r:id="rId4"/>
     <p:sldId id="259" r:id="rId5"/>
@@ -3622,6 +3623,58 @@
           <a:p>
             <a:r>
               <a:t>Nhóm em xin cảm ơn thầy và các bạn đã lắng nghe.</a:t>
+            </a:r>
+          </a:p>
+        </p:txBody>
+      </p:sp>
+    </p:spTree>
+  </p:cSld>
+  <p:clrMapOvr>
+    <a:masterClrMapping/>
+  </p:clrMapOvr>
+</p:notes>
+</file>
+
+<file path=ppt/notesSlides/notesSlide18.xml><?xml version="1.0" encoding="utf-8"?>
+<p:notes xmlns:a="http://schemas.openxmlformats.org/drawingml/2006/main" xmlns:p="http://schemas.openxmlformats.org/presentationml/2006/main" xmlns:r="http://schemas.openxmlformats.org/officeDocument/2006/relationships">
+  <p:cSld>
+    <p:spTree>
+      <p:nvGrpSpPr>
+        <p:cNvPr id="1" name=""/>
+        <p:cNvGrpSpPr/>
+        <p:nvPr/>
+      </p:nvGrpSpPr>
+      <p:grpSpPr>
+        <a:xfrm>
+          <a:off x="0" y="0"/>
+          <a:ext cx="0" cy="0"/>
+          <a:chOff x="0" y="0"/>
+          <a:chExt cx="0" cy="0"/>
+        </a:xfrm>
+      </p:grpSpPr>
+      <p:sp>
+        <p:nvSpPr>
+          <p:cNvPr id="3" name="Notes Placeholder 2"/>
+          <p:cNvSpPr>
+            <a:spLocks noGrp="1"/>
+          </p:cNvSpPr>
+          <p:nvPr>
+            <p:ph type="body" idx="1"/>
+          </p:nvPr>
+        </p:nvSpPr>
+        <p:spPr/>
+        <p:txBody>
+          <a:bodyPr/>
+          <a:lstStyle/>
+          <a:p>
+            <a:r>
+              <a:t>Lê Hoàng Lộc  ·  khoảng 10 giây</a:t>
+            </a:r>
+          </a:p>
+          <a:p/>
+          <a:p>
+            <a:r>
+              <a:t>Bài trình bày của em gồm năm phần: bài toán, dữ liệu, phương pháp, kết quả, và cuối cùng là kết luận kèm demo.</a:t>
             </a:r>
           </a:p>
         </p:txBody>
@@ -5054,6 +5107,442 @@
 
 <file path=ppt/slides/slide10.xml><?xml version="1.0" encoding="utf-8"?>
 <p:sld xmlns:a="http://schemas.openxmlformats.org/drawingml/2006/main" xmlns:r="http://schemas.openxmlformats.org/officeDocument/2006/relationships" xmlns:p="http://schemas.openxmlformats.org/presentationml/2006/main">
+  <p:cSld name="Slide 9">
+    <p:bg>
+      <p:bgPr>
+        <a:solidFill>
+          <a:srgbClr val="FFFFFF"/>
+        </a:solidFill>
+        <a:effectLst/>
+      </p:bgPr>
+    </p:bg>
+    <p:spTree>
+      <p:nvGrpSpPr>
+        <p:cNvPr id="1" name=""/>
+        <p:cNvGrpSpPr/>
+        <p:nvPr/>
+      </p:nvGrpSpPr>
+      <p:grpSpPr>
+        <a:xfrm>
+          <a:off x="0" y="0"/>
+          <a:ext cx="0" cy="0"/>
+          <a:chOff x="0" y="0"/>
+          <a:chExt cx="0" cy="0"/>
+        </a:xfrm>
+      </p:grpSpPr>
+      <p:sp>
+        <p:nvSpPr>
+          <p:cNvPr id="2" name="Text 0"/>
+          <p:cNvSpPr txBox="1"/>
+          <p:nvPr/>
+        </p:nvSpPr>
+        <p:spPr>
+          <a:xfrm>
+            <a:off x="5193792" y="146304"/>
+            <a:ext cx="6400800" cy="292608"/>
+          </a:xfrm>
+          <a:prstGeom prst="rect">
+            <a:avLst/>
+          </a:prstGeom>
+          <a:noFill/>
+          <a:ln/>
+        </p:spPr>
+        <p:txBody>
+          <a:bodyPr wrap="square" lIns="0" tIns="0" rIns="0" bIns="0" rtlCol="0" anchor="ctr"/>
+          <a:lstStyle/>
+          <a:p>
+            <a:pPr marL="0" indent="0" algn="r">
+              <a:buNone/>
+            </a:pPr>
+            <a:r>
+              <a:rPr sz="1400" b="0">
+                <a:solidFill>
+                  <a:srgbClr val="77858E"/>
+                </a:solidFill>
+                <a:latin typeface="Cambria"/>
+              </a:rPr>
+              <a:t>Phần 3</a:t>
+            </a:r>
+            <a:r>
+              <a:rPr sz="1400" b="0">
+                <a:solidFill>
+                  <a:srgbClr val="77858E"/>
+                </a:solidFill>
+                <a:latin typeface="Cambria"/>
+              </a:rPr>
+              <a:t>   |   </a:t>
+            </a:r>
+            <a:r>
+              <a:rPr sz="1500" b="0">
+                <a:solidFill>
+                  <a:srgbClr val="16222C"/>
+                </a:solidFill>
+                <a:latin typeface="Cambria"/>
+              </a:rPr>
+              <a:t>Phương pháp</a:t>
+            </a:r>
+            <a:endParaRPr lang="en-US" sz="1100" dirty="0"/>
+          </a:p>
+        </p:txBody>
+      </p:sp>
+      <p:sp>
+        <p:nvSpPr>
+          <p:cNvPr id="3" name="Text 1"/>
+          <p:cNvSpPr txBox="1"/>
+          <p:nvPr/>
+        </p:nvSpPr>
+        <p:spPr>
+          <a:xfrm>
+            <a:off x="594360" y="585216"/>
+            <a:ext cx="11002975" cy="868680"/>
+          </a:xfrm>
+          <a:prstGeom prst="rect">
+            <a:avLst/>
+          </a:prstGeom>
+          <a:noFill/>
+          <a:ln/>
+        </p:spPr>
+        <p:txBody>
+          <a:bodyPr wrap="square" lIns="0" tIns="0" rIns="0" bIns="0" rtlCol="0" anchor="t"/>
+          <a:lstStyle/>
+          <a:p>
+            <a:pPr marL="0" indent="0">
+              <a:lnSpc>
+                <a:spcPct val="95000"/>
+              </a:lnSpc>
+              <a:buNone/>
+            </a:pPr>
+            <a:r>
+              <a:rPr lang="en-US" sz="2800" b="1" dirty="0">
+                <a:solidFill>
+                  <a:srgbClr val="16222C"/>
+                </a:solidFill>
+                <a:latin typeface="Cambria" pitchFamily="34" charset="0"/>
+                <a:ea typeface="Cambria" pitchFamily="34" charset="-122"/>
+                <a:cs typeface="Cambria" pitchFamily="34" charset="-120"/>
+              </a:rPr>
+              <a:t>61% điều luật dài hơn giới hạn của mô hình, nên phải chia đoạn</a:t>
+            </a:r>
+            <a:endParaRPr lang="en-US" sz="2800" dirty="0"/>
+          </a:p>
+        </p:txBody>
+      </p:sp>
+      <p:sp>
+        <p:nvSpPr>
+          <p:cNvPr id="4" name="Text 2"/>
+          <p:cNvSpPr txBox="1"/>
+          <p:nvPr/>
+        </p:nvSpPr>
+        <p:spPr>
+          <a:xfrm>
+            <a:off x="594360" y="6473952"/>
+            <a:ext cx="7315200" cy="219456"/>
+          </a:xfrm>
+          <a:prstGeom prst="rect">
+            <a:avLst/>
+          </a:prstGeom>
+          <a:noFill/>
+          <a:ln/>
+        </p:spPr>
+        <p:txBody>
+          <a:bodyPr wrap="square" lIns="0" tIns="0" rIns="0" bIns="0" rtlCol="0" anchor="ctr"/>
+          <a:lstStyle/>
+          <a:p>
+            <a:pPr marL="0" indent="0">
+              <a:buNone/>
+            </a:pPr>
+            <a:r>
+              <a:rPr lang="en-US" sz="1000" dirty="0">
+                <a:solidFill>
+                  <a:srgbClr val="77858E"/>
+                </a:solidFill>
+                <a:latin typeface="Calibri" pitchFamily="34" charset="0"/>
+                <a:ea typeface="Calibri" pitchFamily="34" charset="-122"/>
+                <a:cs typeface="Calibri" pitchFamily="34" charset="-120"/>
+              </a:rPr>
+              <a:t>Nhóm 08  ·  Tìm kiếm điều luật tiếng Việt cho câu hỏi gõ thiếu dấu</a:t>
+            </a:r>
+            <a:endParaRPr lang="en-US" sz="1000" dirty="0"/>
+          </a:p>
+        </p:txBody>
+      </p:sp>
+      <p:sp>
+        <p:nvSpPr>
+          <p:cNvPr id="5" name="Text 3"/>
+          <p:cNvSpPr txBox="1"/>
+          <p:nvPr/>
+        </p:nvSpPr>
+        <p:spPr>
+          <a:xfrm>
+            <a:off x="10225735" y="6473952"/>
+            <a:ext cx="1371600" cy="219456"/>
+          </a:xfrm>
+          <a:prstGeom prst="rect">
+            <a:avLst/>
+          </a:prstGeom>
+          <a:noFill/>
+          <a:ln/>
+        </p:spPr>
+        <p:txBody>
+          <a:bodyPr wrap="square" lIns="0" tIns="0" rIns="0" bIns="0" rtlCol="0" anchor="ctr"/>
+          <a:lstStyle/>
+          <a:p>
+            <a:pPr marL="0" indent="0" algn="r">
+              <a:buNone/>
+            </a:pPr>
+            <a:r>
+              <a:rPr lang="en-US" sz="1000" dirty="0">
+                <a:solidFill>
+                  <a:srgbClr val="77858E"/>
+                </a:solidFill>
+                <a:latin typeface="Consolas" pitchFamily="34" charset="0"/>
+                <a:ea typeface="Consolas" pitchFamily="34" charset="-122"/>
+                <a:cs typeface="Consolas" pitchFamily="34" charset="-120"/>
+              </a:rPr>
+              <a:t>10 / 18</a:t>
+            </a:r>
+            <a:endParaRPr lang="en-US" sz="1000" dirty="0"/>
+          </a:p>
+        </p:txBody>
+      </p:sp>
+      <p:graphicFrame>
+        <p:nvGraphicFramePr>
+          <p:cNvPr id="7" name="Chart 0"/>
+          <p:cNvGraphicFramePr/>
+          <p:nvPr/>
+        </p:nvGraphicFramePr>
+        <p:xfrm>
+          <a:off x="594360" y="1645920"/>
+          <a:ext cx="7498080" cy="4343400"/>
+        </p:xfrm>
+        <a:graphic>
+          <a:graphicData uri="http://schemas.openxmlformats.org/drawingml/2006/chart">
+            <c:chart xmlns:c="http://schemas.openxmlformats.org/drawingml/2006/chart" xmlns:r="http://schemas.openxmlformats.org/officeDocument/2006/relationships" r:id="rId3"/>
+          </a:graphicData>
+        </a:graphic>
+      </p:graphicFrame>
+      <p:sp>
+        <p:nvSpPr>
+          <p:cNvPr id="8" name="Text 4"/>
+          <p:cNvSpPr txBox="1"/>
+          <p:nvPr/>
+        </p:nvSpPr>
+        <p:spPr>
+          <a:xfrm>
+            <a:off x="8503920" y="1828800"/>
+            <a:ext cx="3093415" cy="731520"/>
+          </a:xfrm>
+          <a:prstGeom prst="rect">
+            <a:avLst/>
+          </a:prstGeom>
+          <a:noFill/>
+          <a:ln/>
+        </p:spPr>
+        <p:txBody>
+          <a:bodyPr wrap="square" lIns="0" tIns="0" rIns="0" bIns="0" rtlCol="0" anchor="ctr"/>
+          <a:lstStyle/>
+          <a:p>
+            <a:pPr marL="0" indent="0">
+              <a:buNone/>
+            </a:pPr>
+            <a:r>
+              <a:rPr lang="en-US" sz="4800" b="1" dirty="0">
+                <a:solidFill>
+                  <a:srgbClr val="A8202B"/>
+                </a:solidFill>
+                <a:latin typeface="Cambria" pitchFamily="34" charset="0"/>
+                <a:ea typeface="Cambria" pitchFamily="34" charset="-122"/>
+                <a:cs typeface="Cambria" pitchFamily="34" charset="-120"/>
+              </a:rPr>
+              <a:t>61,1%</a:t>
+            </a:r>
+            <a:endParaRPr lang="en-US" sz="4800" dirty="0"/>
+          </a:p>
+        </p:txBody>
+      </p:sp>
+      <p:sp>
+        <p:nvSpPr>
+          <p:cNvPr id="9" name="Text 5"/>
+          <p:cNvSpPr txBox="1"/>
+          <p:nvPr/>
+        </p:nvSpPr>
+        <p:spPr>
+          <a:xfrm>
+            <a:off x="8503920" y="2615184"/>
+            <a:ext cx="3093415" cy="566928"/>
+          </a:xfrm>
+          <a:prstGeom prst="rect">
+            <a:avLst/>
+          </a:prstGeom>
+          <a:noFill/>
+          <a:ln/>
+        </p:spPr>
+        <p:txBody>
+          <a:bodyPr wrap="square" lIns="0" tIns="0" rIns="0" bIns="0" rtlCol="0" anchor="t"/>
+          <a:lstStyle/>
+          <a:p>
+            <a:pPr marL="0" indent="0">
+              <a:buNone/>
+            </a:pPr>
+            <a:r>
+              <a:rPr lang="en-US" sz="1300" dirty="0">
+                <a:solidFill>
+                  <a:srgbClr val="46545F"/>
+                </a:solidFill>
+                <a:latin typeface="Calibri" pitchFamily="34" charset="0"/>
+                <a:ea typeface="Calibri" pitchFamily="34" charset="-122"/>
+                <a:cs typeface="Calibri" pitchFamily="34" charset="-120"/>
+              </a:rPr>
+              <a:t>điều luật dài hơn 256 token (khoảng 140 từ)</a:t>
+            </a:r>
+            <a:endParaRPr lang="en-US" sz="1300" dirty="0"/>
+          </a:p>
+        </p:txBody>
+      </p:sp>
+      <p:sp>
+        <p:nvSpPr>
+          <p:cNvPr id="10" name="Text 6"/>
+          <p:cNvSpPr txBox="1"/>
+          <p:nvPr/>
+        </p:nvSpPr>
+        <p:spPr>
+          <a:xfrm>
+            <a:off x="8503920" y="3429000"/>
+            <a:ext cx="3093415" cy="1234440"/>
+          </a:xfrm>
+          <a:prstGeom prst="rect">
+            <a:avLst/>
+          </a:prstGeom>
+          <a:noFill/>
+          <a:ln/>
+        </p:spPr>
+        <p:txBody>
+          <a:bodyPr wrap="square" lIns="0" tIns="0" rIns="0" bIns="0" rtlCol="0" anchor="t"/>
+          <a:lstStyle/>
+          <a:p>
+            <a:pPr marL="0" indent="0">
+              <a:buNone/>
+            </a:pPr>
+            <a:r>
+              <a:rPr lang="en-US" sz="2400" b="1" dirty="0">
+                <a:solidFill>
+                  <a:srgbClr val="16222C"/>
+                </a:solidFill>
+                <a:latin typeface="Cambria" pitchFamily="34" charset="0"/>
+                <a:ea typeface="Cambria" pitchFamily="34" charset="-122"/>
+                <a:cs typeface="Cambria" pitchFamily="34" charset="-120"/>
+              </a:rPr>
+              <a:t>61.425</a:t>
+            </a:r>
+            <a:r>
+              <a:rPr lang="en-US" sz="2400" dirty="0">
+                <a:solidFill>
+                  <a:srgbClr val="16222C"/>
+                </a:solidFill>
+                <a:latin typeface="Cambria" pitchFamily="34" charset="0"/>
+                <a:ea typeface="Cambria" pitchFamily="34" charset="-122"/>
+                <a:cs typeface="Cambria" pitchFamily="34" charset="-120"/>
+              </a:rPr>
+              <a:t> điều</a:t>
+            </a:r>
+            <a:endParaRPr lang="en-US" sz="2400" dirty="0"/>
+          </a:p>
+          <a:p>
+            <a:pPr marL="0" indent="0">
+              <a:buNone/>
+            </a:pPr>
+            <a:r>
+              <a:rPr lang="en-US" sz="2400" dirty="0">
+                <a:solidFill>
+                  <a:srgbClr val="77858E"/>
+                </a:solidFill>
+                <a:latin typeface="Cambria" pitchFamily="34" charset="0"/>
+                <a:ea typeface="Cambria" pitchFamily="34" charset="-122"/>
+                <a:cs typeface="Cambria" pitchFamily="34" charset="-120"/>
+              </a:rPr>
+              <a:t>↓</a:t>
+            </a:r>
+            <a:endParaRPr lang="en-US" sz="2400" dirty="0"/>
+          </a:p>
+          <a:p>
+            <a:pPr marL="0" indent="0">
+              <a:buNone/>
+            </a:pPr>
+            <a:r>
+              <a:rPr lang="en-US" sz="2400" b="1" dirty="0">
+                <a:solidFill>
+                  <a:srgbClr val="16222C"/>
+                </a:solidFill>
+                <a:latin typeface="Cambria" pitchFamily="34" charset="0"/>
+                <a:ea typeface="Cambria" pitchFamily="34" charset="-122"/>
+                <a:cs typeface="Cambria" pitchFamily="34" charset="-120"/>
+              </a:rPr>
+              <a:t>154.176</a:t>
+            </a:r>
+            <a:r>
+              <a:rPr lang="en-US" sz="2400" dirty="0">
+                <a:solidFill>
+                  <a:srgbClr val="16222C"/>
+                </a:solidFill>
+                <a:latin typeface="Cambria" pitchFamily="34" charset="0"/>
+                <a:ea typeface="Cambria" pitchFamily="34" charset="-122"/>
+                <a:cs typeface="Cambria" pitchFamily="34" charset="-120"/>
+              </a:rPr>
+              <a:t> đoạn</a:t>
+            </a:r>
+            <a:endParaRPr lang="en-US" sz="2400" dirty="0"/>
+          </a:p>
+        </p:txBody>
+      </p:sp>
+      <p:sp>
+        <p:nvSpPr>
+          <p:cNvPr id="11" name="Text 7"/>
+          <p:cNvSpPr txBox="1"/>
+          <p:nvPr/>
+        </p:nvSpPr>
+        <p:spPr>
+          <a:xfrm>
+            <a:off x="8503920" y="4754880"/>
+            <a:ext cx="3093415" cy="822960"/>
+          </a:xfrm>
+          <a:prstGeom prst="rect">
+            <a:avLst/>
+          </a:prstGeom>
+          <a:noFill/>
+          <a:ln/>
+        </p:spPr>
+        <p:txBody>
+          <a:bodyPr wrap="square" lIns="0" tIns="0" rIns="0" bIns="0" rtlCol="0" anchor="t"/>
+          <a:lstStyle/>
+          <a:p>
+            <a:pPr marL="0" indent="0">
+              <a:buNone/>
+            </a:pPr>
+            <a:r>
+              <a:rPr lang="en-US" sz="1300" dirty="0" err="1">
+                <a:solidFill>
+                  <a:srgbClr val="46545F"/>
+                </a:solidFill>
+                <a:latin typeface="Calibri" pitchFamily="34" charset="0"/>
+                <a:ea typeface="Calibri" pitchFamily="34" charset="-122"/>
+                <a:cs typeface="Calibri" pitchFamily="34" charset="-120"/>
+              </a:rPr>
+              <a:t>Cắt theo từng khoản, khoản quá dài thì chia nhỏ tiếp. Đoạn nào cũng kèm tên điều.</a:t>
+            </a:r>
+            <a:endParaRPr lang="en-US" sz="1300" dirty="0"/>
+          </a:p>
+        </p:txBody>
+      </p:sp>
+    </p:spTree>
+  </p:cSld>
+  <p:clrMapOvr>
+    <a:masterClrMapping/>
+  </p:clrMapOvr>
+</p:sld>
+</file>
+
+<file path=ppt/slides/slide11.xml><?xml version="1.0" encoding="utf-8"?>
+<p:sld xmlns:a="http://schemas.openxmlformats.org/drawingml/2006/main" xmlns:r="http://schemas.openxmlformats.org/officeDocument/2006/relationships" xmlns:p="http://schemas.openxmlformats.org/presentationml/2006/main">
   <p:cSld name="Slide 10">
     <p:bg>
       <p:bgPr>
@@ -5085,8 +5574,8 @@
         </p:nvSpPr>
         <p:spPr>
           <a:xfrm>
-            <a:off x="594360" y="329184"/>
-            <a:ext cx="5486400" cy="237744"/>
+            <a:off x="5193792" y="146304"/>
+            <a:ext cx="6400800" cy="292608"/>
           </a:xfrm>
           <a:prstGeom prst="rect">
             <a:avLst/>
@@ -5098,19 +5587,35 @@
           <a:bodyPr wrap="square" lIns="0" tIns="0" rIns="0" bIns="0" rtlCol="0" anchor="ctr"/>
           <a:lstStyle/>
           <a:p>
-            <a:pPr marL="0" indent="0">
-              <a:buNone/>
-            </a:pPr>
-            <a:r>
-              <a:rPr lang="en-US" sz="1100" kern="0" spc="100" dirty="0">
-                <a:solidFill>
-                  <a:srgbClr val="2C5F8A"/>
-                </a:solidFill>
-                <a:latin typeface="Consolas" pitchFamily="34" charset="0"/>
-                <a:ea typeface="Consolas" pitchFamily="34" charset="-122"/>
-                <a:cs typeface="Consolas" pitchFamily="34" charset="-120"/>
-              </a:rPr>
-              <a:t>CH1  ·  CÂU CÓ DẤU  ·  10</a:t>
+            <a:pPr marL="0" indent="0" algn="r">
+              <a:buNone/>
+            </a:pPr>
+            <a:r>
+              <a:rPr sz="1400" b="0">
+                <a:solidFill>
+                  <a:srgbClr val="77858E"/>
+                </a:solidFill>
+                <a:latin typeface="Cambria"/>
+              </a:rPr>
+              <a:t>Phần 4</a:t>
+            </a:r>
+            <a:r>
+              <a:rPr sz="1400" b="0">
+                <a:solidFill>
+                  <a:srgbClr val="77858E"/>
+                </a:solidFill>
+                <a:latin typeface="Cambria"/>
+              </a:rPr>
+              <a:t>   |   </a:t>
+            </a:r>
+            <a:r>
+              <a:rPr sz="1500" b="0">
+                <a:solidFill>
+                  <a:srgbClr val="16222C"/>
+                </a:solidFill>
+                <a:latin typeface="Cambria"/>
+              </a:rPr>
+              <a:t>Câu có dấu</a:t>
             </a:r>
             <a:endParaRPr lang="en-US" sz="1100" dirty="0"/>
           </a:p>
@@ -5230,7 +5735,7 @@
                 <a:ea typeface="Consolas" pitchFamily="34" charset="-122"/>
                 <a:cs typeface="Consolas" pitchFamily="34" charset="-120"/>
               </a:rPr>
-              <a:t>10 / 17</a:t>
+              <a:t>11 / 18</a:t>
             </a:r>
             <a:endParaRPr lang="en-US" sz="1000" dirty="0"/>
           </a:p>
@@ -5455,7 +5960,7 @@
 </p:sld>
 </file>
 
-<file path=ppt/slides/slide11.xml><?xml version="1.0" encoding="utf-8"?>
+<file path=ppt/slides/slide12.xml><?xml version="1.0" encoding="utf-8"?>
 <p:sld xmlns:a="http://schemas.openxmlformats.org/drawingml/2006/main" xmlns:r="http://schemas.openxmlformats.org/officeDocument/2006/relationships" xmlns:p="http://schemas.openxmlformats.org/presentationml/2006/main">
   <p:cSld name="Slide 11">
     <p:bg>
@@ -5488,8 +5993,8 @@
         </p:nvSpPr>
         <p:spPr>
           <a:xfrm>
-            <a:off x="594360" y="329184"/>
-            <a:ext cx="5486400" cy="237744"/>
+            <a:off x="5193792" y="146304"/>
+            <a:ext cx="6400800" cy="292608"/>
           </a:xfrm>
           <a:prstGeom prst="rect">
             <a:avLst/>
@@ -5501,19 +6006,35 @@
           <a:bodyPr wrap="square" lIns="0" tIns="0" rIns="0" bIns="0" rtlCol="0" anchor="ctr"/>
           <a:lstStyle/>
           <a:p>
-            <a:pPr marL="0" indent="0">
-              <a:buNone/>
-            </a:pPr>
-            <a:r>
-              <a:rPr lang="en-US" sz="1100" kern="0" spc="100" dirty="0">
-                <a:solidFill>
-                  <a:srgbClr val="2C5F8A"/>
-                </a:solidFill>
-                <a:latin typeface="Consolas" pitchFamily="34" charset="0"/>
-                <a:ea typeface="Consolas" pitchFamily="34" charset="-122"/>
-                <a:cs typeface="Consolas" pitchFamily="34" charset="-120"/>
-              </a:rPr>
-              <a:t>CH1  ·  CÂU CÓ DẤU  ·  11</a:t>
+            <a:pPr marL="0" indent="0" algn="r">
+              <a:buNone/>
+            </a:pPr>
+            <a:r>
+              <a:rPr sz="1400" b="0">
+                <a:solidFill>
+                  <a:srgbClr val="77858E"/>
+                </a:solidFill>
+                <a:latin typeface="Cambria"/>
+              </a:rPr>
+              <a:t>Phần 4</a:t>
+            </a:r>
+            <a:r>
+              <a:rPr sz="1400" b="0">
+                <a:solidFill>
+                  <a:srgbClr val="77858E"/>
+                </a:solidFill>
+                <a:latin typeface="Cambria"/>
+              </a:rPr>
+              <a:t>   |   </a:t>
+            </a:r>
+            <a:r>
+              <a:rPr sz="1500" b="0">
+                <a:solidFill>
+                  <a:srgbClr val="16222C"/>
+                </a:solidFill>
+                <a:latin typeface="Cambria"/>
+              </a:rPr>
+              <a:t>Câu có dấu</a:t>
             </a:r>
             <a:endParaRPr lang="en-US" sz="1100" dirty="0"/>
           </a:p>
@@ -5633,7 +6154,7 @@
                 <a:ea typeface="Consolas" pitchFamily="34" charset="-122"/>
                 <a:cs typeface="Consolas" pitchFamily="34" charset="-120"/>
               </a:rPr>
-              <a:t>11 / 17</a:t>
+              <a:t>12 / 18</a:t>
             </a:r>
             <a:endParaRPr lang="en-US" sz="1000" dirty="0"/>
           </a:p>
@@ -6378,7 +6899,7 @@
 </p:sld>
 </file>
 
-<file path=ppt/slides/slide12.xml><?xml version="1.0" encoding="utf-8"?>
+<file path=ppt/slides/slide13.xml><?xml version="1.0" encoding="utf-8"?>
 <p:sld xmlns:a="http://schemas.openxmlformats.org/drawingml/2006/main" xmlns:r="http://schemas.openxmlformats.org/officeDocument/2006/relationships" xmlns:p="http://schemas.openxmlformats.org/presentationml/2006/main">
   <p:cSld name="Slide 12">
     <p:bg>
@@ -6411,8 +6932,8 @@
         </p:nvSpPr>
         <p:spPr>
           <a:xfrm>
-            <a:off x="594360" y="329184"/>
-            <a:ext cx="5486400" cy="237744"/>
+            <a:off x="5193792" y="146304"/>
+            <a:ext cx="6400800" cy="292608"/>
           </a:xfrm>
           <a:prstGeom prst="rect">
             <a:avLst/>
@@ -6424,19 +6945,35 @@
           <a:bodyPr wrap="square" lIns="0" tIns="0" rIns="0" bIns="0" rtlCol="0" anchor="ctr"/>
           <a:lstStyle/>
           <a:p>
-            <a:pPr marL="0" indent="0">
-              <a:buNone/>
-            </a:pPr>
-            <a:r>
-              <a:rPr lang="en-US" sz="1100" kern="0" spc="100" dirty="0">
-                <a:solidFill>
-                  <a:srgbClr val="2C5F8A"/>
-                </a:solidFill>
-                <a:latin typeface="Consolas" pitchFamily="34" charset="0"/>
-                <a:ea typeface="Consolas" pitchFamily="34" charset="-122"/>
-                <a:cs typeface="Consolas" pitchFamily="34" charset="-120"/>
-              </a:rPr>
-              <a:t>CH2  ·  CÂU MẤT DẤU  ·  12</a:t>
+            <a:pPr marL="0" indent="0" algn="r">
+              <a:buNone/>
+            </a:pPr>
+            <a:r>
+              <a:rPr sz="1400" b="0">
+                <a:solidFill>
+                  <a:srgbClr val="77858E"/>
+                </a:solidFill>
+                <a:latin typeface="Cambria"/>
+              </a:rPr>
+              <a:t>Phần 4</a:t>
+            </a:r>
+            <a:r>
+              <a:rPr sz="1400" b="0">
+                <a:solidFill>
+                  <a:srgbClr val="77858E"/>
+                </a:solidFill>
+                <a:latin typeface="Cambria"/>
+              </a:rPr>
+              <a:t>   |   </a:t>
+            </a:r>
+            <a:r>
+              <a:rPr sz="1500" b="0">
+                <a:solidFill>
+                  <a:srgbClr val="16222C"/>
+                </a:solidFill>
+                <a:latin typeface="Cambria"/>
+              </a:rPr>
+              <a:t>Câu mất dấu</a:t>
             </a:r>
             <a:endParaRPr lang="en-US" sz="1100" dirty="0"/>
           </a:p>
@@ -6556,7 +7093,7 @@
                 <a:ea typeface="Consolas" pitchFamily="34" charset="-122"/>
                 <a:cs typeface="Consolas" pitchFamily="34" charset="-120"/>
               </a:rPr>
-              <a:t>12 / 17</a:t>
+              <a:t>13 / 18</a:t>
             </a:r>
             <a:endParaRPr lang="en-US" sz="1000" dirty="0"/>
           </a:p>
@@ -6786,7 +7323,7 @@
 </p:sld>
 </file>
 
-<file path=ppt/slides/slide13.xml><?xml version="1.0" encoding="utf-8"?>
+<file path=ppt/slides/slide14.xml><?xml version="1.0" encoding="utf-8"?>
 <p:sld xmlns:a="http://schemas.openxmlformats.org/drawingml/2006/main" xmlns:r="http://schemas.openxmlformats.org/officeDocument/2006/relationships" xmlns:p="http://schemas.openxmlformats.org/presentationml/2006/main">
   <p:cSld name="Slide 13">
     <p:bg>
@@ -6819,8 +7356,8 @@
         </p:nvSpPr>
         <p:spPr>
           <a:xfrm>
-            <a:off x="594360" y="329184"/>
-            <a:ext cx="5486400" cy="237744"/>
+            <a:off x="5193792" y="146304"/>
+            <a:ext cx="6400800" cy="292608"/>
           </a:xfrm>
           <a:prstGeom prst="rect">
             <a:avLst/>
@@ -6832,19 +7369,35 @@
           <a:bodyPr wrap="square" lIns="0" tIns="0" rIns="0" bIns="0" rtlCol="0" anchor="ctr"/>
           <a:lstStyle/>
           <a:p>
-            <a:pPr marL="0" indent="0">
-              <a:buNone/>
-            </a:pPr>
-            <a:r>
-              <a:rPr lang="en-US" sz="1100" kern="0" spc="100" dirty="0">
-                <a:solidFill>
-                  <a:srgbClr val="2C5F8A"/>
-                </a:solidFill>
-                <a:latin typeface="Consolas" pitchFamily="34" charset="0"/>
-                <a:ea typeface="Consolas" pitchFamily="34" charset="-122"/>
-                <a:cs typeface="Consolas" pitchFamily="34" charset="-120"/>
-              </a:rPr>
-              <a:t>CH2  ·  CÂU MẤT DẤU  ·  13</a:t>
+            <a:pPr marL="0" indent="0" algn="r">
+              <a:buNone/>
+            </a:pPr>
+            <a:r>
+              <a:rPr sz="1400" b="0">
+                <a:solidFill>
+                  <a:srgbClr val="77858E"/>
+                </a:solidFill>
+                <a:latin typeface="Cambria"/>
+              </a:rPr>
+              <a:t>Phần 4</a:t>
+            </a:r>
+            <a:r>
+              <a:rPr sz="1400" b="0">
+                <a:solidFill>
+                  <a:srgbClr val="77858E"/>
+                </a:solidFill>
+                <a:latin typeface="Cambria"/>
+              </a:rPr>
+              <a:t>   |   </a:t>
+            </a:r>
+            <a:r>
+              <a:rPr sz="1500" b="0">
+                <a:solidFill>
+                  <a:srgbClr val="16222C"/>
+                </a:solidFill>
+                <a:latin typeface="Cambria"/>
+              </a:rPr>
+              <a:t>Câu mất dấu</a:t>
             </a:r>
             <a:endParaRPr lang="en-US" sz="1100" dirty="0"/>
           </a:p>
@@ -6964,7 +7517,7 @@
                 <a:ea typeface="Consolas" pitchFamily="34" charset="-122"/>
                 <a:cs typeface="Consolas" pitchFamily="34" charset="-120"/>
               </a:rPr>
-              <a:t>13 / 17</a:t>
+              <a:t>14 / 18</a:t>
             </a:r>
             <a:endParaRPr lang="en-US" sz="1000" dirty="0"/>
           </a:p>
@@ -7547,7 +8100,7 @@
 </p:sld>
 </file>
 
-<file path=ppt/slides/slide14.xml><?xml version="1.0" encoding="utf-8"?>
+<file path=ppt/slides/slide15.xml><?xml version="1.0" encoding="utf-8"?>
 <p:sld xmlns:a="http://schemas.openxmlformats.org/drawingml/2006/main" xmlns:r="http://schemas.openxmlformats.org/officeDocument/2006/relationships" xmlns:p="http://schemas.openxmlformats.org/presentationml/2006/main">
   <p:cSld name="Slide 14">
     <p:bg>
@@ -7580,8 +8133,8 @@
         </p:nvSpPr>
         <p:spPr>
           <a:xfrm>
-            <a:off x="594360" y="329184"/>
-            <a:ext cx="5486400" cy="237744"/>
+            <a:off x="5193792" y="146304"/>
+            <a:ext cx="6400800" cy="292608"/>
           </a:xfrm>
           <a:prstGeom prst="rect">
             <a:avLst/>
@@ -7593,19 +8146,35 @@
           <a:bodyPr wrap="square" lIns="0" tIns="0" rIns="0" bIns="0" rtlCol="0" anchor="ctr"/>
           <a:lstStyle/>
           <a:p>
-            <a:pPr marL="0" indent="0">
-              <a:buNone/>
-            </a:pPr>
-            <a:r>
-              <a:rPr lang="en-US" sz="1100" kern="0" spc="100" dirty="0">
-                <a:solidFill>
-                  <a:srgbClr val="2C5F8A"/>
-                </a:solidFill>
-                <a:latin typeface="Consolas" pitchFamily="34" charset="0"/>
-                <a:ea typeface="Consolas" pitchFamily="34" charset="-122"/>
-                <a:cs typeface="Consolas" pitchFamily="34" charset="-120"/>
-              </a:rPr>
-              <a:t>CH2  ·  CÂU MẤT DẤU  ·  14</a:t>
+            <a:pPr marL="0" indent="0" algn="r">
+              <a:buNone/>
+            </a:pPr>
+            <a:r>
+              <a:rPr sz="1400" b="0">
+                <a:solidFill>
+                  <a:srgbClr val="77858E"/>
+                </a:solidFill>
+                <a:latin typeface="Cambria"/>
+              </a:rPr>
+              <a:t>Phần 4</a:t>
+            </a:r>
+            <a:r>
+              <a:rPr sz="1400" b="0">
+                <a:solidFill>
+                  <a:srgbClr val="77858E"/>
+                </a:solidFill>
+                <a:latin typeface="Cambria"/>
+              </a:rPr>
+              <a:t>   |   </a:t>
+            </a:r>
+            <a:r>
+              <a:rPr sz="1500" b="0">
+                <a:solidFill>
+                  <a:srgbClr val="16222C"/>
+                </a:solidFill>
+                <a:latin typeface="Cambria"/>
+              </a:rPr>
+              <a:t>Câu mất dấu</a:t>
             </a:r>
             <a:endParaRPr lang="en-US" sz="1100" dirty="0"/>
           </a:p>
@@ -7725,7 +8294,7 @@
                 <a:ea typeface="Consolas" pitchFamily="34" charset="-122"/>
                 <a:cs typeface="Consolas" pitchFamily="34" charset="-120"/>
               </a:rPr>
-              <a:t>14 / 17</a:t>
+              <a:t>15 / 18</a:t>
             </a:r>
             <a:endParaRPr lang="en-US" sz="1000" dirty="0"/>
           </a:p>
@@ -8262,7 +8831,7 @@
 </p:sld>
 </file>
 
-<file path=ppt/slides/slide15.xml><?xml version="1.0" encoding="utf-8"?>
+<file path=ppt/slides/slide16.xml><?xml version="1.0" encoding="utf-8"?>
 <p:sld xmlns:a="http://schemas.openxmlformats.org/drawingml/2006/main" xmlns:r="http://schemas.openxmlformats.org/officeDocument/2006/relationships" xmlns:p="http://schemas.openxmlformats.org/presentationml/2006/main">
   <p:cSld name="Slide 15">
     <p:bg>
@@ -8295,8 +8864,8 @@
         </p:nvSpPr>
         <p:spPr>
           <a:xfrm>
-            <a:off x="594360" y="329184"/>
-            <a:ext cx="5486400" cy="237744"/>
+            <a:off x="5193792" y="146304"/>
+            <a:ext cx="6400800" cy="292608"/>
           </a:xfrm>
           <a:prstGeom prst="rect">
             <a:avLst/>
@@ -8308,34 +8877,206 @@
           <a:bodyPr wrap="square" lIns="0" tIns="0" rIns="0" bIns="0" rtlCol="0" anchor="ctr"/>
           <a:lstStyle/>
           <a:p>
+            <a:pPr marL="0" indent="0" algn="r">
+              <a:buNone/>
+            </a:pPr>
+            <a:r>
+              <a:rPr sz="1400" b="0">
+                <a:solidFill>
+                  <a:srgbClr val="9AA8B2"/>
+                </a:solidFill>
+                <a:latin typeface="Cambria"/>
+              </a:rPr>
+              <a:t>Phần 5</a:t>
+            </a:r>
+            <a:r>
+              <a:rPr sz="1400" b="0">
+                <a:solidFill>
+                  <a:srgbClr val="9AA8B2"/>
+                </a:solidFill>
+                <a:latin typeface="Cambria"/>
+              </a:rPr>
+              <a:t>   |   </a:t>
+            </a:r>
+            <a:r>
+              <a:rPr sz="1500" b="0">
+                <a:solidFill>
+                  <a:srgbClr val="FFFFFF"/>
+                </a:solidFill>
+                <a:latin typeface="Cambria"/>
+              </a:rPr>
+              <a:t>Kết luận</a:t>
+            </a:r>
+            <a:endParaRPr lang="en-US" sz="1100" dirty="0"/>
+          </a:p>
+        </p:txBody>
+      </p:sp>
+      <p:sp>
+        <p:nvSpPr>
+          <p:cNvPr id="3" name="Text 1"/>
+          <p:cNvSpPr txBox="1"/>
+          <p:nvPr/>
+        </p:nvSpPr>
+        <p:spPr>
+          <a:xfrm>
+            <a:off x="594360" y="585216"/>
+            <a:ext cx="11002975" cy="731520"/>
+          </a:xfrm>
+          <a:prstGeom prst="rect">
+            <a:avLst/>
+          </a:prstGeom>
+          <a:noFill/>
+          <a:ln/>
+        </p:spPr>
+        <p:txBody>
+          <a:bodyPr wrap="square" lIns="0" tIns="0" rIns="0" bIns="0" rtlCol="0" anchor="ctr"/>
+          <a:lstStyle/>
+          <a:p>
             <a:pPr marL="0" indent="0">
               <a:buNone/>
             </a:pPr>
             <a:r>
-              <a:rPr lang="en-US" sz="1100" kern="0" spc="100" dirty="0">
+              <a:rPr lang="en-US" sz="3200" b="1" dirty="0">
+                <a:solidFill>
+                  <a:srgbClr val="FFFFFF"/>
+                </a:solidFill>
+                <a:latin typeface="Cambria" pitchFamily="34" charset="0"/>
+                <a:ea typeface="Cambria" pitchFamily="34" charset="-122"/>
+                <a:cs typeface="Cambria" pitchFamily="34" charset="-120"/>
+              </a:rPr>
+              <a:t>Ba điều nhóm rút ra</a:t>
+            </a:r>
+            <a:endParaRPr lang="en-US" sz="3200" dirty="0"/>
+          </a:p>
+        </p:txBody>
+      </p:sp>
+      <p:sp>
+        <p:nvSpPr>
+          <p:cNvPr id="4" name="Text 2"/>
+          <p:cNvSpPr txBox="1"/>
+          <p:nvPr/>
+        </p:nvSpPr>
+        <p:spPr>
+          <a:xfrm>
+            <a:off x="594360" y="1783080"/>
+            <a:ext cx="3423818" cy="914400"/>
+          </a:xfrm>
+          <a:prstGeom prst="rect">
+            <a:avLst/>
+          </a:prstGeom>
+          <a:noFill/>
+          <a:ln/>
+        </p:spPr>
+        <p:txBody>
+          <a:bodyPr wrap="square" lIns="0" tIns="0" rIns="0" bIns="0" rtlCol="0" anchor="ctr"/>
+          <a:lstStyle/>
+          <a:p>
+            <a:pPr marL="0" indent="0">
+              <a:buNone/>
+            </a:pPr>
+            <a:r>
+              <a:rPr lang="en-US" sz="4800" b="1" dirty="0">
                 <a:solidFill>
                   <a:srgbClr val="9FC2DB"/>
+                </a:solidFill>
+                <a:latin typeface="Cambria" pitchFamily="34" charset="0"/>
+                <a:ea typeface="Cambria" pitchFamily="34" charset="-122"/>
+                <a:cs typeface="Cambria" pitchFamily="34" charset="-120"/>
+              </a:rPr>
+              <a:t>+0,51</a:t>
+            </a:r>
+            <a:endParaRPr lang="en-US" sz="4800" dirty="0"/>
+          </a:p>
+        </p:txBody>
+      </p:sp>
+      <p:sp>
+        <p:nvSpPr>
+          <p:cNvPr id="5" name="Text 3"/>
+          <p:cNvSpPr txBox="1"/>
+          <p:nvPr/>
+        </p:nvSpPr>
+        <p:spPr>
+          <a:xfrm>
+            <a:off x="594360" y="2788920"/>
+            <a:ext cx="3423818" cy="274320"/>
+          </a:xfrm>
+          <a:prstGeom prst="rect">
+            <a:avLst/>
+          </a:prstGeom>
+          <a:noFill/>
+          <a:ln/>
+        </p:spPr>
+        <p:txBody>
+          <a:bodyPr wrap="square" lIns="0" tIns="0" rIns="0" bIns="0" rtlCol="0" anchor="ctr"/>
+          <a:lstStyle/>
+          <a:p>
+            <a:pPr marL="0" indent="0">
+              <a:buNone/>
+            </a:pPr>
+            <a:r>
+              <a:rPr lang="en-US" sz="1200" b="1" dirty="0">
+                <a:solidFill>
+                  <a:srgbClr val="C9D6DF"/>
                 </a:solidFill>
                 <a:latin typeface="Consolas" pitchFamily="34" charset="0"/>
                 <a:ea typeface="Consolas" pitchFamily="34" charset="-122"/>
                 <a:cs typeface="Consolas" pitchFamily="34" charset="-120"/>
               </a:rPr>
-              <a:t>KẾT LUẬN  ·  15</a:t>
-            </a:r>
-            <a:endParaRPr lang="en-US" sz="1100" dirty="0"/>
-          </a:p>
-        </p:txBody>
-      </p:sp>
-      <p:sp>
-        <p:nvSpPr>
-          <p:cNvPr id="3" name="Text 1"/>
-          <p:cNvSpPr txBox="1"/>
-          <p:nvPr/>
-        </p:nvSpPr>
-        <p:spPr>
-          <a:xfrm>
-            <a:off x="594360" y="585216"/>
-            <a:ext cx="11002975" cy="731520"/>
+              <a:t>CH1  ·  CÂU CÓ DẤU</a:t>
+            </a:r>
+            <a:endParaRPr lang="en-US" sz="1200" dirty="0"/>
+          </a:p>
+        </p:txBody>
+      </p:sp>
+      <p:sp>
+        <p:nvSpPr>
+          <p:cNvPr id="6" name="Text 4"/>
+          <p:cNvSpPr txBox="1"/>
+          <p:nvPr/>
+        </p:nvSpPr>
+        <p:spPr>
+          <a:xfrm>
+            <a:off x="594360" y="3154680"/>
+            <a:ext cx="3423818" cy="1371600"/>
+          </a:xfrm>
+          <a:prstGeom prst="rect">
+            <a:avLst/>
+          </a:prstGeom>
+          <a:noFill/>
+          <a:ln/>
+        </p:spPr>
+        <p:txBody>
+          <a:bodyPr wrap="square" lIns="0" tIns="0" rIns="0" bIns="0" rtlCol="0" anchor="t"/>
+          <a:lstStyle/>
+          <a:p>
+            <a:pPr marL="0" indent="0">
+              <a:buNone/>
+            </a:pPr>
+            <a:r>
+              <a:rPr lang="en-US" sz="1600" dirty="0">
+                <a:solidFill>
+                  <a:srgbClr val="FFFFFF"/>
+                </a:solidFill>
+                <a:latin typeface="Calibri" pitchFamily="34" charset="0"/>
+                <a:ea typeface="Calibri" pitchFamily="34" charset="-122"/>
+                <a:cs typeface="Calibri" pitchFamily="34" charset="-120"/>
+              </a:rPr>
+              <a:t>Hợp nhất chỉ hơn ngữ nghĩa 4 câu trên 788. BM25 vẫn đáng giữ vì nhanh và giải thích được.</a:t>
+            </a:r>
+            <a:endParaRPr lang="en-US" sz="1600" dirty="0"/>
+          </a:p>
+        </p:txBody>
+      </p:sp>
+      <p:sp>
+        <p:nvSpPr>
+          <p:cNvPr id="7" name="Text 5"/>
+          <p:cNvSpPr txBox="1"/>
+          <p:nvPr/>
+        </p:nvSpPr>
+        <p:spPr>
+          <a:xfrm>
+            <a:off x="4383938" y="1783080"/>
+            <a:ext cx="3423818" cy="914400"/>
           </a:xfrm>
           <a:prstGeom prst="rect">
             <a:avLst/>
@@ -8351,29 +9092,107 @@
               <a:buNone/>
             </a:pPr>
             <a:r>
-              <a:rPr lang="en-US" sz="3200" b="1" dirty="0">
-                <a:solidFill>
-                  <a:srgbClr val="FFFFFF"/>
+              <a:rPr lang="en-US" sz="4800" b="1" dirty="0">
+                <a:solidFill>
+                  <a:srgbClr val="7FD1B0"/>
                 </a:solidFill>
                 <a:latin typeface="Cambria" pitchFamily="34" charset="0"/>
                 <a:ea typeface="Cambria" pitchFamily="34" charset="-122"/>
                 <a:cs typeface="Cambria" pitchFamily="34" charset="-120"/>
               </a:rPr>
-              <a:t>Ba điều nhóm rút ra</a:t>
-            </a:r>
-            <a:endParaRPr lang="en-US" sz="3200" dirty="0"/>
-          </a:p>
-        </p:txBody>
-      </p:sp>
-      <p:sp>
-        <p:nvSpPr>
-          <p:cNvPr id="4" name="Text 2"/>
-          <p:cNvSpPr txBox="1"/>
-          <p:nvPr/>
-        </p:nvSpPr>
-        <p:spPr>
-          <a:xfrm>
-            <a:off x="594360" y="1783080"/>
+              <a:t>14 → 97</a:t>
+            </a:r>
+            <a:endParaRPr lang="en-US" sz="4800" dirty="0"/>
+          </a:p>
+        </p:txBody>
+      </p:sp>
+      <p:sp>
+        <p:nvSpPr>
+          <p:cNvPr id="8" name="Text 6"/>
+          <p:cNvSpPr txBox="1"/>
+          <p:nvPr/>
+        </p:nvSpPr>
+        <p:spPr>
+          <a:xfrm>
+            <a:off x="4383938" y="2788920"/>
+            <a:ext cx="3423818" cy="274320"/>
+          </a:xfrm>
+          <a:prstGeom prst="rect">
+            <a:avLst/>
+          </a:prstGeom>
+          <a:noFill/>
+          <a:ln/>
+        </p:spPr>
+        <p:txBody>
+          <a:bodyPr wrap="square" lIns="0" tIns="0" rIns="0" bIns="0" rtlCol="0" anchor="ctr"/>
+          <a:lstStyle/>
+          <a:p>
+            <a:pPr marL="0" indent="0">
+              <a:buNone/>
+            </a:pPr>
+            <a:r>
+              <a:rPr lang="en-US" sz="1200" b="1" dirty="0">
+                <a:solidFill>
+                  <a:srgbClr val="C9D6DF"/>
+                </a:solidFill>
+                <a:latin typeface="Consolas" pitchFamily="34" charset="0"/>
+                <a:ea typeface="Consolas" pitchFamily="34" charset="-122"/>
+                <a:cs typeface="Consolas" pitchFamily="34" charset="-120"/>
+              </a:rPr>
+              <a:t>CH2  ·  CÂU MẤT DẤU</a:t>
+            </a:r>
+            <a:endParaRPr lang="en-US" sz="1200" dirty="0"/>
+          </a:p>
+        </p:txBody>
+      </p:sp>
+      <p:sp>
+        <p:nvSpPr>
+          <p:cNvPr id="9" name="Text 7"/>
+          <p:cNvSpPr txBox="1"/>
+          <p:nvPr/>
+        </p:nvSpPr>
+        <p:spPr>
+          <a:xfrm>
+            <a:off x="4383938" y="3154680"/>
+            <a:ext cx="3423818" cy="1371600"/>
+          </a:xfrm>
+          <a:prstGeom prst="rect">
+            <a:avLst/>
+          </a:prstGeom>
+          <a:noFill/>
+          <a:ln/>
+        </p:spPr>
+        <p:txBody>
+          <a:bodyPr wrap="square" lIns="0" tIns="0" rIns="0" bIns="0" rtlCol="0" anchor="t"/>
+          <a:lstStyle/>
+          <a:p>
+            <a:pPr marL="0" indent="0">
+              <a:buNone/>
+            </a:pPr>
+            <a:r>
+              <a:rPr lang="en-US" sz="1600" dirty="0">
+                <a:solidFill>
+                  <a:srgbClr val="FFFFFF"/>
+                </a:solidFill>
+                <a:latin typeface="Calibri" pitchFamily="34" charset="0"/>
+                <a:ea typeface="Calibri" pitchFamily="34" charset="-122"/>
+                <a:cs typeface="Calibri" pitchFamily="34" charset="-120"/>
+              </a:rPr>
+              <a:t>Mất dấu thì hệ sụp. Bigram học từ chính kho luật kéo lại gần hết, 0,88 ms mỗi câu.</a:t>
+            </a:r>
+            <a:endParaRPr lang="en-US" sz="1600" dirty="0"/>
+          </a:p>
+        </p:txBody>
+      </p:sp>
+      <p:sp>
+        <p:nvSpPr>
+          <p:cNvPr id="10" name="Text 8"/>
+          <p:cNvSpPr txBox="1"/>
+          <p:nvPr/>
+        </p:nvSpPr>
+        <p:spPr>
+          <a:xfrm>
+            <a:off x="8173517" y="1783080"/>
             <a:ext cx="3423818" cy="914400"/>
           </a:xfrm>
           <a:prstGeom prst="rect">
@@ -8392,13 +9211,13 @@
             <a:r>
               <a:rPr lang="en-US" sz="4800" b="1" dirty="0">
                 <a:solidFill>
-                  <a:srgbClr val="9FC2DB"/>
+                  <a:srgbClr val="F0A0A6"/>
                 </a:solidFill>
                 <a:latin typeface="Cambria" pitchFamily="34" charset="0"/>
                 <a:ea typeface="Cambria" pitchFamily="34" charset="-122"/>
                 <a:cs typeface="Cambria" pitchFamily="34" charset="-120"/>
               </a:rPr>
-              <a:t>+0,51</a:t>
+              <a:t>80%</a:t>
             </a:r>
             <a:endParaRPr lang="en-US" sz="4800" dirty="0"/>
           </a:p>
@@ -8406,13 +9225,13 @@
       </p:sp>
       <p:sp>
         <p:nvSpPr>
-          <p:cNvPr id="5" name="Text 3"/>
-          <p:cNvSpPr txBox="1"/>
-          <p:nvPr/>
-        </p:nvSpPr>
-        <p:spPr>
-          <a:xfrm>
-            <a:off x="594360" y="2788920"/>
+          <p:cNvPr id="11" name="Text 9"/>
+          <p:cNvSpPr txBox="1"/>
+          <p:nvPr/>
+        </p:nvSpPr>
+        <p:spPr>
+          <a:xfrm>
+            <a:off x="8173517" y="2788920"/>
             <a:ext cx="3423818" cy="274320"/>
           </a:xfrm>
           <a:prstGeom prst="rect">
@@ -8437,7 +9256,7 @@
                 <a:ea typeface="Consolas" pitchFamily="34" charset="-122"/>
                 <a:cs typeface="Consolas" pitchFamily="34" charset="-120"/>
               </a:rPr>
-              <a:t>CH1  ·  CÂU CÓ DẤU</a:t>
+              <a:t>RÒ RỈ DỮ LIỆU</a:t>
             </a:r>
             <a:endParaRPr lang="en-US" sz="1200" dirty="0"/>
           </a:p>
@@ -8445,13 +9264,13 @@
       </p:sp>
       <p:sp>
         <p:nvSpPr>
-          <p:cNvPr id="6" name="Text 4"/>
-          <p:cNvSpPr txBox="1"/>
-          <p:nvPr/>
-        </p:nvSpPr>
-        <p:spPr>
-          <a:xfrm>
-            <a:off x="594360" y="3154680"/>
+          <p:cNvPr id="12" name="Text 10"/>
+          <p:cNvSpPr txBox="1"/>
+          <p:nvPr/>
+        </p:nvSpPr>
+        <p:spPr>
+          <a:xfrm>
+            <a:off x="8173517" y="3154680"/>
             <a:ext cx="3423818" cy="1371600"/>
           </a:xfrm>
           <a:prstGeom prst="rect">
@@ -8476,7 +9295,7 @@
                 <a:ea typeface="Calibri" pitchFamily="34" charset="-122"/>
                 <a:cs typeface="Calibri" pitchFamily="34" charset="-120"/>
               </a:rPr>
-              <a:t>Hợp nhất chỉ hơn ngữ nghĩa 4 câu trên 788. BM25 vẫn đáng giữ vì nhanh và giải thích được.</a:t>
+              <a:t>Mô hình phổ biến nhất đã học tập train Zalo. Đọc model card trước khi tin một con số benchmark.</a:t>
             </a:r>
             <a:endParaRPr lang="en-US" sz="1600" dirty="0"/>
           </a:p>
@@ -8484,14 +9303,53 @@
       </p:sp>
       <p:sp>
         <p:nvSpPr>
-          <p:cNvPr id="7" name="Text 5"/>
-          <p:cNvSpPr txBox="1"/>
-          <p:nvPr/>
-        </p:nvSpPr>
-        <p:spPr>
-          <a:xfrm>
-            <a:off x="4383938" y="1783080"/>
-            <a:ext cx="3423818" cy="914400"/>
+          <p:cNvPr id="13" name="Text 11"/>
+          <p:cNvSpPr txBox="1"/>
+          <p:nvPr/>
+        </p:nvSpPr>
+        <p:spPr>
+          <a:xfrm>
+            <a:off x="594360" y="4892040"/>
+            <a:ext cx="11002975" cy="548640"/>
+          </a:xfrm>
+          <a:prstGeom prst="rect">
+            <a:avLst/>
+          </a:prstGeom>
+          <a:noFill/>
+          <a:ln/>
+        </p:spPr>
+        <p:txBody>
+          <a:bodyPr wrap="square" lIns="0" tIns="0" rIns="0" bIns="0" rtlCol="0" anchor="t"/>
+          <a:lstStyle/>
+          <a:p>
+            <a:pPr marL="0" indent="0">
+              <a:buNone/>
+            </a:pPr>
+            <a:r>
+              <a:rPr lang="en-US" sz="1300" dirty="0">
+                <a:solidFill>
+                  <a:srgbClr val="9AA8B2"/>
+                </a:solidFill>
+                <a:latin typeface="Calibri" pitchFamily="34" charset="0"/>
+                <a:ea typeface="Calibri" pitchFamily="34" charset="-122"/>
+                <a:cs typeface="Calibri" pitchFamily="34" charset="-120"/>
+              </a:rPr>
+              <a:t>Giới hạn: câu không dấu và nửa dấu do máy tạo, chưa có câu người thật gõ  ·  nhãn không đầy đủ nên Recall là cận dưới  ·  mỗi cấu hình một seed</a:t>
+            </a:r>
+            <a:endParaRPr lang="en-US" sz="1300" dirty="0"/>
+          </a:p>
+        </p:txBody>
+      </p:sp>
+      <p:sp>
+        <p:nvSpPr>
+          <p:cNvPr id="14" name="Text 12"/>
+          <p:cNvSpPr txBox="1"/>
+          <p:nvPr/>
+        </p:nvSpPr>
+        <p:spPr>
+          <a:xfrm>
+            <a:off x="594360" y="5715000"/>
+            <a:ext cx="11002975" cy="411480"/>
           </a:xfrm>
           <a:prstGeom prst="rect">
             <a:avLst/>
@@ -8503,34 +9361,34 @@
           <a:bodyPr wrap="square" lIns="0" tIns="0" rIns="0" bIns="0" rtlCol="0" anchor="ctr"/>
           <a:lstStyle/>
           <a:p>
-            <a:pPr marL="0" indent="0">
-              <a:buNone/>
-            </a:pPr>
-            <a:r>
-              <a:rPr lang="en-US" sz="4800" b="1" dirty="0">
-                <a:solidFill>
-                  <a:srgbClr val="7FD1B0"/>
-                </a:solidFill>
-                <a:latin typeface="Cambria" pitchFamily="34" charset="0"/>
-                <a:ea typeface="Cambria" pitchFamily="34" charset="-122"/>
-                <a:cs typeface="Cambria" pitchFamily="34" charset="-120"/>
-              </a:rPr>
-              <a:t>14 → 97</a:t>
-            </a:r>
-            <a:endParaRPr lang="en-US" sz="4800" dirty="0"/>
-          </a:p>
-        </p:txBody>
-      </p:sp>
-      <p:sp>
-        <p:nvSpPr>
-          <p:cNvPr id="8" name="Text 6"/>
-          <p:cNvSpPr txBox="1"/>
-          <p:nvPr/>
-        </p:nvSpPr>
-        <p:spPr>
-          <a:xfrm>
-            <a:off x="4383938" y="2788920"/>
-            <a:ext cx="3423818" cy="274320"/>
+            <a:pPr marL="0" indent="0" algn="r">
+              <a:buNone/>
+            </a:pPr>
+            <a:r>
+              <a:rPr lang="en-US" sz="1800" b="1" dirty="0">
+                <a:solidFill>
+                  <a:srgbClr val="FFFFFF"/>
+                </a:solidFill>
+                <a:latin typeface="Calibri" pitchFamily="34" charset="0"/>
+                <a:ea typeface="Calibri" pitchFamily="34" charset="-122"/>
+                <a:cs typeface="Calibri" pitchFamily="34" charset="-120"/>
+              </a:rPr>
+              <a:t>Tiếp theo: demo trên Kaggle  →</a:t>
+            </a:r>
+            <a:endParaRPr lang="en-US" sz="1800" dirty="0"/>
+          </a:p>
+        </p:txBody>
+      </p:sp>
+      <p:sp>
+        <p:nvSpPr>
+          <p:cNvPr id="15" name="Text 13"/>
+          <p:cNvSpPr txBox="1"/>
+          <p:nvPr/>
+        </p:nvSpPr>
+        <p:spPr>
+          <a:xfrm>
+            <a:off x="10225735" y="6473952"/>
+            <a:ext cx="1371600" cy="219456"/>
           </a:xfrm>
           <a:prstGeom prst="rect">
             <a:avLst/>
@@ -8542,292 +9400,19 @@
           <a:bodyPr wrap="square" lIns="0" tIns="0" rIns="0" bIns="0" rtlCol="0" anchor="ctr"/>
           <a:lstStyle/>
           <a:p>
-            <a:pPr marL="0" indent="0">
-              <a:buNone/>
-            </a:pPr>
-            <a:r>
-              <a:rPr lang="en-US" sz="1200" b="1" dirty="0">
-                <a:solidFill>
-                  <a:srgbClr val="C9D6DF"/>
+            <a:pPr marL="0" indent="0" algn="r">
+              <a:buNone/>
+            </a:pPr>
+            <a:r>
+              <a:rPr lang="en-US" sz="1000" dirty="0">
+                <a:solidFill>
+                  <a:srgbClr val="9AA8B2"/>
                 </a:solidFill>
                 <a:latin typeface="Consolas" pitchFamily="34" charset="0"/>
                 <a:ea typeface="Consolas" pitchFamily="34" charset="-122"/>
                 <a:cs typeface="Consolas" pitchFamily="34" charset="-120"/>
               </a:rPr>
-              <a:t>CH2  ·  CÂU MẤT DẤU</a:t>
-            </a:r>
-            <a:endParaRPr lang="en-US" sz="1200" dirty="0"/>
-          </a:p>
-        </p:txBody>
-      </p:sp>
-      <p:sp>
-        <p:nvSpPr>
-          <p:cNvPr id="9" name="Text 7"/>
-          <p:cNvSpPr txBox="1"/>
-          <p:nvPr/>
-        </p:nvSpPr>
-        <p:spPr>
-          <a:xfrm>
-            <a:off x="4383938" y="3154680"/>
-            <a:ext cx="3423818" cy="1371600"/>
-          </a:xfrm>
-          <a:prstGeom prst="rect">
-            <a:avLst/>
-          </a:prstGeom>
-          <a:noFill/>
-          <a:ln/>
-        </p:spPr>
-        <p:txBody>
-          <a:bodyPr wrap="square" lIns="0" tIns="0" rIns="0" bIns="0" rtlCol="0" anchor="t"/>
-          <a:lstStyle/>
-          <a:p>
-            <a:pPr marL="0" indent="0">
-              <a:buNone/>
-            </a:pPr>
-            <a:r>
-              <a:rPr lang="en-US" sz="1600" dirty="0">
-                <a:solidFill>
-                  <a:srgbClr val="FFFFFF"/>
-                </a:solidFill>
-                <a:latin typeface="Calibri" pitchFamily="34" charset="0"/>
-                <a:ea typeface="Calibri" pitchFamily="34" charset="-122"/>
-                <a:cs typeface="Calibri" pitchFamily="34" charset="-120"/>
-              </a:rPr>
-              <a:t>Mất dấu thì hệ sụp. Bigram học từ chính kho luật kéo lại gần hết, 0,88 ms mỗi câu.</a:t>
-            </a:r>
-            <a:endParaRPr lang="en-US" sz="1600" dirty="0"/>
-          </a:p>
-        </p:txBody>
-      </p:sp>
-      <p:sp>
-        <p:nvSpPr>
-          <p:cNvPr id="10" name="Text 8"/>
-          <p:cNvSpPr txBox="1"/>
-          <p:nvPr/>
-        </p:nvSpPr>
-        <p:spPr>
-          <a:xfrm>
-            <a:off x="8173517" y="1783080"/>
-            <a:ext cx="3423818" cy="914400"/>
-          </a:xfrm>
-          <a:prstGeom prst="rect">
-            <a:avLst/>
-          </a:prstGeom>
-          <a:noFill/>
-          <a:ln/>
-        </p:spPr>
-        <p:txBody>
-          <a:bodyPr wrap="square" lIns="0" tIns="0" rIns="0" bIns="0" rtlCol="0" anchor="ctr"/>
-          <a:lstStyle/>
-          <a:p>
-            <a:pPr marL="0" indent="0">
-              <a:buNone/>
-            </a:pPr>
-            <a:r>
-              <a:rPr lang="en-US" sz="4800" b="1" dirty="0">
-                <a:solidFill>
-                  <a:srgbClr val="F0A0A6"/>
-                </a:solidFill>
-                <a:latin typeface="Cambria" pitchFamily="34" charset="0"/>
-                <a:ea typeface="Cambria" pitchFamily="34" charset="-122"/>
-                <a:cs typeface="Cambria" pitchFamily="34" charset="-120"/>
-              </a:rPr>
-              <a:t>80%</a:t>
-            </a:r>
-            <a:endParaRPr lang="en-US" sz="4800" dirty="0"/>
-          </a:p>
-        </p:txBody>
-      </p:sp>
-      <p:sp>
-        <p:nvSpPr>
-          <p:cNvPr id="11" name="Text 9"/>
-          <p:cNvSpPr txBox="1"/>
-          <p:nvPr/>
-        </p:nvSpPr>
-        <p:spPr>
-          <a:xfrm>
-            <a:off x="8173517" y="2788920"/>
-            <a:ext cx="3423818" cy="274320"/>
-          </a:xfrm>
-          <a:prstGeom prst="rect">
-            <a:avLst/>
-          </a:prstGeom>
-          <a:noFill/>
-          <a:ln/>
-        </p:spPr>
-        <p:txBody>
-          <a:bodyPr wrap="square" lIns="0" tIns="0" rIns="0" bIns="0" rtlCol="0" anchor="ctr"/>
-          <a:lstStyle/>
-          <a:p>
-            <a:pPr marL="0" indent="0">
-              <a:buNone/>
-            </a:pPr>
-            <a:r>
-              <a:rPr lang="en-US" sz="1200" b="1" dirty="0">
-                <a:solidFill>
-                  <a:srgbClr val="C9D6DF"/>
-                </a:solidFill>
-                <a:latin typeface="Consolas" pitchFamily="34" charset="0"/>
-                <a:ea typeface="Consolas" pitchFamily="34" charset="-122"/>
-                <a:cs typeface="Consolas" pitchFamily="34" charset="-120"/>
-              </a:rPr>
-              <a:t>RÒ RỈ DỮ LIỆU</a:t>
-            </a:r>
-            <a:endParaRPr lang="en-US" sz="1200" dirty="0"/>
-          </a:p>
-        </p:txBody>
-      </p:sp>
-      <p:sp>
-        <p:nvSpPr>
-          <p:cNvPr id="12" name="Text 10"/>
-          <p:cNvSpPr txBox="1"/>
-          <p:nvPr/>
-        </p:nvSpPr>
-        <p:spPr>
-          <a:xfrm>
-            <a:off x="8173517" y="3154680"/>
-            <a:ext cx="3423818" cy="1371600"/>
-          </a:xfrm>
-          <a:prstGeom prst="rect">
-            <a:avLst/>
-          </a:prstGeom>
-          <a:noFill/>
-          <a:ln/>
-        </p:spPr>
-        <p:txBody>
-          <a:bodyPr wrap="square" lIns="0" tIns="0" rIns="0" bIns="0" rtlCol="0" anchor="t"/>
-          <a:lstStyle/>
-          <a:p>
-            <a:pPr marL="0" indent="0">
-              <a:buNone/>
-            </a:pPr>
-            <a:r>
-              <a:rPr lang="en-US" sz="1600" dirty="0">
-                <a:solidFill>
-                  <a:srgbClr val="FFFFFF"/>
-                </a:solidFill>
-                <a:latin typeface="Calibri" pitchFamily="34" charset="0"/>
-                <a:ea typeface="Calibri" pitchFamily="34" charset="-122"/>
-                <a:cs typeface="Calibri" pitchFamily="34" charset="-120"/>
-              </a:rPr>
-              <a:t>Mô hình phổ biến nhất đã học tập train Zalo. Đọc model card trước khi tin một con số benchmark.</a:t>
-            </a:r>
-            <a:endParaRPr lang="en-US" sz="1600" dirty="0"/>
-          </a:p>
-        </p:txBody>
-      </p:sp>
-      <p:sp>
-        <p:nvSpPr>
-          <p:cNvPr id="13" name="Text 11"/>
-          <p:cNvSpPr txBox="1"/>
-          <p:nvPr/>
-        </p:nvSpPr>
-        <p:spPr>
-          <a:xfrm>
-            <a:off x="594360" y="4892040"/>
-            <a:ext cx="11002975" cy="548640"/>
-          </a:xfrm>
-          <a:prstGeom prst="rect">
-            <a:avLst/>
-          </a:prstGeom>
-          <a:noFill/>
-          <a:ln/>
-        </p:spPr>
-        <p:txBody>
-          <a:bodyPr wrap="square" lIns="0" tIns="0" rIns="0" bIns="0" rtlCol="0" anchor="t"/>
-          <a:lstStyle/>
-          <a:p>
-            <a:pPr marL="0" indent="0">
-              <a:buNone/>
-            </a:pPr>
-            <a:r>
-              <a:rPr lang="en-US" sz="1300" dirty="0">
-                <a:solidFill>
-                  <a:srgbClr val="9AA8B2"/>
-                </a:solidFill>
-                <a:latin typeface="Calibri" pitchFamily="34" charset="0"/>
-                <a:ea typeface="Calibri" pitchFamily="34" charset="-122"/>
-                <a:cs typeface="Calibri" pitchFamily="34" charset="-120"/>
-              </a:rPr>
-              <a:t>Giới hạn: câu không dấu và nửa dấu do máy tạo, chưa có câu người thật gõ  ·  nhãn không đầy đủ nên Recall là cận dưới  ·  mỗi cấu hình một seed</a:t>
-            </a:r>
-            <a:endParaRPr lang="en-US" sz="1300" dirty="0"/>
-          </a:p>
-        </p:txBody>
-      </p:sp>
-      <p:sp>
-        <p:nvSpPr>
-          <p:cNvPr id="14" name="Text 12"/>
-          <p:cNvSpPr txBox="1"/>
-          <p:nvPr/>
-        </p:nvSpPr>
-        <p:spPr>
-          <a:xfrm>
-            <a:off x="594360" y="5715000"/>
-            <a:ext cx="11002975" cy="411480"/>
-          </a:xfrm>
-          <a:prstGeom prst="rect">
-            <a:avLst/>
-          </a:prstGeom>
-          <a:noFill/>
-          <a:ln/>
-        </p:spPr>
-        <p:txBody>
-          <a:bodyPr wrap="square" lIns="0" tIns="0" rIns="0" bIns="0" rtlCol="0" anchor="ctr"/>
-          <a:lstStyle/>
-          <a:p>
-            <a:pPr marL="0" indent="0" algn="r">
-              <a:buNone/>
-            </a:pPr>
-            <a:r>
-              <a:rPr lang="en-US" sz="1800" b="1" dirty="0">
-                <a:solidFill>
-                  <a:srgbClr val="FFFFFF"/>
-                </a:solidFill>
-                <a:latin typeface="Calibri" pitchFamily="34" charset="0"/>
-                <a:ea typeface="Calibri" pitchFamily="34" charset="-122"/>
-                <a:cs typeface="Calibri" pitchFamily="34" charset="-120"/>
-              </a:rPr>
-              <a:t>Tiếp theo: demo trên Kaggle  →</a:t>
-            </a:r>
-            <a:endParaRPr lang="en-US" sz="1800" dirty="0"/>
-          </a:p>
-        </p:txBody>
-      </p:sp>
-      <p:sp>
-        <p:nvSpPr>
-          <p:cNvPr id="15" name="Text 13"/>
-          <p:cNvSpPr txBox="1"/>
-          <p:nvPr/>
-        </p:nvSpPr>
-        <p:spPr>
-          <a:xfrm>
-            <a:off x="10225735" y="6473952"/>
-            <a:ext cx="1371600" cy="219456"/>
-          </a:xfrm>
-          <a:prstGeom prst="rect">
-            <a:avLst/>
-          </a:prstGeom>
-          <a:noFill/>
-          <a:ln/>
-        </p:spPr>
-        <p:txBody>
-          <a:bodyPr wrap="square" lIns="0" tIns="0" rIns="0" bIns="0" rtlCol="0" anchor="ctr"/>
-          <a:lstStyle/>
-          <a:p>
-            <a:pPr marL="0" indent="0" algn="r">
-              <a:buNone/>
-            </a:pPr>
-            <a:r>
-              <a:rPr lang="en-US" sz="1000" dirty="0">
-                <a:solidFill>
-                  <a:srgbClr val="9AA8B2"/>
-                </a:solidFill>
-                <a:latin typeface="Consolas" pitchFamily="34" charset="0"/>
-                <a:ea typeface="Consolas" pitchFamily="34" charset="-122"/>
-                <a:cs typeface="Consolas" pitchFamily="34" charset="-120"/>
-              </a:rPr>
-              <a:t>15 / 17</a:t>
+              <a:t>16 / 18</a:t>
             </a:r>
             <a:endParaRPr lang="en-US" sz="1000" dirty="0"/>
           </a:p>
@@ -8841,7 +9426,7 @@
 </p:sld>
 </file>
 
-<file path=ppt/slides/slide16.xml><?xml version="1.0" encoding="utf-8"?>
+<file path=ppt/slides/slide17.xml><?xml version="1.0" encoding="utf-8"?>
 <p:sld xmlns:a="http://schemas.openxmlformats.org/drawingml/2006/main" xmlns:r="http://schemas.openxmlformats.org/officeDocument/2006/relationships" xmlns:p="http://schemas.openxmlformats.org/presentationml/2006/main">
   <p:cSld name="Slide 16">
     <p:bg>
@@ -8874,8 +9459,8 @@
         </p:nvSpPr>
         <p:spPr>
           <a:xfrm>
-            <a:off x="594360" y="329184"/>
-            <a:ext cx="5486400" cy="237744"/>
+            <a:off x="5193792" y="146304"/>
+            <a:ext cx="6400800" cy="292608"/>
           </a:xfrm>
           <a:prstGeom prst="rect">
             <a:avLst/>
@@ -8887,19 +9472,35 @@
           <a:bodyPr wrap="square" lIns="0" tIns="0" rIns="0" bIns="0" rtlCol="0" anchor="ctr"/>
           <a:lstStyle/>
           <a:p>
-            <a:pPr marL="0" indent="0">
-              <a:buNone/>
-            </a:pPr>
-            <a:r>
-              <a:rPr lang="en-US" sz="1100" kern="0" spc="100" dirty="0">
-                <a:solidFill>
-                  <a:srgbClr val="2C5F8A"/>
-                </a:solidFill>
-                <a:latin typeface="Consolas" pitchFamily="34" charset="0"/>
-                <a:ea typeface="Consolas" pitchFamily="34" charset="-122"/>
-                <a:cs typeface="Consolas" pitchFamily="34" charset="-120"/>
-              </a:rPr>
-              <a:t>PHỤ LỤC  ·  16</a:t>
+            <a:pPr marL="0" indent="0" algn="r">
+              <a:buNone/>
+            </a:pPr>
+            <a:r>
+              <a:rPr sz="1400" b="0">
+                <a:solidFill>
+                  <a:srgbClr val="77858E"/>
+                </a:solidFill>
+                <a:latin typeface="Cambria"/>
+              </a:rPr>
+              <a:t>Phụ lục</a:t>
+            </a:r>
+            <a:r>
+              <a:rPr sz="1400" b="0">
+                <a:solidFill>
+                  <a:srgbClr val="77858E"/>
+                </a:solidFill>
+                <a:latin typeface="Cambria"/>
+              </a:rPr>
+              <a:t>   |   </a:t>
+            </a:r>
+            <a:r>
+              <a:rPr sz="1500" b="0">
+                <a:solidFill>
+                  <a:srgbClr val="16222C"/>
+                </a:solidFill>
+                <a:latin typeface="Cambria"/>
+              </a:rPr>
+              <a:t>Tài liệu tham khảo</a:t>
             </a:r>
             <a:endParaRPr lang="en-US" sz="1100" dirty="0"/>
           </a:p>
@@ -9019,7 +9620,7 @@
                 <a:ea typeface="Consolas" pitchFamily="34" charset="-122"/>
                 <a:cs typeface="Consolas" pitchFamily="34" charset="-120"/>
               </a:rPr>
-              <a:t>17 / 17</a:t>
+              <a:t>17 / 18</a:t>
             </a:r>
             <a:endParaRPr lang="en-US" sz="1000" dirty="0"/>
           </a:p>
@@ -9617,7 +10218,7 @@
 </p:sld>
 </file>
 
-<file path=ppt/slides/slide17.xml><?xml version="1.0" encoding="utf-8"?>
+<file path=ppt/slides/slide18.xml><?xml version="1.0" encoding="utf-8"?>
 <p:sld xmlns:a="http://schemas.openxmlformats.org/drawingml/2006/main" xmlns:r="http://schemas.openxmlformats.org/officeDocument/2006/relationships" xmlns:p="http://schemas.openxmlformats.org/presentationml/2006/main">
   <p:cSld name="Slide 1">
     <p:bg>
@@ -9868,8 +10469,8 @@
         </p:nvSpPr>
         <p:spPr>
           <a:xfrm>
-            <a:off x="594360" y="329184"/>
-            <a:ext cx="5486400" cy="237744"/>
+            <a:off x="5193792" y="146304"/>
+            <a:ext cx="6400800" cy="292608"/>
           </a:xfrm>
           <a:prstGeom prst="rect">
             <a:avLst/>
@@ -9881,19 +10482,17 @@
           <a:bodyPr wrap="square" lIns="0" tIns="0" rIns="0" bIns="0" rtlCol="0" anchor="ctr"/>
           <a:lstStyle/>
           <a:p>
-            <a:pPr marL="0" indent="0">
-              <a:buNone/>
-            </a:pPr>
-            <a:r>
-              <a:rPr lang="en-US" sz="1100" kern="0" spc="100" dirty="0">
-                <a:solidFill>
-                  <a:srgbClr val="2C5F8A"/>
-                </a:solidFill>
-                <a:latin typeface="Consolas" pitchFamily="34" charset="0"/>
-                <a:ea typeface="Consolas" pitchFamily="34" charset="-122"/>
-                <a:cs typeface="Consolas" pitchFamily="34" charset="-120"/>
-              </a:rPr>
-              <a:t>BÀI TOÁN  ·  02</a:t>
+            <a:pPr marL="0" indent="0" algn="r">
+              <a:buNone/>
+            </a:pPr>
+            <a:r>
+              <a:rPr sz="1500" b="0">
+                <a:solidFill>
+                  <a:srgbClr val="16222C"/>
+                </a:solidFill>
+                <a:latin typeface="Cambria"/>
+              </a:rPr>
+              <a:t>Bố cục trình bày</a:t>
             </a:r>
             <a:endParaRPr lang="en-US" sz="1100" dirty="0"/>
           </a:p>
@@ -9935,7 +10534,7 @@
                 <a:ea typeface="Cambria" pitchFamily="34" charset="-122"/>
                 <a:cs typeface="Cambria" pitchFamily="34" charset="-120"/>
               </a:rPr>
-              <a:t>Người dân hỏi luật bằng lời thường, và thường gõ không dấu</a:t>
+              <a:t>Bài trình bày gồm năm phần</a:t>
             </a:r>
             <a:endParaRPr lang="en-US" sz="2800" dirty="0"/>
           </a:p>
@@ -10013,7 +10612,7 @@
                 <a:ea typeface="Consolas" pitchFamily="34" charset="-122"/>
                 <a:cs typeface="Consolas" pitchFamily="34" charset="-120"/>
               </a:rPr>
-              <a:t>02 / 17</a:t>
+              <a:t>02 / 18</a:t>
             </a:r>
             <a:endParaRPr lang="en-US" sz="1000" dirty="0"/>
           </a:p>
@@ -10021,14 +10620,14 @@
       </p:sp>
       <p:sp>
         <p:nvSpPr>
-          <p:cNvPr id="7" name="Shape 4"/>
+          <p:cNvPr id="6" name="Rectangle 5"/>
           <p:cNvSpPr/>
           <p:nvPr/>
         </p:nvSpPr>
         <p:spPr>
           <a:xfrm>
-            <a:off x="594360" y="1691640"/>
-            <a:ext cx="5318608" cy="3520440"/>
+            <a:off x="594360" y="2011680"/>
+            <a:ext cx="2017166" cy="2743200"/>
           </a:xfrm>
           <a:prstGeom prst="rect">
             <a:avLst/>
@@ -10036,260 +10635,164 @@
           <a:solidFill>
             <a:srgbClr val="F3F5F2"/>
           </a:solidFill>
-          <a:ln/>
-        </p:spPr>
-        <p:txBody>
-          <a:bodyPr/>
-          <a:lstStyle/>
-          <a:p>
-            <a:endParaRPr lang="en-US"/>
-          </a:p>
-        </p:txBody>
-      </p:sp>
-      <p:sp>
-        <p:nvSpPr>
-          <p:cNvPr id="8" name="Text 5"/>
-          <p:cNvSpPr txBox="1"/>
-          <p:nvPr/>
-        </p:nvSpPr>
-        <p:spPr>
-          <a:xfrm>
-            <a:off x="914400" y="1965960"/>
-            <a:ext cx="3657600" cy="274320"/>
-          </a:xfrm>
-          <a:prstGeom prst="rect">
-            <a:avLst/>
-          </a:prstGeom>
-          <a:noFill/>
-          <a:ln/>
-        </p:spPr>
-        <p:txBody>
-          <a:bodyPr wrap="square" lIns="0" tIns="0" rIns="0" bIns="0" rtlCol="0" anchor="ctr"/>
-          <a:lstStyle/>
-          <a:p>
-            <a:pPr marL="0" indent="0">
-              <a:buNone/>
-            </a:pPr>
-            <a:r>
-              <a:rPr lang="en-US" sz="1200" b="1" dirty="0">
-                <a:solidFill>
-                  <a:srgbClr val="2C5F8A"/>
-                </a:solidFill>
-                <a:latin typeface="Consolas" pitchFamily="34" charset="0"/>
-                <a:ea typeface="Consolas" pitchFamily="34" charset="-122"/>
-                <a:cs typeface="Consolas" pitchFamily="34" charset="-120"/>
-              </a:rPr>
-              <a:t>KHÁC TỪ VỰNG</a:t>
-            </a:r>
-            <a:endParaRPr lang="en-US" sz="1200" dirty="0"/>
-          </a:p>
-        </p:txBody>
-      </p:sp>
-      <p:sp>
-        <p:nvSpPr>
-          <p:cNvPr id="9" name="Text 6"/>
-          <p:cNvSpPr txBox="1"/>
-          <p:nvPr/>
-        </p:nvSpPr>
-        <p:spPr>
-          <a:xfrm>
-            <a:off x="914400" y="2423160"/>
-            <a:ext cx="3657600" cy="256032"/>
-          </a:xfrm>
-          <a:prstGeom prst="rect">
-            <a:avLst/>
-          </a:prstGeom>
-          <a:noFill/>
-          <a:ln/>
-        </p:spPr>
-        <p:txBody>
-          <a:bodyPr wrap="square" lIns="0" tIns="0" rIns="0" bIns="0" rtlCol="0" anchor="ctr"/>
-          <a:lstStyle/>
-          <a:p>
-            <a:pPr marL="0" indent="0">
-              <a:buNone/>
-            </a:pPr>
-            <a:r>
-              <a:rPr lang="en-US" sz="1300" dirty="0">
-                <a:solidFill>
-                  <a:srgbClr val="77858E"/>
-                </a:solidFill>
-                <a:latin typeface="Calibri" pitchFamily="34" charset="0"/>
-                <a:ea typeface="Calibri" pitchFamily="34" charset="-122"/>
-                <a:cs typeface="Calibri" pitchFamily="34" charset="-120"/>
-              </a:rPr>
-              <a:t>Người hỏi</a:t>
-            </a:r>
-            <a:endParaRPr lang="en-US" sz="1300" dirty="0"/>
-          </a:p>
-        </p:txBody>
-      </p:sp>
-      <p:sp>
-        <p:nvSpPr>
-          <p:cNvPr id="10" name="Text 7"/>
-          <p:cNvSpPr txBox="1"/>
-          <p:nvPr/>
-        </p:nvSpPr>
-        <p:spPr>
-          <a:xfrm>
-            <a:off x="914400" y="2697480"/>
-            <a:ext cx="4678528" cy="731520"/>
-          </a:xfrm>
-          <a:prstGeom prst="rect">
-            <a:avLst/>
-          </a:prstGeom>
-          <a:noFill/>
-          <a:ln/>
-        </p:spPr>
-        <p:txBody>
-          <a:bodyPr wrap="square" lIns="0" tIns="0" rIns="0" bIns="0" rtlCol="0" anchor="t"/>
-          <a:lstStyle/>
-          <a:p>
-            <a:pPr marL="0" indent="0">
-              <a:buNone/>
-            </a:pPr>
-            <a:r>
-              <a:rPr lang="en-US" sz="2100" dirty="0">
+          <a:ln>
+            <a:noFill/>
+          </a:ln>
+          <a:effectLst/>
+        </p:spPr>
+        <p:style>
+          <a:lnRef idx="1">
+            <a:schemeClr val="accent1"/>
+          </a:lnRef>
+          <a:fillRef idx="3">
+            <a:schemeClr val="accent1"/>
+          </a:fillRef>
+          <a:effectRef idx="2">
+            <a:schemeClr val="accent1"/>
+          </a:effectRef>
+          <a:fontRef idx="minor">
+            <a:schemeClr val="lt1"/>
+          </a:fontRef>
+        </p:style>
+        <p:txBody>
+          <a:bodyPr rtlCol="0" anchor="ctr"/>
+          <a:lstStyle/>
+          <a:p>
+            <a:pPr algn="ctr"/>
+          </a:p>
+        </p:txBody>
+      </p:sp>
+      <p:sp>
+        <p:nvSpPr>
+          <p:cNvPr id="7" name="Rectangle 6"/>
+          <p:cNvSpPr/>
+          <p:nvPr/>
+        </p:nvSpPr>
+        <p:spPr>
+          <a:xfrm>
+            <a:off x="822960" y="2286000"/>
+            <a:ext cx="566928" cy="566928"/>
+          </a:xfrm>
+          <a:prstGeom prst="rect">
+            <a:avLst/>
+          </a:prstGeom>
+          <a:solidFill>
+            <a:srgbClr val="16222C"/>
+          </a:solidFill>
+          <a:ln>
+            <a:noFill/>
+          </a:ln>
+          <a:effectLst/>
+        </p:spPr>
+        <p:style>
+          <a:lnRef idx="1">
+            <a:schemeClr val="accent1"/>
+          </a:lnRef>
+          <a:fillRef idx="3">
+            <a:schemeClr val="accent1"/>
+          </a:fillRef>
+          <a:effectRef idx="2">
+            <a:schemeClr val="accent1"/>
+          </a:effectRef>
+          <a:fontRef idx="minor">
+            <a:schemeClr val="lt1"/>
+          </a:fontRef>
+        </p:style>
+        <p:txBody>
+          <a:bodyPr rtlCol="0" anchor="ctr" lIns="0" rIns="0" tIns="0" bIns="0"/>
+          <a:lstStyle/>
+          <a:p>
+            <a:pPr algn="ctr"/>
+            <a:r>
+              <a:rPr sz="1800" b="1">
+                <a:solidFill>
+                  <a:srgbClr val="FFFFFF"/>
+                </a:solidFill>
+                <a:latin typeface="Cambria"/>
+              </a:rPr>
+              <a:t>01</a:t>
+            </a:r>
+          </a:p>
+        </p:txBody>
+      </p:sp>
+      <p:sp>
+        <p:nvSpPr>
+          <p:cNvPr id="8" name="TextBox 7"/>
+          <p:cNvSpPr txBox="1"/>
+          <p:nvPr/>
+        </p:nvSpPr>
+        <p:spPr>
+          <a:xfrm>
+            <a:off x="822960" y="3063240"/>
+            <a:ext cx="1605686" cy="457200"/>
+          </a:xfrm>
+          <a:prstGeom prst="rect">
+            <a:avLst/>
+          </a:prstGeom>
+          <a:noFill/>
+        </p:spPr>
+        <p:txBody>
+          <a:bodyPr wrap="square" lIns="0" rIns="0" tIns="0" bIns="0">
+            <a:spAutoFit/>
+          </a:bodyPr>
+          <a:lstStyle/>
+          <a:p>
+            <a:r>
+              <a:rPr sz="2000" b="1">
                 <a:solidFill>
                   <a:srgbClr val="16222C"/>
                 </a:solidFill>
-                <a:latin typeface="Cambria" pitchFamily="34" charset="0"/>
-                <a:ea typeface="Cambria" pitchFamily="34" charset="-122"/>
-                <a:cs typeface="Cambria" pitchFamily="34" charset="-120"/>
-              </a:rPr>
-              <a:t>Nướng bắp, ngô trên cầu phạt bao nhiêu tiền?</a:t>
-            </a:r>
-            <a:endParaRPr lang="en-US" sz="2100" dirty="0"/>
-          </a:p>
-        </p:txBody>
-      </p:sp>
-      <p:sp>
-        <p:nvSpPr>
-          <p:cNvPr id="11" name="Text 8"/>
-          <p:cNvSpPr txBox="1"/>
-          <p:nvPr/>
-        </p:nvSpPr>
-        <p:spPr>
-          <a:xfrm>
-            <a:off x="914400" y="3566160"/>
-            <a:ext cx="3657600" cy="256032"/>
-          </a:xfrm>
-          <a:prstGeom prst="rect">
-            <a:avLst/>
-          </a:prstGeom>
-          <a:noFill/>
-          <a:ln/>
-        </p:spPr>
-        <p:txBody>
-          <a:bodyPr wrap="square" lIns="0" tIns="0" rIns="0" bIns="0" rtlCol="0" anchor="ctr"/>
-          <a:lstStyle/>
-          <a:p>
-            <a:pPr marL="0" indent="0">
-              <a:buNone/>
-            </a:pPr>
-            <a:r>
-              <a:rPr lang="en-US" sz="1300" dirty="0">
-                <a:solidFill>
-                  <a:srgbClr val="77858E"/>
-                </a:solidFill>
-                <a:latin typeface="Calibri" pitchFamily="34" charset="0"/>
-                <a:ea typeface="Calibri" pitchFamily="34" charset="-122"/>
-                <a:cs typeface="Calibri" pitchFamily="34" charset="-120"/>
-              </a:rPr>
-              <a:t>Điều luật đúng</a:t>
-            </a:r>
-            <a:endParaRPr lang="en-US" sz="1300" dirty="0"/>
-          </a:p>
-        </p:txBody>
-      </p:sp>
-      <p:sp>
-        <p:nvSpPr>
-          <p:cNvPr id="12" name="Text 9"/>
-          <p:cNvSpPr txBox="1"/>
-          <p:nvPr/>
-        </p:nvSpPr>
-        <p:spPr>
-          <a:xfrm>
-            <a:off x="914400" y="3840480"/>
-            <a:ext cx="4678528" cy="731520"/>
-          </a:xfrm>
-          <a:prstGeom prst="rect">
-            <a:avLst/>
-          </a:prstGeom>
-          <a:noFill/>
-          <a:ln/>
-        </p:spPr>
-        <p:txBody>
-          <a:bodyPr wrap="square" lIns="0" tIns="0" rIns="0" bIns="0" rtlCol="0" anchor="t"/>
-          <a:lstStyle/>
-          <a:p>
-            <a:pPr marL="0" indent="0">
-              <a:buNone/>
-            </a:pPr>
-            <a:r>
-              <a:rPr lang="en-US" sz="1700" dirty="0">
+                <a:latin typeface="Cambria"/>
+              </a:rPr>
+              <a:t>Bài toán</a:t>
+            </a:r>
+          </a:p>
+        </p:txBody>
+      </p:sp>
+      <p:sp>
+        <p:nvSpPr>
+          <p:cNvPr id="9" name="TextBox 8"/>
+          <p:cNvSpPr txBox="1"/>
+          <p:nvPr/>
+        </p:nvSpPr>
+        <p:spPr>
+          <a:xfrm>
+            <a:off x="822960" y="3611880"/>
+            <a:ext cx="1605686" cy="1737360"/>
+          </a:xfrm>
+          <a:prstGeom prst="rect">
+            <a:avLst/>
+          </a:prstGeom>
+          <a:noFill/>
+        </p:spPr>
+        <p:txBody>
+          <a:bodyPr wrap="square" lIns="0" rIns="0" tIns="0" bIns="0">
+            <a:spAutoFit/>
+          </a:bodyPr>
+          <a:lstStyle/>
+          <a:p>
+            <a:r>
+              <a:rPr sz="1400" b="0">
                 <a:solidFill>
                   <a:srgbClr val="46545F"/>
                 </a:solidFill>
-                <a:latin typeface="Cambria" pitchFamily="34" charset="0"/>
-                <a:ea typeface="Cambria" pitchFamily="34" charset="-122"/>
-                <a:cs typeface="Cambria" pitchFamily="34" charset="-120"/>
-              </a:rPr>
-              <a:t>Xử phạt vi phạm quy định về quản lý, khai thác, bảo trì công trình đường bộ</a:t>
-            </a:r>
-            <a:endParaRPr lang="en-US" sz="1700" dirty="0"/>
-          </a:p>
-        </p:txBody>
-      </p:sp>
-      <p:sp>
-        <p:nvSpPr>
-          <p:cNvPr id="13" name="Text 10"/>
-          <p:cNvSpPr txBox="1"/>
-          <p:nvPr/>
-        </p:nvSpPr>
-        <p:spPr>
-          <a:xfrm>
-            <a:off x="914400" y="4709160"/>
-            <a:ext cx="4678528" cy="310896"/>
-          </a:xfrm>
-          <a:prstGeom prst="rect">
-            <a:avLst/>
-          </a:prstGeom>
-          <a:noFill/>
-          <a:ln/>
-        </p:spPr>
-        <p:txBody>
-          <a:bodyPr wrap="square" lIns="0" tIns="0" rIns="0" bIns="0" rtlCol="0" anchor="ctr"/>
-          <a:lstStyle/>
-          <a:p>
-            <a:pPr marL="0" indent="0">
-              <a:buNone/>
-            </a:pPr>
-            <a:r>
-              <a:rPr lang="en-US" sz="1500" b="1" dirty="0">
-                <a:solidFill>
-                  <a:srgbClr val="A8202B"/>
-                </a:solidFill>
-                <a:latin typeface="Calibri" pitchFamily="34" charset="0"/>
-                <a:ea typeface="Calibri" pitchFamily="34" charset="-122"/>
-                <a:cs typeface="Calibri" pitchFamily="34" charset="-120"/>
-              </a:rPr>
-              <a:t>Không trùng một từ nào</a:t>
-            </a:r>
-            <a:endParaRPr lang="en-US" sz="1500" dirty="0"/>
-          </a:p>
-        </p:txBody>
-      </p:sp>
-      <p:sp>
-        <p:nvSpPr>
-          <p:cNvPr id="14" name="Shape 11"/>
+                <a:latin typeface="Calibri"/>
+              </a:rPr>
+              <a:t>Vì sao câu gõ thiếu dấu làm khó việc tìm luật, nghiên cứu trước còn thiếu gì</a:t>
+            </a:r>
+          </a:p>
+        </p:txBody>
+      </p:sp>
+      <p:sp>
+        <p:nvSpPr>
+          <p:cNvPr id="10" name="Rectangle 9"/>
           <p:cNvSpPr/>
           <p:nvPr/>
         </p:nvSpPr>
         <p:spPr>
           <a:xfrm>
-            <a:off x="6278728" y="1691640"/>
-            <a:ext cx="5318608" cy="3520440"/>
+            <a:off x="2840126" y="2011680"/>
+            <a:ext cx="2017166" cy="2743200"/>
           </a:xfrm>
           <a:prstGeom prst="rect">
             <a:avLst/>
@@ -10297,286 +10800,646 @@
           <a:solidFill>
             <a:srgbClr val="F3F5F2"/>
           </a:solidFill>
-          <a:ln/>
-        </p:spPr>
-        <p:txBody>
-          <a:bodyPr/>
-          <a:lstStyle/>
-          <a:p>
-            <a:endParaRPr lang="en-US"/>
-          </a:p>
-        </p:txBody>
-      </p:sp>
-      <p:sp>
-        <p:nvSpPr>
-          <p:cNvPr id="15" name="Text 12"/>
-          <p:cNvSpPr txBox="1"/>
-          <p:nvPr/>
-        </p:nvSpPr>
-        <p:spPr>
-          <a:xfrm>
-            <a:off x="6598768" y="1965960"/>
-            <a:ext cx="3657600" cy="274320"/>
-          </a:xfrm>
-          <a:prstGeom prst="rect">
-            <a:avLst/>
-          </a:prstGeom>
-          <a:noFill/>
-          <a:ln/>
-        </p:spPr>
-        <p:txBody>
-          <a:bodyPr wrap="square" lIns="0" tIns="0" rIns="0" bIns="0" rtlCol="0" anchor="ctr"/>
-          <a:lstStyle/>
-          <a:p>
-            <a:pPr marL="0" indent="0">
-              <a:buNone/>
-            </a:pPr>
-            <a:r>
-              <a:rPr lang="en-US" sz="1200" b="1" dirty="0">
-                <a:solidFill>
-                  <a:srgbClr val="A8202B"/>
-                </a:solidFill>
-                <a:latin typeface="Consolas" pitchFamily="34" charset="0"/>
-                <a:ea typeface="Consolas" pitchFamily="34" charset="-122"/>
-                <a:cs typeface="Consolas" pitchFamily="34" charset="-120"/>
-              </a:rPr>
-              <a:t>MẤT DẤU</a:t>
-            </a:r>
-            <a:endParaRPr lang="en-US" sz="1200" dirty="0"/>
-          </a:p>
-        </p:txBody>
-      </p:sp>
-      <p:sp>
-        <p:nvSpPr>
-          <p:cNvPr id="16" name="Text 13"/>
-          <p:cNvSpPr txBox="1"/>
-          <p:nvPr/>
-        </p:nvSpPr>
-        <p:spPr>
-          <a:xfrm>
-            <a:off x="6598768" y="2423160"/>
-            <a:ext cx="3657600" cy="256032"/>
-          </a:xfrm>
-          <a:prstGeom prst="rect">
-            <a:avLst/>
-          </a:prstGeom>
-          <a:noFill/>
-          <a:ln/>
-        </p:spPr>
-        <p:txBody>
-          <a:bodyPr wrap="square" lIns="0" tIns="0" rIns="0" bIns="0" rtlCol="0" anchor="ctr"/>
-          <a:lstStyle/>
-          <a:p>
-            <a:pPr marL="0" indent="0">
-              <a:buNone/>
-            </a:pPr>
-            <a:r>
-              <a:rPr lang="en-US" sz="1300" dirty="0">
-                <a:solidFill>
-                  <a:srgbClr val="77858E"/>
-                </a:solidFill>
-                <a:latin typeface="Calibri" pitchFamily="34" charset="0"/>
-                <a:ea typeface="Calibri" pitchFamily="34" charset="-122"/>
-                <a:cs typeface="Calibri" pitchFamily="34" charset="-120"/>
-              </a:rPr>
-              <a:t>Gõ đủ dấu</a:t>
-            </a:r>
-            <a:endParaRPr lang="en-US" sz="1300" dirty="0"/>
-          </a:p>
-        </p:txBody>
-      </p:sp>
-      <p:sp>
-        <p:nvSpPr>
-          <p:cNvPr id="17" name="Text 14"/>
-          <p:cNvSpPr txBox="1"/>
-          <p:nvPr/>
-        </p:nvSpPr>
-        <p:spPr>
-          <a:xfrm>
-            <a:off x="6598768" y="2697480"/>
-            <a:ext cx="4678528" cy="731520"/>
-          </a:xfrm>
-          <a:prstGeom prst="rect">
-            <a:avLst/>
-          </a:prstGeom>
-          <a:noFill/>
-          <a:ln/>
-        </p:spPr>
-        <p:txBody>
-          <a:bodyPr wrap="square" lIns="0" tIns="0" rIns="0" bIns="0" rtlCol="0" anchor="t"/>
-          <a:lstStyle/>
-          <a:p>
-            <a:pPr marL="0" indent="0">
-              <a:buNone/>
-            </a:pPr>
-            <a:r>
-              <a:rPr lang="en-US" sz="2100" dirty="0">
+          <a:ln>
+            <a:noFill/>
+          </a:ln>
+          <a:effectLst/>
+        </p:spPr>
+        <p:style>
+          <a:lnRef idx="1">
+            <a:schemeClr val="accent1"/>
+          </a:lnRef>
+          <a:fillRef idx="3">
+            <a:schemeClr val="accent1"/>
+          </a:fillRef>
+          <a:effectRef idx="2">
+            <a:schemeClr val="accent1"/>
+          </a:effectRef>
+          <a:fontRef idx="minor">
+            <a:schemeClr val="lt1"/>
+          </a:fontRef>
+        </p:style>
+        <p:txBody>
+          <a:bodyPr rtlCol="0" anchor="ctr"/>
+          <a:lstStyle/>
+          <a:p>
+            <a:pPr algn="ctr"/>
+          </a:p>
+        </p:txBody>
+      </p:sp>
+      <p:sp>
+        <p:nvSpPr>
+          <p:cNvPr id="11" name="Rectangle 10"/>
+          <p:cNvSpPr/>
+          <p:nvPr/>
+        </p:nvSpPr>
+        <p:spPr>
+          <a:xfrm>
+            <a:off x="3068726" y="2286000"/>
+            <a:ext cx="566928" cy="566928"/>
+          </a:xfrm>
+          <a:prstGeom prst="rect">
+            <a:avLst/>
+          </a:prstGeom>
+          <a:solidFill>
+            <a:srgbClr val="16222C"/>
+          </a:solidFill>
+          <a:ln>
+            <a:noFill/>
+          </a:ln>
+          <a:effectLst/>
+        </p:spPr>
+        <p:style>
+          <a:lnRef idx="1">
+            <a:schemeClr val="accent1"/>
+          </a:lnRef>
+          <a:fillRef idx="3">
+            <a:schemeClr val="accent1"/>
+          </a:fillRef>
+          <a:effectRef idx="2">
+            <a:schemeClr val="accent1"/>
+          </a:effectRef>
+          <a:fontRef idx="minor">
+            <a:schemeClr val="lt1"/>
+          </a:fontRef>
+        </p:style>
+        <p:txBody>
+          <a:bodyPr rtlCol="0" anchor="ctr" lIns="0" rIns="0" tIns="0" bIns="0"/>
+          <a:lstStyle/>
+          <a:p>
+            <a:pPr algn="ctr"/>
+            <a:r>
+              <a:rPr sz="1800" b="1">
+                <a:solidFill>
+                  <a:srgbClr val="FFFFFF"/>
+                </a:solidFill>
+                <a:latin typeface="Cambria"/>
+              </a:rPr>
+              <a:t>02</a:t>
+            </a:r>
+          </a:p>
+        </p:txBody>
+      </p:sp>
+      <p:sp>
+        <p:nvSpPr>
+          <p:cNvPr id="12" name="TextBox 11"/>
+          <p:cNvSpPr txBox="1"/>
+          <p:nvPr/>
+        </p:nvSpPr>
+        <p:spPr>
+          <a:xfrm>
+            <a:off x="3068726" y="3063240"/>
+            <a:ext cx="1605686" cy="457200"/>
+          </a:xfrm>
+          <a:prstGeom prst="rect">
+            <a:avLst/>
+          </a:prstGeom>
+          <a:noFill/>
+        </p:spPr>
+        <p:txBody>
+          <a:bodyPr wrap="square" lIns="0" rIns="0" tIns="0" bIns="0">
+            <a:spAutoFit/>
+          </a:bodyPr>
+          <a:lstStyle/>
+          <a:p>
+            <a:r>
+              <a:rPr sz="2000" b="1">
                 <a:solidFill>
                   <a:srgbClr val="16222C"/>
                 </a:solidFill>
-                <a:latin typeface="Cambria" pitchFamily="34" charset="0"/>
-                <a:ea typeface="Cambria" pitchFamily="34" charset="-122"/>
-                <a:cs typeface="Cambria" pitchFamily="34" charset="-120"/>
-              </a:rPr>
-              <a:t>Đi xe máy không đội mũ bảo hiểm bị phạt bao nhiêu tiền?</a:t>
-            </a:r>
-            <a:endParaRPr lang="en-US" sz="2100" dirty="0"/>
-          </a:p>
-        </p:txBody>
-      </p:sp>
-      <p:sp>
-        <p:nvSpPr>
-          <p:cNvPr id="18" name="Text 15"/>
-          <p:cNvSpPr txBox="1"/>
-          <p:nvPr/>
-        </p:nvSpPr>
-        <p:spPr>
-          <a:xfrm>
-            <a:off x="6598768" y="3566160"/>
-            <a:ext cx="3657600" cy="256032"/>
-          </a:xfrm>
-          <a:prstGeom prst="rect">
-            <a:avLst/>
-          </a:prstGeom>
-          <a:noFill/>
-          <a:ln/>
-        </p:spPr>
-        <p:txBody>
-          <a:bodyPr wrap="square" lIns="0" tIns="0" rIns="0" bIns="0" rtlCol="0" anchor="ctr"/>
-          <a:lstStyle/>
-          <a:p>
-            <a:pPr marL="0" indent="0">
-              <a:buNone/>
-            </a:pPr>
-            <a:r>
-              <a:rPr lang="en-US" sz="1300" dirty="0">
-                <a:solidFill>
-                  <a:srgbClr val="77858E"/>
-                </a:solidFill>
-                <a:latin typeface="Calibri" pitchFamily="34" charset="0"/>
-                <a:ea typeface="Calibri" pitchFamily="34" charset="-122"/>
-                <a:cs typeface="Calibri" pitchFamily="34" charset="-120"/>
-              </a:rPr>
-              <a:t>Gõ vội trên điện thoại</a:t>
-            </a:r>
-            <a:endParaRPr lang="en-US" sz="1300" dirty="0"/>
-          </a:p>
-        </p:txBody>
-      </p:sp>
-      <p:sp>
-        <p:nvSpPr>
-          <p:cNvPr id="19" name="Text 16"/>
-          <p:cNvSpPr txBox="1"/>
-          <p:nvPr/>
-        </p:nvSpPr>
-        <p:spPr>
-          <a:xfrm>
-            <a:off x="6598768" y="3840480"/>
-            <a:ext cx="4678528" cy="731520"/>
-          </a:xfrm>
-          <a:prstGeom prst="rect">
-            <a:avLst/>
-          </a:prstGeom>
-          <a:noFill/>
-          <a:ln/>
-        </p:spPr>
-        <p:txBody>
-          <a:bodyPr wrap="square" lIns="0" tIns="0" rIns="0" bIns="0" rtlCol="0" anchor="t"/>
-          <a:lstStyle/>
-          <a:p>
-            <a:pPr marL="0" indent="0">
-              <a:buNone/>
-            </a:pPr>
-            <a:r>
-              <a:rPr lang="en-US" sz="1700" dirty="0">
-                <a:solidFill>
-                  <a:srgbClr val="A8202B"/>
-                </a:solidFill>
-                <a:latin typeface="Consolas" pitchFamily="34" charset="0"/>
-                <a:ea typeface="Consolas" pitchFamily="34" charset="-122"/>
-                <a:cs typeface="Consolas" pitchFamily="34" charset="-120"/>
-              </a:rPr>
-              <a:t>di xe may khong doi mu bao hiem bi phat bao nhieu tien</a:t>
-            </a:r>
-            <a:endParaRPr lang="en-US" sz="1700" dirty="0"/>
-          </a:p>
-        </p:txBody>
-      </p:sp>
-      <p:sp>
-        <p:nvSpPr>
-          <p:cNvPr id="20" name="Text 17"/>
-          <p:cNvSpPr txBox="1"/>
-          <p:nvPr/>
-        </p:nvSpPr>
-        <p:spPr>
-          <a:xfrm>
-            <a:off x="6598768" y="4709160"/>
-            <a:ext cx="4678528" cy="310896"/>
-          </a:xfrm>
-          <a:prstGeom prst="rect">
-            <a:avLst/>
-          </a:prstGeom>
-          <a:noFill/>
-          <a:ln/>
-        </p:spPr>
-        <p:txBody>
-          <a:bodyPr wrap="square" lIns="0" tIns="0" rIns="0" bIns="0" rtlCol="0" anchor="ctr"/>
-          <a:lstStyle/>
-          <a:p>
-            <a:pPr marL="0" indent="0">
-              <a:buNone/>
-            </a:pPr>
-            <a:r>
-              <a:rPr lang="en-US" sz="1500" b="1" dirty="0">
-                <a:solidFill>
-                  <a:srgbClr val="A8202B"/>
-                </a:solidFill>
-                <a:latin typeface="Calibri" pitchFamily="34" charset="0"/>
-                <a:ea typeface="Calibri" pitchFamily="34" charset="-122"/>
-                <a:cs typeface="Calibri" pitchFamily="34" charset="-120"/>
-              </a:rPr>
-              <a:t>Với máy, “phạt” và “phat” là hai chữ khác nhau</a:t>
-            </a:r>
-            <a:endParaRPr lang="en-US" sz="1500" dirty="0"/>
-          </a:p>
-        </p:txBody>
-      </p:sp>
-      <p:sp>
-        <p:nvSpPr>
-          <p:cNvPr id="21" name="Text 18"/>
-          <p:cNvSpPr txBox="1"/>
-          <p:nvPr/>
-        </p:nvSpPr>
-        <p:spPr>
-          <a:xfrm>
-            <a:off x="594360" y="5532120"/>
-            <a:ext cx="11002975" cy="365760"/>
-          </a:xfrm>
-          <a:prstGeom prst="rect">
-            <a:avLst/>
-          </a:prstGeom>
-          <a:noFill/>
-          <a:ln/>
-        </p:spPr>
-        <p:txBody>
-          <a:bodyPr wrap="square" lIns="0" tIns="0" rIns="0" bIns="0" rtlCol="0" anchor="ctr"/>
-          <a:lstStyle/>
-          <a:p>
-            <a:pPr marL="0" indent="0">
-              <a:buNone/>
-            </a:pPr>
-            <a:r>
-              <a:rPr lang="en-US" sz="1500" dirty="0">
+                <a:latin typeface="Cambria"/>
+              </a:rPr>
+              <a:t>Dữ liệu</a:t>
+            </a:r>
+          </a:p>
+        </p:txBody>
+      </p:sp>
+      <p:sp>
+        <p:nvSpPr>
+          <p:cNvPr id="13" name="TextBox 12"/>
+          <p:cNvSpPr txBox="1"/>
+          <p:nvPr/>
+        </p:nvSpPr>
+        <p:spPr>
+          <a:xfrm>
+            <a:off x="3068726" y="3611880"/>
+            <a:ext cx="1605686" cy="1737360"/>
+          </a:xfrm>
+          <a:prstGeom prst="rect">
+            <a:avLst/>
+          </a:prstGeom>
+          <a:noFill/>
+        </p:spPr>
+        <p:txBody>
+          <a:bodyPr wrap="square" lIns="0" rIns="0" tIns="0" bIns="0">
+            <a:spAutoFit/>
+          </a:bodyPr>
+          <a:lstStyle/>
+          <a:p>
+            <a:r>
+              <a:rPr sz="1400" b="0">
                 <a:solidFill>
                   <a:srgbClr val="46545F"/>
                 </a:solidFill>
-                <a:latin typeface="Calibri" pitchFamily="34" charset="0"/>
-                <a:ea typeface="Calibri" pitchFamily="34" charset="-122"/>
-                <a:cs typeface="Calibri" pitchFamily="34" charset="-120"/>
-              </a:rPr>
-              <a:t>Đầu vào: một câu hỏi tự nhiên.   Đầu ra: điều luật xếp hạng trong 61.425 điều của 3.271 văn bản, kèm từ đã khớp.</a:t>
-            </a:r>
-            <a:endParaRPr lang="en-US" sz="1500" dirty="0"/>
+                <a:latin typeface="Calibri"/>
+              </a:rPr>
+              <a:t>Bộ Zalo 2021, sáu vấn đề khi kiểm toán, rò rỉ ở dữ liệu và mô hình</a:t>
+            </a:r>
+          </a:p>
+        </p:txBody>
+      </p:sp>
+      <p:sp>
+        <p:nvSpPr>
+          <p:cNvPr id="14" name="Rectangle 13"/>
+          <p:cNvSpPr/>
+          <p:nvPr/>
+        </p:nvSpPr>
+        <p:spPr>
+          <a:xfrm>
+            <a:off x="5085892" y="2011680"/>
+            <a:ext cx="2017166" cy="2743200"/>
+          </a:xfrm>
+          <a:prstGeom prst="rect">
+            <a:avLst/>
+          </a:prstGeom>
+          <a:solidFill>
+            <a:srgbClr val="F3F5F2"/>
+          </a:solidFill>
+          <a:ln>
+            <a:noFill/>
+          </a:ln>
+          <a:effectLst/>
+        </p:spPr>
+        <p:style>
+          <a:lnRef idx="1">
+            <a:schemeClr val="accent1"/>
+          </a:lnRef>
+          <a:fillRef idx="3">
+            <a:schemeClr val="accent1"/>
+          </a:fillRef>
+          <a:effectRef idx="2">
+            <a:schemeClr val="accent1"/>
+          </a:effectRef>
+          <a:fontRef idx="minor">
+            <a:schemeClr val="lt1"/>
+          </a:fontRef>
+        </p:style>
+        <p:txBody>
+          <a:bodyPr rtlCol="0" anchor="ctr"/>
+          <a:lstStyle/>
+          <a:p>
+            <a:pPr algn="ctr"/>
+          </a:p>
+        </p:txBody>
+      </p:sp>
+      <p:sp>
+        <p:nvSpPr>
+          <p:cNvPr id="15" name="Rectangle 14"/>
+          <p:cNvSpPr/>
+          <p:nvPr/>
+        </p:nvSpPr>
+        <p:spPr>
+          <a:xfrm>
+            <a:off x="5314492" y="2286000"/>
+            <a:ext cx="566928" cy="566928"/>
+          </a:xfrm>
+          <a:prstGeom prst="rect">
+            <a:avLst/>
+          </a:prstGeom>
+          <a:solidFill>
+            <a:srgbClr val="16222C"/>
+          </a:solidFill>
+          <a:ln>
+            <a:noFill/>
+          </a:ln>
+          <a:effectLst/>
+        </p:spPr>
+        <p:style>
+          <a:lnRef idx="1">
+            <a:schemeClr val="accent1"/>
+          </a:lnRef>
+          <a:fillRef idx="3">
+            <a:schemeClr val="accent1"/>
+          </a:fillRef>
+          <a:effectRef idx="2">
+            <a:schemeClr val="accent1"/>
+          </a:effectRef>
+          <a:fontRef idx="minor">
+            <a:schemeClr val="lt1"/>
+          </a:fontRef>
+        </p:style>
+        <p:txBody>
+          <a:bodyPr rtlCol="0" anchor="ctr" lIns="0" rIns="0" tIns="0" bIns="0"/>
+          <a:lstStyle/>
+          <a:p>
+            <a:pPr algn="ctr"/>
+            <a:r>
+              <a:rPr sz="1800" b="1">
+                <a:solidFill>
+                  <a:srgbClr val="FFFFFF"/>
+                </a:solidFill>
+                <a:latin typeface="Cambria"/>
+              </a:rPr>
+              <a:t>03</a:t>
+            </a:r>
+          </a:p>
+        </p:txBody>
+      </p:sp>
+      <p:sp>
+        <p:nvSpPr>
+          <p:cNvPr id="16" name="TextBox 15"/>
+          <p:cNvSpPr txBox="1"/>
+          <p:nvPr/>
+        </p:nvSpPr>
+        <p:spPr>
+          <a:xfrm>
+            <a:off x="5314492" y="3063240"/>
+            <a:ext cx="1605686" cy="457200"/>
+          </a:xfrm>
+          <a:prstGeom prst="rect">
+            <a:avLst/>
+          </a:prstGeom>
+          <a:noFill/>
+        </p:spPr>
+        <p:txBody>
+          <a:bodyPr wrap="square" lIns="0" rIns="0" tIns="0" bIns="0">
+            <a:spAutoFit/>
+          </a:bodyPr>
+          <a:lstStyle/>
+          <a:p>
+            <a:r>
+              <a:rPr sz="2000" b="1">
+                <a:solidFill>
+                  <a:srgbClr val="16222C"/>
+                </a:solidFill>
+                <a:latin typeface="Cambria"/>
+              </a:rPr>
+              <a:t>Phương pháp</a:t>
+            </a:r>
+          </a:p>
+        </p:txBody>
+      </p:sp>
+      <p:sp>
+        <p:nvSpPr>
+          <p:cNvPr id="17" name="TextBox 16"/>
+          <p:cNvSpPr txBox="1"/>
+          <p:nvPr/>
+        </p:nvSpPr>
+        <p:spPr>
+          <a:xfrm>
+            <a:off x="5314492" y="3611880"/>
+            <a:ext cx="1605686" cy="1737360"/>
+          </a:xfrm>
+          <a:prstGeom prst="rect">
+            <a:avLst/>
+          </a:prstGeom>
+          <a:noFill/>
+        </p:spPr>
+        <p:txBody>
+          <a:bodyPr wrap="square" lIns="0" rIns="0" tIns="0" bIns="0">
+            <a:spAutoFit/>
+          </a:bodyPr>
+          <a:lstStyle/>
+          <a:p>
+            <a:r>
+              <a:rPr sz="1400" b="0">
+                <a:solidFill>
+                  <a:srgbClr val="46545F"/>
+                </a:solidFill>
+                <a:latin typeface="Calibri"/>
+              </a:rPr>
+              <a:t>Phục hồi dấu, BM25, mô hình ngữ nghĩa và hợp nhất</a:t>
+            </a:r>
+          </a:p>
+        </p:txBody>
+      </p:sp>
+      <p:sp>
+        <p:nvSpPr>
+          <p:cNvPr id="18" name="Rectangle 17"/>
+          <p:cNvSpPr/>
+          <p:nvPr/>
+        </p:nvSpPr>
+        <p:spPr>
+          <a:xfrm>
+            <a:off x="7331659" y="2011680"/>
+            <a:ext cx="2017166" cy="2743200"/>
+          </a:xfrm>
+          <a:prstGeom prst="rect">
+            <a:avLst/>
+          </a:prstGeom>
+          <a:solidFill>
+            <a:srgbClr val="F3F5F2"/>
+          </a:solidFill>
+          <a:ln>
+            <a:noFill/>
+          </a:ln>
+          <a:effectLst/>
+        </p:spPr>
+        <p:style>
+          <a:lnRef idx="1">
+            <a:schemeClr val="accent1"/>
+          </a:lnRef>
+          <a:fillRef idx="3">
+            <a:schemeClr val="accent1"/>
+          </a:fillRef>
+          <a:effectRef idx="2">
+            <a:schemeClr val="accent1"/>
+          </a:effectRef>
+          <a:fontRef idx="minor">
+            <a:schemeClr val="lt1"/>
+          </a:fontRef>
+        </p:style>
+        <p:txBody>
+          <a:bodyPr rtlCol="0" anchor="ctr"/>
+          <a:lstStyle/>
+          <a:p>
+            <a:pPr algn="ctr"/>
+          </a:p>
+        </p:txBody>
+      </p:sp>
+      <p:sp>
+        <p:nvSpPr>
+          <p:cNvPr id="19" name="Rectangle 18"/>
+          <p:cNvSpPr/>
+          <p:nvPr/>
+        </p:nvSpPr>
+        <p:spPr>
+          <a:xfrm>
+            <a:off x="7560259" y="2286000"/>
+            <a:ext cx="566928" cy="566928"/>
+          </a:xfrm>
+          <a:prstGeom prst="rect">
+            <a:avLst/>
+          </a:prstGeom>
+          <a:solidFill>
+            <a:srgbClr val="16222C"/>
+          </a:solidFill>
+          <a:ln>
+            <a:noFill/>
+          </a:ln>
+          <a:effectLst/>
+        </p:spPr>
+        <p:style>
+          <a:lnRef idx="1">
+            <a:schemeClr val="accent1"/>
+          </a:lnRef>
+          <a:fillRef idx="3">
+            <a:schemeClr val="accent1"/>
+          </a:fillRef>
+          <a:effectRef idx="2">
+            <a:schemeClr val="accent1"/>
+          </a:effectRef>
+          <a:fontRef idx="minor">
+            <a:schemeClr val="lt1"/>
+          </a:fontRef>
+        </p:style>
+        <p:txBody>
+          <a:bodyPr rtlCol="0" anchor="ctr" lIns="0" rIns="0" tIns="0" bIns="0"/>
+          <a:lstStyle/>
+          <a:p>
+            <a:pPr algn="ctr"/>
+            <a:r>
+              <a:rPr sz="1800" b="1">
+                <a:solidFill>
+                  <a:srgbClr val="FFFFFF"/>
+                </a:solidFill>
+                <a:latin typeface="Cambria"/>
+              </a:rPr>
+              <a:t>04</a:t>
+            </a:r>
+          </a:p>
+        </p:txBody>
+      </p:sp>
+      <p:sp>
+        <p:nvSpPr>
+          <p:cNvPr id="20" name="TextBox 19"/>
+          <p:cNvSpPr txBox="1"/>
+          <p:nvPr/>
+        </p:nvSpPr>
+        <p:spPr>
+          <a:xfrm>
+            <a:off x="7560259" y="3063240"/>
+            <a:ext cx="1605686" cy="457200"/>
+          </a:xfrm>
+          <a:prstGeom prst="rect">
+            <a:avLst/>
+          </a:prstGeom>
+          <a:noFill/>
+        </p:spPr>
+        <p:txBody>
+          <a:bodyPr wrap="square" lIns="0" rIns="0" tIns="0" bIns="0">
+            <a:spAutoFit/>
+          </a:bodyPr>
+          <a:lstStyle/>
+          <a:p>
+            <a:r>
+              <a:rPr sz="2000" b="1">
+                <a:solidFill>
+                  <a:srgbClr val="16222C"/>
+                </a:solidFill>
+                <a:latin typeface="Cambria"/>
+              </a:rPr>
+              <a:t>Kết quả</a:t>
+            </a:r>
+          </a:p>
+        </p:txBody>
+      </p:sp>
+      <p:sp>
+        <p:nvSpPr>
+          <p:cNvPr id="21" name="TextBox 20"/>
+          <p:cNvSpPr txBox="1"/>
+          <p:nvPr/>
+        </p:nvSpPr>
+        <p:spPr>
+          <a:xfrm>
+            <a:off x="7560259" y="3611880"/>
+            <a:ext cx="1605686" cy="1737360"/>
+          </a:xfrm>
+          <a:prstGeom prst="rect">
+            <a:avLst/>
+          </a:prstGeom>
+          <a:noFill/>
+        </p:spPr>
+        <p:txBody>
+          <a:bodyPr wrap="square" lIns="0" rIns="0" tIns="0" bIns="0">
+            <a:spAutoFit/>
+          </a:bodyPr>
+          <a:lstStyle/>
+          <a:p>
+            <a:r>
+              <a:rPr sz="1400" b="0">
+                <a:solidFill>
+                  <a:srgbClr val="46545F"/>
+                </a:solidFill>
+                <a:latin typeface="Calibri"/>
+              </a:rPr>
+              <a:t>Câu có dấu, câu mất dấu, phục hồi dấu lấy lại được bao nhiêu</a:t>
+            </a:r>
+          </a:p>
+        </p:txBody>
+      </p:sp>
+      <p:sp>
+        <p:nvSpPr>
+          <p:cNvPr id="22" name="Rectangle 21"/>
+          <p:cNvSpPr/>
+          <p:nvPr/>
+        </p:nvSpPr>
+        <p:spPr>
+          <a:xfrm>
+            <a:off x="9577425" y="2011680"/>
+            <a:ext cx="2017166" cy="2743200"/>
+          </a:xfrm>
+          <a:prstGeom prst="rect">
+            <a:avLst/>
+          </a:prstGeom>
+          <a:solidFill>
+            <a:srgbClr val="F3F5F2"/>
+          </a:solidFill>
+          <a:ln>
+            <a:noFill/>
+          </a:ln>
+          <a:effectLst/>
+        </p:spPr>
+        <p:style>
+          <a:lnRef idx="1">
+            <a:schemeClr val="accent1"/>
+          </a:lnRef>
+          <a:fillRef idx="3">
+            <a:schemeClr val="accent1"/>
+          </a:fillRef>
+          <a:effectRef idx="2">
+            <a:schemeClr val="accent1"/>
+          </a:effectRef>
+          <a:fontRef idx="minor">
+            <a:schemeClr val="lt1"/>
+          </a:fontRef>
+        </p:style>
+        <p:txBody>
+          <a:bodyPr rtlCol="0" anchor="ctr"/>
+          <a:lstStyle/>
+          <a:p>
+            <a:pPr algn="ctr"/>
+          </a:p>
+        </p:txBody>
+      </p:sp>
+      <p:sp>
+        <p:nvSpPr>
+          <p:cNvPr id="23" name="Rectangle 22"/>
+          <p:cNvSpPr/>
+          <p:nvPr/>
+        </p:nvSpPr>
+        <p:spPr>
+          <a:xfrm>
+            <a:off x="9806025" y="2286000"/>
+            <a:ext cx="566928" cy="566928"/>
+          </a:xfrm>
+          <a:prstGeom prst="rect">
+            <a:avLst/>
+          </a:prstGeom>
+          <a:solidFill>
+            <a:srgbClr val="16222C"/>
+          </a:solidFill>
+          <a:ln>
+            <a:noFill/>
+          </a:ln>
+          <a:effectLst/>
+        </p:spPr>
+        <p:style>
+          <a:lnRef idx="1">
+            <a:schemeClr val="accent1"/>
+          </a:lnRef>
+          <a:fillRef idx="3">
+            <a:schemeClr val="accent1"/>
+          </a:fillRef>
+          <a:effectRef idx="2">
+            <a:schemeClr val="accent1"/>
+          </a:effectRef>
+          <a:fontRef idx="minor">
+            <a:schemeClr val="lt1"/>
+          </a:fontRef>
+        </p:style>
+        <p:txBody>
+          <a:bodyPr rtlCol="0" anchor="ctr" lIns="0" rIns="0" tIns="0" bIns="0"/>
+          <a:lstStyle/>
+          <a:p>
+            <a:pPr algn="ctr"/>
+            <a:r>
+              <a:rPr sz="1800" b="1">
+                <a:solidFill>
+                  <a:srgbClr val="FFFFFF"/>
+                </a:solidFill>
+                <a:latin typeface="Cambria"/>
+              </a:rPr>
+              <a:t>05</a:t>
+            </a:r>
+          </a:p>
+        </p:txBody>
+      </p:sp>
+      <p:sp>
+        <p:nvSpPr>
+          <p:cNvPr id="24" name="TextBox 23"/>
+          <p:cNvSpPr txBox="1"/>
+          <p:nvPr/>
+        </p:nvSpPr>
+        <p:spPr>
+          <a:xfrm>
+            <a:off x="9806025" y="3063240"/>
+            <a:ext cx="1605686" cy="457200"/>
+          </a:xfrm>
+          <a:prstGeom prst="rect">
+            <a:avLst/>
+          </a:prstGeom>
+          <a:noFill/>
+        </p:spPr>
+        <p:txBody>
+          <a:bodyPr wrap="square" lIns="0" rIns="0" tIns="0" bIns="0">
+            <a:spAutoFit/>
+          </a:bodyPr>
+          <a:lstStyle/>
+          <a:p>
+            <a:r>
+              <a:rPr sz="2000" b="1">
+                <a:solidFill>
+                  <a:srgbClr val="16222C"/>
+                </a:solidFill>
+                <a:latin typeface="Cambria"/>
+              </a:rPr>
+              <a:t>Kết luận</a:t>
+            </a:r>
+          </a:p>
+        </p:txBody>
+      </p:sp>
+      <p:sp>
+        <p:nvSpPr>
+          <p:cNvPr id="25" name="TextBox 24"/>
+          <p:cNvSpPr txBox="1"/>
+          <p:nvPr/>
+        </p:nvSpPr>
+        <p:spPr>
+          <a:xfrm>
+            <a:off x="9806025" y="3611880"/>
+            <a:ext cx="1605686" cy="1737360"/>
+          </a:xfrm>
+          <a:prstGeom prst="rect">
+            <a:avLst/>
+          </a:prstGeom>
+          <a:noFill/>
+        </p:spPr>
+        <p:txBody>
+          <a:bodyPr wrap="square" lIns="0" rIns="0" tIns="0" bIns="0">
+            <a:spAutoFit/>
+          </a:bodyPr>
+          <a:lstStyle/>
+          <a:p>
+            <a:r>
+              <a:rPr sz="1400" b="0">
+                <a:solidFill>
+                  <a:srgbClr val="46545F"/>
+                </a:solidFill>
+                <a:latin typeface="Calibri"/>
+              </a:rPr>
+              <a:t>Ba điều rút ra, giới hạn, rồi demo trên Kaggle</a:t>
+            </a:r>
           </a:p>
         </p:txBody>
       </p:sp>
@@ -10589,6 +11452,775 @@
 </file>
 
 <file path=ppt/slides/slide3.xml><?xml version="1.0" encoding="utf-8"?>
+<p:sld xmlns:a="http://schemas.openxmlformats.org/drawingml/2006/main" xmlns:r="http://schemas.openxmlformats.org/officeDocument/2006/relationships" xmlns:p="http://schemas.openxmlformats.org/presentationml/2006/main">
+  <p:cSld name="Slide 2">
+    <p:bg>
+      <p:bgPr>
+        <a:solidFill>
+          <a:srgbClr val="FFFFFF"/>
+        </a:solidFill>
+        <a:effectLst/>
+      </p:bgPr>
+    </p:bg>
+    <p:spTree>
+      <p:nvGrpSpPr>
+        <p:cNvPr id="1" name=""/>
+        <p:cNvGrpSpPr/>
+        <p:nvPr/>
+      </p:nvGrpSpPr>
+      <p:grpSpPr>
+        <a:xfrm>
+          <a:off x="0" y="0"/>
+          <a:ext cx="0" cy="0"/>
+          <a:chOff x="0" y="0"/>
+          <a:chExt cx="0" cy="0"/>
+        </a:xfrm>
+      </p:grpSpPr>
+      <p:sp>
+        <p:nvSpPr>
+          <p:cNvPr id="2" name="Text 0"/>
+          <p:cNvSpPr txBox="1"/>
+          <p:nvPr/>
+        </p:nvSpPr>
+        <p:spPr>
+          <a:xfrm>
+            <a:off x="5193792" y="146304"/>
+            <a:ext cx="6400800" cy="292608"/>
+          </a:xfrm>
+          <a:prstGeom prst="rect">
+            <a:avLst/>
+          </a:prstGeom>
+          <a:noFill/>
+          <a:ln/>
+        </p:spPr>
+        <p:txBody>
+          <a:bodyPr wrap="square" lIns="0" tIns="0" rIns="0" bIns="0" rtlCol="0" anchor="ctr"/>
+          <a:lstStyle/>
+          <a:p>
+            <a:pPr marL="0" indent="0" algn="r">
+              <a:buNone/>
+            </a:pPr>
+            <a:r>
+              <a:rPr sz="1400" b="0">
+                <a:solidFill>
+                  <a:srgbClr val="77858E"/>
+                </a:solidFill>
+                <a:latin typeface="Cambria"/>
+              </a:rPr>
+              <a:t>Phần 1</a:t>
+            </a:r>
+            <a:r>
+              <a:rPr sz="1400" b="0">
+                <a:solidFill>
+                  <a:srgbClr val="77858E"/>
+                </a:solidFill>
+                <a:latin typeface="Cambria"/>
+              </a:rPr>
+              <a:t>   |   </a:t>
+            </a:r>
+            <a:r>
+              <a:rPr sz="1500" b="0">
+                <a:solidFill>
+                  <a:srgbClr val="16222C"/>
+                </a:solidFill>
+                <a:latin typeface="Cambria"/>
+              </a:rPr>
+              <a:t>Bài toán</a:t>
+            </a:r>
+            <a:endParaRPr lang="en-US" sz="1100" dirty="0"/>
+          </a:p>
+        </p:txBody>
+      </p:sp>
+      <p:sp>
+        <p:nvSpPr>
+          <p:cNvPr id="3" name="Text 1"/>
+          <p:cNvSpPr txBox="1"/>
+          <p:nvPr/>
+        </p:nvSpPr>
+        <p:spPr>
+          <a:xfrm>
+            <a:off x="594360" y="585216"/>
+            <a:ext cx="11002975" cy="868680"/>
+          </a:xfrm>
+          <a:prstGeom prst="rect">
+            <a:avLst/>
+          </a:prstGeom>
+          <a:noFill/>
+          <a:ln/>
+        </p:spPr>
+        <p:txBody>
+          <a:bodyPr wrap="square" lIns="0" tIns="0" rIns="0" bIns="0" rtlCol="0" anchor="t"/>
+          <a:lstStyle/>
+          <a:p>
+            <a:pPr marL="0" indent="0">
+              <a:lnSpc>
+                <a:spcPct val="95000"/>
+              </a:lnSpc>
+              <a:buNone/>
+            </a:pPr>
+            <a:r>
+              <a:rPr lang="en-US" sz="2800" b="1" dirty="0">
+                <a:solidFill>
+                  <a:srgbClr val="16222C"/>
+                </a:solidFill>
+                <a:latin typeface="Cambria" pitchFamily="34" charset="0"/>
+                <a:ea typeface="Cambria" pitchFamily="34" charset="-122"/>
+                <a:cs typeface="Cambria" pitchFamily="34" charset="-120"/>
+              </a:rPr>
+              <a:t>Người dân hỏi luật bằng lời thường, và thường gõ không dấu</a:t>
+            </a:r>
+            <a:endParaRPr lang="en-US" sz="2800" dirty="0"/>
+          </a:p>
+        </p:txBody>
+      </p:sp>
+      <p:sp>
+        <p:nvSpPr>
+          <p:cNvPr id="4" name="Text 2"/>
+          <p:cNvSpPr txBox="1"/>
+          <p:nvPr/>
+        </p:nvSpPr>
+        <p:spPr>
+          <a:xfrm>
+            <a:off x="594360" y="6473952"/>
+            <a:ext cx="7315200" cy="219456"/>
+          </a:xfrm>
+          <a:prstGeom prst="rect">
+            <a:avLst/>
+          </a:prstGeom>
+          <a:noFill/>
+          <a:ln/>
+        </p:spPr>
+        <p:txBody>
+          <a:bodyPr wrap="square" lIns="0" tIns="0" rIns="0" bIns="0" rtlCol="0" anchor="ctr"/>
+          <a:lstStyle/>
+          <a:p>
+            <a:pPr marL="0" indent="0">
+              <a:buNone/>
+            </a:pPr>
+            <a:r>
+              <a:rPr lang="en-US" sz="1000" dirty="0">
+                <a:solidFill>
+                  <a:srgbClr val="77858E"/>
+                </a:solidFill>
+                <a:latin typeface="Calibri" pitchFamily="34" charset="0"/>
+                <a:ea typeface="Calibri" pitchFamily="34" charset="-122"/>
+                <a:cs typeface="Calibri" pitchFamily="34" charset="-120"/>
+              </a:rPr>
+              <a:t>Nhóm 08  ·  Tìm kiếm điều luật tiếng Việt cho câu hỏi gõ thiếu dấu</a:t>
+            </a:r>
+            <a:endParaRPr lang="en-US" sz="1000" dirty="0"/>
+          </a:p>
+        </p:txBody>
+      </p:sp>
+      <p:sp>
+        <p:nvSpPr>
+          <p:cNvPr id="5" name="Text 3"/>
+          <p:cNvSpPr txBox="1"/>
+          <p:nvPr/>
+        </p:nvSpPr>
+        <p:spPr>
+          <a:xfrm>
+            <a:off x="10225735" y="6473952"/>
+            <a:ext cx="1371600" cy="219456"/>
+          </a:xfrm>
+          <a:prstGeom prst="rect">
+            <a:avLst/>
+          </a:prstGeom>
+          <a:noFill/>
+          <a:ln/>
+        </p:spPr>
+        <p:txBody>
+          <a:bodyPr wrap="square" lIns="0" tIns="0" rIns="0" bIns="0" rtlCol="0" anchor="ctr"/>
+          <a:lstStyle/>
+          <a:p>
+            <a:pPr marL="0" indent="0" algn="r">
+              <a:buNone/>
+            </a:pPr>
+            <a:r>
+              <a:rPr lang="en-US" sz="1000" dirty="0">
+                <a:solidFill>
+                  <a:srgbClr val="77858E"/>
+                </a:solidFill>
+                <a:latin typeface="Consolas" pitchFamily="34" charset="0"/>
+                <a:ea typeface="Consolas" pitchFamily="34" charset="-122"/>
+                <a:cs typeface="Consolas" pitchFamily="34" charset="-120"/>
+              </a:rPr>
+              <a:t>03 / 18</a:t>
+            </a:r>
+            <a:endParaRPr lang="en-US" sz="1000" dirty="0"/>
+          </a:p>
+        </p:txBody>
+      </p:sp>
+      <p:sp>
+        <p:nvSpPr>
+          <p:cNvPr id="7" name="Shape 4"/>
+          <p:cNvSpPr/>
+          <p:nvPr/>
+        </p:nvSpPr>
+        <p:spPr>
+          <a:xfrm>
+            <a:off x="594360" y="1691640"/>
+            <a:ext cx="5318608" cy="3520440"/>
+          </a:xfrm>
+          <a:prstGeom prst="rect">
+            <a:avLst/>
+          </a:prstGeom>
+          <a:solidFill>
+            <a:srgbClr val="F3F5F2"/>
+          </a:solidFill>
+          <a:ln/>
+        </p:spPr>
+        <p:txBody>
+          <a:bodyPr/>
+          <a:lstStyle/>
+          <a:p>
+            <a:endParaRPr lang="en-US"/>
+          </a:p>
+        </p:txBody>
+      </p:sp>
+      <p:sp>
+        <p:nvSpPr>
+          <p:cNvPr id="8" name="Text 5"/>
+          <p:cNvSpPr txBox="1"/>
+          <p:nvPr/>
+        </p:nvSpPr>
+        <p:spPr>
+          <a:xfrm>
+            <a:off x="914400" y="1965960"/>
+            <a:ext cx="3657600" cy="274320"/>
+          </a:xfrm>
+          <a:prstGeom prst="rect">
+            <a:avLst/>
+          </a:prstGeom>
+          <a:noFill/>
+          <a:ln/>
+        </p:spPr>
+        <p:txBody>
+          <a:bodyPr wrap="square" lIns="0" tIns="0" rIns="0" bIns="0" rtlCol="0" anchor="ctr"/>
+          <a:lstStyle/>
+          <a:p>
+            <a:pPr marL="0" indent="0">
+              <a:buNone/>
+            </a:pPr>
+            <a:r>
+              <a:rPr lang="en-US" sz="1200" b="1" dirty="0">
+                <a:solidFill>
+                  <a:srgbClr val="2C5F8A"/>
+                </a:solidFill>
+                <a:latin typeface="Consolas" pitchFamily="34" charset="0"/>
+                <a:ea typeface="Consolas" pitchFamily="34" charset="-122"/>
+                <a:cs typeface="Consolas" pitchFamily="34" charset="-120"/>
+              </a:rPr>
+              <a:t>KHÁC TỪ VỰNG</a:t>
+            </a:r>
+            <a:endParaRPr lang="en-US" sz="1200" dirty="0"/>
+          </a:p>
+        </p:txBody>
+      </p:sp>
+      <p:sp>
+        <p:nvSpPr>
+          <p:cNvPr id="9" name="Text 6"/>
+          <p:cNvSpPr txBox="1"/>
+          <p:nvPr/>
+        </p:nvSpPr>
+        <p:spPr>
+          <a:xfrm>
+            <a:off x="914400" y="2423160"/>
+            <a:ext cx="3657600" cy="256032"/>
+          </a:xfrm>
+          <a:prstGeom prst="rect">
+            <a:avLst/>
+          </a:prstGeom>
+          <a:noFill/>
+          <a:ln/>
+        </p:spPr>
+        <p:txBody>
+          <a:bodyPr wrap="square" lIns="0" tIns="0" rIns="0" bIns="0" rtlCol="0" anchor="ctr"/>
+          <a:lstStyle/>
+          <a:p>
+            <a:pPr marL="0" indent="0">
+              <a:buNone/>
+            </a:pPr>
+            <a:r>
+              <a:rPr lang="en-US" sz="1300" dirty="0">
+                <a:solidFill>
+                  <a:srgbClr val="77858E"/>
+                </a:solidFill>
+                <a:latin typeface="Calibri" pitchFamily="34" charset="0"/>
+                <a:ea typeface="Calibri" pitchFamily="34" charset="-122"/>
+                <a:cs typeface="Calibri" pitchFamily="34" charset="-120"/>
+              </a:rPr>
+              <a:t>Người hỏi</a:t>
+            </a:r>
+            <a:endParaRPr lang="en-US" sz="1300" dirty="0"/>
+          </a:p>
+        </p:txBody>
+      </p:sp>
+      <p:sp>
+        <p:nvSpPr>
+          <p:cNvPr id="10" name="Text 7"/>
+          <p:cNvSpPr txBox="1"/>
+          <p:nvPr/>
+        </p:nvSpPr>
+        <p:spPr>
+          <a:xfrm>
+            <a:off x="914400" y="2697480"/>
+            <a:ext cx="4678528" cy="731520"/>
+          </a:xfrm>
+          <a:prstGeom prst="rect">
+            <a:avLst/>
+          </a:prstGeom>
+          <a:noFill/>
+          <a:ln/>
+        </p:spPr>
+        <p:txBody>
+          <a:bodyPr wrap="square" lIns="0" tIns="0" rIns="0" bIns="0" rtlCol="0" anchor="t"/>
+          <a:lstStyle/>
+          <a:p>
+            <a:pPr marL="0" indent="0">
+              <a:buNone/>
+            </a:pPr>
+            <a:r>
+              <a:rPr lang="en-US" sz="2100" dirty="0">
+                <a:solidFill>
+                  <a:srgbClr val="16222C"/>
+                </a:solidFill>
+                <a:latin typeface="Cambria" pitchFamily="34" charset="0"/>
+                <a:ea typeface="Cambria" pitchFamily="34" charset="-122"/>
+                <a:cs typeface="Cambria" pitchFamily="34" charset="-120"/>
+              </a:rPr>
+              <a:t>Nướng bắp, ngô trên cầu phạt bao nhiêu tiền?</a:t>
+            </a:r>
+            <a:endParaRPr lang="en-US" sz="2100" dirty="0"/>
+          </a:p>
+        </p:txBody>
+      </p:sp>
+      <p:sp>
+        <p:nvSpPr>
+          <p:cNvPr id="11" name="Text 8"/>
+          <p:cNvSpPr txBox="1"/>
+          <p:nvPr/>
+        </p:nvSpPr>
+        <p:spPr>
+          <a:xfrm>
+            <a:off x="914400" y="3566160"/>
+            <a:ext cx="3657600" cy="256032"/>
+          </a:xfrm>
+          <a:prstGeom prst="rect">
+            <a:avLst/>
+          </a:prstGeom>
+          <a:noFill/>
+          <a:ln/>
+        </p:spPr>
+        <p:txBody>
+          <a:bodyPr wrap="square" lIns="0" tIns="0" rIns="0" bIns="0" rtlCol="0" anchor="ctr"/>
+          <a:lstStyle/>
+          <a:p>
+            <a:pPr marL="0" indent="0">
+              <a:buNone/>
+            </a:pPr>
+            <a:r>
+              <a:rPr lang="en-US" sz="1300" dirty="0">
+                <a:solidFill>
+                  <a:srgbClr val="77858E"/>
+                </a:solidFill>
+                <a:latin typeface="Calibri" pitchFamily="34" charset="0"/>
+                <a:ea typeface="Calibri" pitchFamily="34" charset="-122"/>
+                <a:cs typeface="Calibri" pitchFamily="34" charset="-120"/>
+              </a:rPr>
+              <a:t>Điều luật đúng</a:t>
+            </a:r>
+            <a:endParaRPr lang="en-US" sz="1300" dirty="0"/>
+          </a:p>
+        </p:txBody>
+      </p:sp>
+      <p:sp>
+        <p:nvSpPr>
+          <p:cNvPr id="12" name="Text 9"/>
+          <p:cNvSpPr txBox="1"/>
+          <p:nvPr/>
+        </p:nvSpPr>
+        <p:spPr>
+          <a:xfrm>
+            <a:off x="914400" y="3840480"/>
+            <a:ext cx="4678528" cy="731520"/>
+          </a:xfrm>
+          <a:prstGeom prst="rect">
+            <a:avLst/>
+          </a:prstGeom>
+          <a:noFill/>
+          <a:ln/>
+        </p:spPr>
+        <p:txBody>
+          <a:bodyPr wrap="square" lIns="0" tIns="0" rIns="0" bIns="0" rtlCol="0" anchor="t"/>
+          <a:lstStyle/>
+          <a:p>
+            <a:pPr marL="0" indent="0">
+              <a:buNone/>
+            </a:pPr>
+            <a:r>
+              <a:rPr lang="en-US" sz="1700" dirty="0">
+                <a:solidFill>
+                  <a:srgbClr val="46545F"/>
+                </a:solidFill>
+                <a:latin typeface="Cambria" pitchFamily="34" charset="0"/>
+                <a:ea typeface="Cambria" pitchFamily="34" charset="-122"/>
+                <a:cs typeface="Cambria" pitchFamily="34" charset="-120"/>
+              </a:rPr>
+              <a:t>Xử phạt vi phạm quy định về quản lý, khai thác, bảo trì công trình đường bộ</a:t>
+            </a:r>
+            <a:endParaRPr lang="en-US" sz="1700" dirty="0"/>
+          </a:p>
+        </p:txBody>
+      </p:sp>
+      <p:sp>
+        <p:nvSpPr>
+          <p:cNvPr id="13" name="Text 10"/>
+          <p:cNvSpPr txBox="1"/>
+          <p:nvPr/>
+        </p:nvSpPr>
+        <p:spPr>
+          <a:xfrm>
+            <a:off x="914400" y="4709160"/>
+            <a:ext cx="4678528" cy="310896"/>
+          </a:xfrm>
+          <a:prstGeom prst="rect">
+            <a:avLst/>
+          </a:prstGeom>
+          <a:noFill/>
+          <a:ln/>
+        </p:spPr>
+        <p:txBody>
+          <a:bodyPr wrap="square" lIns="0" tIns="0" rIns="0" bIns="0" rtlCol="0" anchor="ctr"/>
+          <a:lstStyle/>
+          <a:p>
+            <a:pPr marL="0" indent="0">
+              <a:buNone/>
+            </a:pPr>
+            <a:r>
+              <a:rPr lang="en-US" sz="1500" b="1" dirty="0">
+                <a:solidFill>
+                  <a:srgbClr val="A8202B"/>
+                </a:solidFill>
+                <a:latin typeface="Calibri" pitchFamily="34" charset="0"/>
+                <a:ea typeface="Calibri" pitchFamily="34" charset="-122"/>
+                <a:cs typeface="Calibri" pitchFamily="34" charset="-120"/>
+              </a:rPr>
+              <a:t>Không trùng một từ nào</a:t>
+            </a:r>
+            <a:endParaRPr lang="en-US" sz="1500" dirty="0"/>
+          </a:p>
+        </p:txBody>
+      </p:sp>
+      <p:sp>
+        <p:nvSpPr>
+          <p:cNvPr id="14" name="Shape 11"/>
+          <p:cNvSpPr/>
+          <p:nvPr/>
+        </p:nvSpPr>
+        <p:spPr>
+          <a:xfrm>
+            <a:off x="6278728" y="1691640"/>
+            <a:ext cx="5318608" cy="3520440"/>
+          </a:xfrm>
+          <a:prstGeom prst="rect">
+            <a:avLst/>
+          </a:prstGeom>
+          <a:solidFill>
+            <a:srgbClr val="F3F5F2"/>
+          </a:solidFill>
+          <a:ln/>
+        </p:spPr>
+        <p:txBody>
+          <a:bodyPr/>
+          <a:lstStyle/>
+          <a:p>
+            <a:endParaRPr lang="en-US"/>
+          </a:p>
+        </p:txBody>
+      </p:sp>
+      <p:sp>
+        <p:nvSpPr>
+          <p:cNvPr id="15" name="Text 12"/>
+          <p:cNvSpPr txBox="1"/>
+          <p:nvPr/>
+        </p:nvSpPr>
+        <p:spPr>
+          <a:xfrm>
+            <a:off x="6598768" y="1965960"/>
+            <a:ext cx="3657600" cy="274320"/>
+          </a:xfrm>
+          <a:prstGeom prst="rect">
+            <a:avLst/>
+          </a:prstGeom>
+          <a:noFill/>
+          <a:ln/>
+        </p:spPr>
+        <p:txBody>
+          <a:bodyPr wrap="square" lIns="0" tIns="0" rIns="0" bIns="0" rtlCol="0" anchor="ctr"/>
+          <a:lstStyle/>
+          <a:p>
+            <a:pPr marL="0" indent="0">
+              <a:buNone/>
+            </a:pPr>
+            <a:r>
+              <a:rPr lang="en-US" sz="1200" b="1" dirty="0">
+                <a:solidFill>
+                  <a:srgbClr val="A8202B"/>
+                </a:solidFill>
+                <a:latin typeface="Consolas" pitchFamily="34" charset="0"/>
+                <a:ea typeface="Consolas" pitchFamily="34" charset="-122"/>
+                <a:cs typeface="Consolas" pitchFamily="34" charset="-120"/>
+              </a:rPr>
+              <a:t>MẤT DẤU</a:t>
+            </a:r>
+            <a:endParaRPr lang="en-US" sz="1200" dirty="0"/>
+          </a:p>
+        </p:txBody>
+      </p:sp>
+      <p:sp>
+        <p:nvSpPr>
+          <p:cNvPr id="16" name="Text 13"/>
+          <p:cNvSpPr txBox="1"/>
+          <p:nvPr/>
+        </p:nvSpPr>
+        <p:spPr>
+          <a:xfrm>
+            <a:off x="6598768" y="2423160"/>
+            <a:ext cx="3657600" cy="256032"/>
+          </a:xfrm>
+          <a:prstGeom prst="rect">
+            <a:avLst/>
+          </a:prstGeom>
+          <a:noFill/>
+          <a:ln/>
+        </p:spPr>
+        <p:txBody>
+          <a:bodyPr wrap="square" lIns="0" tIns="0" rIns="0" bIns="0" rtlCol="0" anchor="ctr"/>
+          <a:lstStyle/>
+          <a:p>
+            <a:pPr marL="0" indent="0">
+              <a:buNone/>
+            </a:pPr>
+            <a:r>
+              <a:rPr lang="en-US" sz="1300" dirty="0">
+                <a:solidFill>
+                  <a:srgbClr val="77858E"/>
+                </a:solidFill>
+                <a:latin typeface="Calibri" pitchFamily="34" charset="0"/>
+                <a:ea typeface="Calibri" pitchFamily="34" charset="-122"/>
+                <a:cs typeface="Calibri" pitchFamily="34" charset="-120"/>
+              </a:rPr>
+              <a:t>Gõ đủ dấu</a:t>
+            </a:r>
+            <a:endParaRPr lang="en-US" sz="1300" dirty="0"/>
+          </a:p>
+        </p:txBody>
+      </p:sp>
+      <p:sp>
+        <p:nvSpPr>
+          <p:cNvPr id="17" name="Text 14"/>
+          <p:cNvSpPr txBox="1"/>
+          <p:nvPr/>
+        </p:nvSpPr>
+        <p:spPr>
+          <a:xfrm>
+            <a:off x="6598768" y="2697480"/>
+            <a:ext cx="4678528" cy="731520"/>
+          </a:xfrm>
+          <a:prstGeom prst="rect">
+            <a:avLst/>
+          </a:prstGeom>
+          <a:noFill/>
+          <a:ln/>
+        </p:spPr>
+        <p:txBody>
+          <a:bodyPr wrap="square" lIns="0" tIns="0" rIns="0" bIns="0" rtlCol="0" anchor="t"/>
+          <a:lstStyle/>
+          <a:p>
+            <a:pPr marL="0" indent="0">
+              <a:buNone/>
+            </a:pPr>
+            <a:r>
+              <a:rPr lang="en-US" sz="2100" dirty="0">
+                <a:solidFill>
+                  <a:srgbClr val="16222C"/>
+                </a:solidFill>
+                <a:latin typeface="Cambria" pitchFamily="34" charset="0"/>
+                <a:ea typeface="Cambria" pitchFamily="34" charset="-122"/>
+                <a:cs typeface="Cambria" pitchFamily="34" charset="-120"/>
+              </a:rPr>
+              <a:t>Đi xe máy không đội mũ bảo hiểm bị phạt bao nhiêu tiền?</a:t>
+            </a:r>
+            <a:endParaRPr lang="en-US" sz="2100" dirty="0"/>
+          </a:p>
+        </p:txBody>
+      </p:sp>
+      <p:sp>
+        <p:nvSpPr>
+          <p:cNvPr id="18" name="Text 15"/>
+          <p:cNvSpPr txBox="1"/>
+          <p:nvPr/>
+        </p:nvSpPr>
+        <p:spPr>
+          <a:xfrm>
+            <a:off x="6598768" y="3566160"/>
+            <a:ext cx="3657600" cy="256032"/>
+          </a:xfrm>
+          <a:prstGeom prst="rect">
+            <a:avLst/>
+          </a:prstGeom>
+          <a:noFill/>
+          <a:ln/>
+        </p:spPr>
+        <p:txBody>
+          <a:bodyPr wrap="square" lIns="0" tIns="0" rIns="0" bIns="0" rtlCol="0" anchor="ctr"/>
+          <a:lstStyle/>
+          <a:p>
+            <a:pPr marL="0" indent="0">
+              <a:buNone/>
+            </a:pPr>
+            <a:r>
+              <a:rPr lang="en-US" sz="1300" dirty="0">
+                <a:solidFill>
+                  <a:srgbClr val="77858E"/>
+                </a:solidFill>
+                <a:latin typeface="Calibri" pitchFamily="34" charset="0"/>
+                <a:ea typeface="Calibri" pitchFamily="34" charset="-122"/>
+                <a:cs typeface="Calibri" pitchFamily="34" charset="-120"/>
+              </a:rPr>
+              <a:t>Gõ vội trên điện thoại</a:t>
+            </a:r>
+            <a:endParaRPr lang="en-US" sz="1300" dirty="0"/>
+          </a:p>
+        </p:txBody>
+      </p:sp>
+      <p:sp>
+        <p:nvSpPr>
+          <p:cNvPr id="19" name="Text 16"/>
+          <p:cNvSpPr txBox="1"/>
+          <p:nvPr/>
+        </p:nvSpPr>
+        <p:spPr>
+          <a:xfrm>
+            <a:off x="6598768" y="3840480"/>
+            <a:ext cx="4678528" cy="731520"/>
+          </a:xfrm>
+          <a:prstGeom prst="rect">
+            <a:avLst/>
+          </a:prstGeom>
+          <a:noFill/>
+          <a:ln/>
+        </p:spPr>
+        <p:txBody>
+          <a:bodyPr wrap="square" lIns="0" tIns="0" rIns="0" bIns="0" rtlCol="0" anchor="t"/>
+          <a:lstStyle/>
+          <a:p>
+            <a:pPr marL="0" indent="0">
+              <a:buNone/>
+            </a:pPr>
+            <a:r>
+              <a:rPr lang="en-US" sz="1700" dirty="0">
+                <a:solidFill>
+                  <a:srgbClr val="A8202B"/>
+                </a:solidFill>
+                <a:latin typeface="Consolas" pitchFamily="34" charset="0"/>
+                <a:ea typeface="Consolas" pitchFamily="34" charset="-122"/>
+                <a:cs typeface="Consolas" pitchFamily="34" charset="-120"/>
+              </a:rPr>
+              <a:t>di xe may khong doi mu bao hiem bi phat bao nhieu tien</a:t>
+            </a:r>
+            <a:endParaRPr lang="en-US" sz="1700" dirty="0"/>
+          </a:p>
+        </p:txBody>
+      </p:sp>
+      <p:sp>
+        <p:nvSpPr>
+          <p:cNvPr id="20" name="Text 17"/>
+          <p:cNvSpPr txBox="1"/>
+          <p:nvPr/>
+        </p:nvSpPr>
+        <p:spPr>
+          <a:xfrm>
+            <a:off x="6598768" y="4709160"/>
+            <a:ext cx="4678528" cy="310896"/>
+          </a:xfrm>
+          <a:prstGeom prst="rect">
+            <a:avLst/>
+          </a:prstGeom>
+          <a:noFill/>
+          <a:ln/>
+        </p:spPr>
+        <p:txBody>
+          <a:bodyPr wrap="square" lIns="0" tIns="0" rIns="0" bIns="0" rtlCol="0" anchor="ctr"/>
+          <a:lstStyle/>
+          <a:p>
+            <a:pPr marL="0" indent="0">
+              <a:buNone/>
+            </a:pPr>
+            <a:r>
+              <a:rPr lang="en-US" sz="1500" b="1" dirty="0">
+                <a:solidFill>
+                  <a:srgbClr val="A8202B"/>
+                </a:solidFill>
+                <a:latin typeface="Calibri" pitchFamily="34" charset="0"/>
+                <a:ea typeface="Calibri" pitchFamily="34" charset="-122"/>
+                <a:cs typeface="Calibri" pitchFamily="34" charset="-120"/>
+              </a:rPr>
+              <a:t>Với máy, “phạt” và “phat” là hai chữ khác nhau</a:t>
+            </a:r>
+            <a:endParaRPr lang="en-US" sz="1500" dirty="0"/>
+          </a:p>
+        </p:txBody>
+      </p:sp>
+      <p:sp>
+        <p:nvSpPr>
+          <p:cNvPr id="21" name="Text 18"/>
+          <p:cNvSpPr txBox="1"/>
+          <p:nvPr/>
+        </p:nvSpPr>
+        <p:spPr>
+          <a:xfrm>
+            <a:off x="594360" y="5532120"/>
+            <a:ext cx="11002975" cy="365760"/>
+          </a:xfrm>
+          <a:prstGeom prst="rect">
+            <a:avLst/>
+          </a:prstGeom>
+          <a:noFill/>
+          <a:ln/>
+        </p:spPr>
+        <p:txBody>
+          <a:bodyPr wrap="square" lIns="0" tIns="0" rIns="0" bIns="0" rtlCol="0" anchor="ctr"/>
+          <a:lstStyle/>
+          <a:p>
+            <a:pPr marL="0" indent="0">
+              <a:buNone/>
+            </a:pPr>
+            <a:r>
+              <a:rPr lang="en-US" sz="1500" dirty="0">
+                <a:solidFill>
+                  <a:srgbClr val="46545F"/>
+                </a:solidFill>
+                <a:latin typeface="Calibri" pitchFamily="34" charset="0"/>
+                <a:ea typeface="Calibri" pitchFamily="34" charset="-122"/>
+                <a:cs typeface="Calibri" pitchFamily="34" charset="-120"/>
+              </a:rPr>
+              <a:t>Đầu vào: một câu hỏi tự nhiên.   Đầu ra: điều luật xếp hạng trong 61.425 điều của 3.271 văn bản, kèm từ đã khớp.</a:t>
+            </a:r>
+            <a:endParaRPr lang="en-US" sz="1500" dirty="0"/>
+          </a:p>
+        </p:txBody>
+      </p:sp>
+    </p:spTree>
+  </p:cSld>
+  <p:clrMapOvr>
+    <a:masterClrMapping/>
+  </p:clrMapOvr>
+</p:sld>
+</file>
+
+<file path=ppt/slides/slide4.xml><?xml version="1.0" encoding="utf-8"?>
 <p:sld xmlns:a="http://schemas.openxmlformats.org/drawingml/2006/main" xmlns:r="http://schemas.openxmlformats.org/officeDocument/2006/relationships" xmlns:p="http://schemas.openxmlformats.org/presentationml/2006/main">
   <p:cSld name="Slide 3">
     <p:bg>
@@ -10621,8 +12253,8 @@
         </p:nvSpPr>
         <p:spPr>
           <a:xfrm>
-            <a:off x="594360" y="329184"/>
-            <a:ext cx="5486400" cy="237744"/>
+            <a:off x="5193792" y="146304"/>
+            <a:ext cx="6400800" cy="292608"/>
           </a:xfrm>
           <a:prstGeom prst="rect">
             <a:avLst/>
@@ -10634,19 +12266,35 @@
           <a:bodyPr wrap="square" lIns="0" tIns="0" rIns="0" bIns="0" rtlCol="0" anchor="ctr"/>
           <a:lstStyle/>
           <a:p>
-            <a:pPr marL="0" indent="0">
-              <a:buNone/>
-            </a:pPr>
-            <a:r>
-              <a:rPr lang="en-US" sz="1100" kern="0" spc="100" dirty="0">
-                <a:solidFill>
-                  <a:srgbClr val="2C5F8A"/>
-                </a:solidFill>
-                <a:latin typeface="Consolas" pitchFamily="34" charset="0"/>
-                <a:ea typeface="Consolas" pitchFamily="34" charset="-122"/>
-                <a:cs typeface="Consolas" pitchFamily="34" charset="-120"/>
-              </a:rPr>
-              <a:t>NGHIÊN CỨU TRƯỚC  ·  03</a:t>
+            <a:pPr marL="0" indent="0" algn="r">
+              <a:buNone/>
+            </a:pPr>
+            <a:r>
+              <a:rPr sz="1400" b="0">
+                <a:solidFill>
+                  <a:srgbClr val="77858E"/>
+                </a:solidFill>
+                <a:latin typeface="Cambria"/>
+              </a:rPr>
+              <a:t>Phần 1</a:t>
+            </a:r>
+            <a:r>
+              <a:rPr sz="1400" b="0">
+                <a:solidFill>
+                  <a:srgbClr val="77858E"/>
+                </a:solidFill>
+                <a:latin typeface="Cambria"/>
+              </a:rPr>
+              <a:t>   |   </a:t>
+            </a:r>
+            <a:r>
+              <a:rPr sz="1500" b="0">
+                <a:solidFill>
+                  <a:srgbClr val="16222C"/>
+                </a:solidFill>
+                <a:latin typeface="Cambria"/>
+              </a:rPr>
+              <a:t>Nghiên cứu trước</a:t>
             </a:r>
             <a:endParaRPr lang="en-US" sz="1100" dirty="0"/>
           </a:p>
@@ -10766,7 +12414,7 @@
                 <a:ea typeface="Consolas" pitchFamily="34" charset="-122"/>
                 <a:cs typeface="Consolas" pitchFamily="34" charset="-120"/>
               </a:rPr>
-              <a:t>03 / 17</a:t>
+              <a:t>04 / 18</a:t>
             </a:r>
             <a:endParaRPr lang="en-US" sz="1000" dirty="0"/>
           </a:p>
@@ -12134,7 +13782,7 @@
 </p:sld>
 </file>
 
-<file path=ppt/slides/slide4.xml><?xml version="1.0" encoding="utf-8"?>
+<file path=ppt/slides/slide5.xml><?xml version="1.0" encoding="utf-8"?>
 <p:sld xmlns:a="http://schemas.openxmlformats.org/drawingml/2006/main" xmlns:r="http://schemas.openxmlformats.org/officeDocument/2006/relationships" xmlns:p="http://schemas.openxmlformats.org/presentationml/2006/main">
   <p:cSld name="Slide 4">
     <p:bg>
@@ -12167,8 +13815,8 @@
         </p:nvSpPr>
         <p:spPr>
           <a:xfrm>
-            <a:off x="594360" y="329184"/>
-            <a:ext cx="5486400" cy="237744"/>
+            <a:off x="5193792" y="146304"/>
+            <a:ext cx="6400800" cy="292608"/>
           </a:xfrm>
           <a:prstGeom prst="rect">
             <a:avLst/>
@@ -12180,19 +13828,35 @@
           <a:bodyPr wrap="square" lIns="0" tIns="0" rIns="0" bIns="0" rtlCol="0" anchor="ctr"/>
           <a:lstStyle/>
           <a:p>
-            <a:pPr marL="0" indent="0">
-              <a:buNone/>
-            </a:pPr>
-            <a:r>
-              <a:rPr lang="en-US" sz="1100" kern="0" spc="100" dirty="0">
-                <a:solidFill>
-                  <a:srgbClr val="2C5F8A"/>
-                </a:solidFill>
-                <a:latin typeface="Consolas" pitchFamily="34" charset="0"/>
-                <a:ea typeface="Consolas" pitchFamily="34" charset="-122"/>
-                <a:cs typeface="Consolas" pitchFamily="34" charset="-120"/>
-              </a:rPr>
-              <a:t>CÂU HỎI NGHIÊN CỨU  ·  04</a:t>
+            <a:pPr marL="0" indent="0" algn="r">
+              <a:buNone/>
+            </a:pPr>
+            <a:r>
+              <a:rPr sz="1400" b="0">
+                <a:solidFill>
+                  <a:srgbClr val="77858E"/>
+                </a:solidFill>
+                <a:latin typeface="Cambria"/>
+              </a:rPr>
+              <a:t>Phần 1</a:t>
+            </a:r>
+            <a:r>
+              <a:rPr sz="1400" b="0">
+                <a:solidFill>
+                  <a:srgbClr val="77858E"/>
+                </a:solidFill>
+                <a:latin typeface="Cambria"/>
+              </a:rPr>
+              <a:t>   |   </a:t>
+            </a:r>
+            <a:r>
+              <a:rPr sz="1500" b="0">
+                <a:solidFill>
+                  <a:srgbClr val="16222C"/>
+                </a:solidFill>
+                <a:latin typeface="Cambria"/>
+              </a:rPr>
+              <a:t>Câu hỏi nghiên cứu</a:t>
             </a:r>
             <a:endParaRPr lang="en-US" sz="1100" dirty="0"/>
           </a:p>
@@ -12312,7 +13976,7 @@
                 <a:ea typeface="Consolas" pitchFamily="34" charset="-122"/>
                 <a:cs typeface="Consolas" pitchFamily="34" charset="-120"/>
               </a:rPr>
-              <a:t>04 / 17</a:t>
+              <a:t>05 / 18</a:t>
             </a:r>
             <a:endParaRPr lang="en-US" sz="1000" dirty="0"/>
           </a:p>
@@ -13106,7 +14770,7 @@
 </p:sld>
 </file>
 
-<file path=ppt/slides/slide5.xml><?xml version="1.0" encoding="utf-8"?>
+<file path=ppt/slides/slide6.xml><?xml version="1.0" encoding="utf-8"?>
 <p:sld xmlns:a="http://schemas.openxmlformats.org/drawingml/2006/main" xmlns:r="http://schemas.openxmlformats.org/officeDocument/2006/relationships" xmlns:p="http://schemas.openxmlformats.org/presentationml/2006/main">
   <p:cSld name="Slide 5">
     <p:bg>
@@ -13139,8 +14803,8 @@
         </p:nvSpPr>
         <p:spPr>
           <a:xfrm>
-            <a:off x="594360" y="329184"/>
-            <a:ext cx="5486400" cy="237744"/>
+            <a:off x="5193792" y="146304"/>
+            <a:ext cx="6400800" cy="292608"/>
           </a:xfrm>
           <a:prstGeom prst="rect">
             <a:avLst/>
@@ -13152,19 +14816,35 @@
           <a:bodyPr wrap="square" lIns="0" tIns="0" rIns="0" bIns="0" rtlCol="0" anchor="ctr"/>
           <a:lstStyle/>
           <a:p>
-            <a:pPr marL="0" indent="0">
-              <a:buNone/>
-            </a:pPr>
-            <a:r>
-              <a:rPr lang="en-US" sz="1100" kern="0" spc="100" dirty="0">
-                <a:solidFill>
-                  <a:srgbClr val="2C5F8A"/>
-                </a:solidFill>
-                <a:latin typeface="Consolas" pitchFamily="34" charset="0"/>
-                <a:ea typeface="Consolas" pitchFamily="34" charset="-122"/>
-                <a:cs typeface="Consolas" pitchFamily="34" charset="-120"/>
-              </a:rPr>
-              <a:t>DỮ LIỆU  ·  05</a:t>
+            <a:pPr marL="0" indent="0" algn="r">
+              <a:buNone/>
+            </a:pPr>
+            <a:r>
+              <a:rPr sz="1400" b="0">
+                <a:solidFill>
+                  <a:srgbClr val="77858E"/>
+                </a:solidFill>
+                <a:latin typeface="Cambria"/>
+              </a:rPr>
+              <a:t>Phần 2</a:t>
+            </a:r>
+            <a:r>
+              <a:rPr sz="1400" b="0">
+                <a:solidFill>
+                  <a:srgbClr val="77858E"/>
+                </a:solidFill>
+                <a:latin typeface="Cambria"/>
+              </a:rPr>
+              <a:t>   |   </a:t>
+            </a:r>
+            <a:r>
+              <a:rPr sz="1500" b="0">
+                <a:solidFill>
+                  <a:srgbClr val="16222C"/>
+                </a:solidFill>
+                <a:latin typeface="Cambria"/>
+              </a:rPr>
+              <a:t>Dữ liệu</a:t>
             </a:r>
             <a:endParaRPr lang="en-US" sz="1100" dirty="0"/>
           </a:p>
@@ -13284,7 +14964,7 @@
                 <a:ea typeface="Consolas" pitchFamily="34" charset="-122"/>
                 <a:cs typeface="Consolas" pitchFamily="34" charset="-120"/>
               </a:rPr>
-              <a:t>05 / 17</a:t>
+              <a:t>06 / 18</a:t>
             </a:r>
             <a:endParaRPr lang="en-US" sz="1000" dirty="0"/>
           </a:p>
@@ -13665,7 +15345,7 @@
 </p:sld>
 </file>
 
-<file path=ppt/slides/slide6.xml><?xml version="1.0" encoding="utf-8"?>
+<file path=ppt/slides/slide7.xml><?xml version="1.0" encoding="utf-8"?>
 <p:sld xmlns:a="http://schemas.openxmlformats.org/drawingml/2006/main" xmlns:r="http://schemas.openxmlformats.org/officeDocument/2006/relationships" xmlns:p="http://schemas.openxmlformats.org/presentationml/2006/main">
   <p:cSld name="Slide 6">
     <p:bg>
@@ -13698,8 +15378,8 @@
         </p:nvSpPr>
         <p:spPr>
           <a:xfrm>
-            <a:off x="594360" y="329184"/>
-            <a:ext cx="5486400" cy="237744"/>
+            <a:off x="5193792" y="146304"/>
+            <a:ext cx="6400800" cy="292608"/>
           </a:xfrm>
           <a:prstGeom prst="rect">
             <a:avLst/>
@@ -13711,19 +15391,35 @@
           <a:bodyPr wrap="square" lIns="0" tIns="0" rIns="0" bIns="0" rtlCol="0" anchor="ctr"/>
           <a:lstStyle/>
           <a:p>
-            <a:pPr marL="0" indent="0">
-              <a:buNone/>
-            </a:pPr>
-            <a:r>
-              <a:rPr lang="en-US" sz="1100" kern="0" spc="100" dirty="0">
-                <a:solidFill>
-                  <a:srgbClr val="2C5F8A"/>
-                </a:solidFill>
-                <a:latin typeface="Consolas" pitchFamily="34" charset="0"/>
-                <a:ea typeface="Consolas" pitchFamily="34" charset="-122"/>
-                <a:cs typeface="Consolas" pitchFamily="34" charset="-120"/>
-              </a:rPr>
-              <a:t>RÒ RỈ DỮ LIỆU  ·  06</a:t>
+            <a:pPr marL="0" indent="0" algn="r">
+              <a:buNone/>
+            </a:pPr>
+            <a:r>
+              <a:rPr sz="1400" b="0">
+                <a:solidFill>
+                  <a:srgbClr val="77858E"/>
+                </a:solidFill>
+                <a:latin typeface="Cambria"/>
+              </a:rPr>
+              <a:t>Phần 2</a:t>
+            </a:r>
+            <a:r>
+              <a:rPr sz="1400" b="0">
+                <a:solidFill>
+                  <a:srgbClr val="77858E"/>
+                </a:solidFill>
+                <a:latin typeface="Cambria"/>
+              </a:rPr>
+              <a:t>   |   </a:t>
+            </a:r>
+            <a:r>
+              <a:rPr sz="1500" b="0">
+                <a:solidFill>
+                  <a:srgbClr val="16222C"/>
+                </a:solidFill>
+                <a:latin typeface="Cambria"/>
+              </a:rPr>
+              <a:t>Rò rỉ dữ liệu</a:t>
             </a:r>
             <a:endParaRPr lang="en-US" sz="1100" dirty="0"/>
           </a:p>
@@ -13843,7 +15539,7 @@
                 <a:ea typeface="Consolas" pitchFamily="34" charset="-122"/>
                 <a:cs typeface="Consolas" pitchFamily="34" charset="-120"/>
               </a:rPr>
-              <a:t>06 / 17</a:t>
+              <a:t>07 / 18</a:t>
             </a:r>
             <a:endParaRPr lang="en-US" sz="1000" dirty="0"/>
           </a:p>
@@ -13882,7 +15578,7 @@
                 <a:ea typeface="Cambria" pitchFamily="34" charset="-122"/>
                 <a:cs typeface="Cambria" pitchFamily="34" charset="-120"/>
               </a:rPr>
-              <a:t>24/24</a:t>
+              <a:t>07 / 18</a:t>
             </a:r>
             <a:endParaRPr lang="en-US" sz="8800" dirty="0"/>
           </a:p>
@@ -14897,7 +16593,7 @@
 </p:sld>
 </file>
 
-<file path=ppt/slides/slide7.xml><?xml version="1.0" encoding="utf-8"?>
+<file path=ppt/slides/slide8.xml><?xml version="1.0" encoding="utf-8"?>
 <p:sld xmlns:a="http://schemas.openxmlformats.org/drawingml/2006/main" xmlns:r="http://schemas.openxmlformats.org/officeDocument/2006/relationships" xmlns:p="http://schemas.openxmlformats.org/presentationml/2006/main">
   <p:cSld name="Slide 7">
     <p:bg>
@@ -14930,8 +16626,8 @@
         </p:nvSpPr>
         <p:spPr>
           <a:xfrm>
-            <a:off x="594360" y="329184"/>
-            <a:ext cx="5486400" cy="237744"/>
+            <a:off x="5193792" y="146304"/>
+            <a:ext cx="6400800" cy="292608"/>
           </a:xfrm>
           <a:prstGeom prst="rect">
             <a:avLst/>
@@ -14943,19 +16639,35 @@
           <a:bodyPr wrap="square" lIns="0" tIns="0" rIns="0" bIns="0" rtlCol="0" anchor="ctr"/>
           <a:lstStyle/>
           <a:p>
-            <a:pPr marL="0" indent="0">
-              <a:buNone/>
-            </a:pPr>
-            <a:r>
-              <a:rPr lang="en-US" sz="1100" kern="0" spc="100" dirty="0">
-                <a:solidFill>
-                  <a:srgbClr val="2C5F8A"/>
-                </a:solidFill>
-                <a:latin typeface="Consolas" pitchFamily="34" charset="0"/>
-                <a:ea typeface="Consolas" pitchFamily="34" charset="-122"/>
-                <a:cs typeface="Consolas" pitchFamily="34" charset="-120"/>
-              </a:rPr>
-              <a:t>RÒ RỈ DỮ LIỆU  ·  07</a:t>
+            <a:pPr marL="0" indent="0" algn="r">
+              <a:buNone/>
+            </a:pPr>
+            <a:r>
+              <a:rPr sz="1400" b="0">
+                <a:solidFill>
+                  <a:srgbClr val="77858E"/>
+                </a:solidFill>
+                <a:latin typeface="Cambria"/>
+              </a:rPr>
+              <a:t>Phần 2</a:t>
+            </a:r>
+            <a:r>
+              <a:rPr sz="1400" b="0">
+                <a:solidFill>
+                  <a:srgbClr val="77858E"/>
+                </a:solidFill>
+                <a:latin typeface="Cambria"/>
+              </a:rPr>
+              <a:t>   |   </a:t>
+            </a:r>
+            <a:r>
+              <a:rPr sz="1500" b="0">
+                <a:solidFill>
+                  <a:srgbClr val="16222C"/>
+                </a:solidFill>
+                <a:latin typeface="Cambria"/>
+              </a:rPr>
+              <a:t>Rò rỉ dữ liệu</a:t>
             </a:r>
             <a:endParaRPr lang="en-US" sz="1100" dirty="0"/>
           </a:p>
@@ -15075,7 +16787,7 @@
                 <a:ea typeface="Consolas" pitchFamily="34" charset="-122"/>
                 <a:cs typeface="Consolas" pitchFamily="34" charset="-120"/>
               </a:rPr>
-              <a:t>07 / 17</a:t>
+              <a:t>08 / 18</a:t>
             </a:r>
             <a:endParaRPr lang="en-US" sz="1000" dirty="0"/>
           </a:p>
@@ -15815,7 +17527,7 @@
 </p:sld>
 </file>
 
-<file path=ppt/slides/slide8.xml><?xml version="1.0" encoding="utf-8"?>
+<file path=ppt/slides/slide9.xml><?xml version="1.0" encoding="utf-8"?>
 <p:sld xmlns:a="http://schemas.openxmlformats.org/drawingml/2006/main" xmlns:r="http://schemas.openxmlformats.org/officeDocument/2006/relationships" xmlns:p="http://schemas.openxmlformats.org/presentationml/2006/main">
   <p:cSld name="Slide 8">
     <p:bg>
@@ -15848,8 +17560,8 @@
         </p:nvSpPr>
         <p:spPr>
           <a:xfrm>
-            <a:off x="594360" y="329184"/>
-            <a:ext cx="5486400" cy="237744"/>
+            <a:off x="5193792" y="146304"/>
+            <a:ext cx="6400800" cy="292608"/>
           </a:xfrm>
           <a:prstGeom prst="rect">
             <a:avLst/>
@@ -15861,19 +17573,35 @@
           <a:bodyPr wrap="square" lIns="0" tIns="0" rIns="0" bIns="0" rtlCol="0" anchor="ctr"/>
           <a:lstStyle/>
           <a:p>
-            <a:pPr marL="0" indent="0">
-              <a:buNone/>
-            </a:pPr>
-            <a:r>
-              <a:rPr lang="en-US" sz="1100" kern="0" spc="100" dirty="0">
-                <a:solidFill>
-                  <a:srgbClr val="2C5F8A"/>
-                </a:solidFill>
-                <a:latin typeface="Consolas" pitchFamily="34" charset="0"/>
-                <a:ea typeface="Consolas" pitchFamily="34" charset="-122"/>
-                <a:cs typeface="Consolas" pitchFamily="34" charset="-120"/>
-              </a:rPr>
-              <a:t>PHƯƠNG PHÁP  ·  08</a:t>
+            <a:pPr marL="0" indent="0" algn="r">
+              <a:buNone/>
+            </a:pPr>
+            <a:r>
+              <a:rPr sz="1400" b="0">
+                <a:solidFill>
+                  <a:srgbClr val="77858E"/>
+                </a:solidFill>
+                <a:latin typeface="Cambria"/>
+              </a:rPr>
+              <a:t>Phần 3</a:t>
+            </a:r>
+            <a:r>
+              <a:rPr sz="1400" b="0">
+                <a:solidFill>
+                  <a:srgbClr val="77858E"/>
+                </a:solidFill>
+                <a:latin typeface="Cambria"/>
+              </a:rPr>
+              <a:t>   |   </a:t>
+            </a:r>
+            <a:r>
+              <a:rPr sz="1500" b="0">
+                <a:solidFill>
+                  <a:srgbClr val="16222C"/>
+                </a:solidFill>
+                <a:latin typeface="Cambria"/>
+              </a:rPr>
+              <a:t>Phương pháp</a:t>
             </a:r>
             <a:endParaRPr lang="en-US" sz="1100" dirty="0"/>
           </a:p>
@@ -15993,7 +17721,7 @@
                 <a:ea typeface="Consolas" pitchFamily="34" charset="-122"/>
                 <a:cs typeface="Consolas" pitchFamily="34" charset="-120"/>
               </a:rPr>
-              <a:t>08 / 17</a:t>
+              <a:t>09 / 18</a:t>
             </a:r>
             <a:endParaRPr lang="en-US" sz="1000" dirty="0"/>
           </a:p>
@@ -17076,426 +18804,6 @@
                 <a:cs typeface="Calibri" pitchFamily="34" charset="-120"/>
               </a:rPr>
               <a:t>Tập test chỉ chạy một lần.</a:t>
-            </a:r>
-            <a:endParaRPr lang="en-US" sz="1300" dirty="0"/>
-          </a:p>
-        </p:txBody>
-      </p:sp>
-    </p:spTree>
-  </p:cSld>
-  <p:clrMapOvr>
-    <a:masterClrMapping/>
-  </p:clrMapOvr>
-</p:sld>
-</file>
-
-<file path=ppt/slides/slide9.xml><?xml version="1.0" encoding="utf-8"?>
-<p:sld xmlns:a="http://schemas.openxmlformats.org/drawingml/2006/main" xmlns:r="http://schemas.openxmlformats.org/officeDocument/2006/relationships" xmlns:p="http://schemas.openxmlformats.org/presentationml/2006/main">
-  <p:cSld name="Slide 9">
-    <p:bg>
-      <p:bgPr>
-        <a:solidFill>
-          <a:srgbClr val="FFFFFF"/>
-        </a:solidFill>
-        <a:effectLst/>
-      </p:bgPr>
-    </p:bg>
-    <p:spTree>
-      <p:nvGrpSpPr>
-        <p:cNvPr id="1" name=""/>
-        <p:cNvGrpSpPr/>
-        <p:nvPr/>
-      </p:nvGrpSpPr>
-      <p:grpSpPr>
-        <a:xfrm>
-          <a:off x="0" y="0"/>
-          <a:ext cx="0" cy="0"/>
-          <a:chOff x="0" y="0"/>
-          <a:chExt cx="0" cy="0"/>
-        </a:xfrm>
-      </p:grpSpPr>
-      <p:sp>
-        <p:nvSpPr>
-          <p:cNvPr id="2" name="Text 0"/>
-          <p:cNvSpPr txBox="1"/>
-          <p:nvPr/>
-        </p:nvSpPr>
-        <p:spPr>
-          <a:xfrm>
-            <a:off x="594360" y="329184"/>
-            <a:ext cx="5486400" cy="237744"/>
-          </a:xfrm>
-          <a:prstGeom prst="rect">
-            <a:avLst/>
-          </a:prstGeom>
-          <a:noFill/>
-          <a:ln/>
-        </p:spPr>
-        <p:txBody>
-          <a:bodyPr wrap="square" lIns="0" tIns="0" rIns="0" bIns="0" rtlCol="0" anchor="ctr"/>
-          <a:lstStyle/>
-          <a:p>
-            <a:pPr marL="0" indent="0">
-              <a:buNone/>
-            </a:pPr>
-            <a:r>
-              <a:rPr lang="en-US" sz="1100" kern="0" spc="100" dirty="0">
-                <a:solidFill>
-                  <a:srgbClr val="2C5F8A"/>
-                </a:solidFill>
-                <a:latin typeface="Consolas" pitchFamily="34" charset="0"/>
-                <a:ea typeface="Consolas" pitchFamily="34" charset="-122"/>
-                <a:cs typeface="Consolas" pitchFamily="34" charset="-120"/>
-              </a:rPr>
-              <a:t>PHƯƠNG PHÁP  ·  09</a:t>
-            </a:r>
-            <a:endParaRPr lang="en-US" sz="1100" dirty="0"/>
-          </a:p>
-        </p:txBody>
-      </p:sp>
-      <p:sp>
-        <p:nvSpPr>
-          <p:cNvPr id="3" name="Text 1"/>
-          <p:cNvSpPr txBox="1"/>
-          <p:nvPr/>
-        </p:nvSpPr>
-        <p:spPr>
-          <a:xfrm>
-            <a:off x="594360" y="585216"/>
-            <a:ext cx="11002975" cy="868680"/>
-          </a:xfrm>
-          <a:prstGeom prst="rect">
-            <a:avLst/>
-          </a:prstGeom>
-          <a:noFill/>
-          <a:ln/>
-        </p:spPr>
-        <p:txBody>
-          <a:bodyPr wrap="square" lIns="0" tIns="0" rIns="0" bIns="0" rtlCol="0" anchor="t"/>
-          <a:lstStyle/>
-          <a:p>
-            <a:pPr marL="0" indent="0">
-              <a:lnSpc>
-                <a:spcPct val="95000"/>
-              </a:lnSpc>
-              <a:buNone/>
-            </a:pPr>
-            <a:r>
-              <a:rPr lang="en-US" sz="2800" b="1" dirty="0">
-                <a:solidFill>
-                  <a:srgbClr val="16222C"/>
-                </a:solidFill>
-                <a:latin typeface="Cambria" pitchFamily="34" charset="0"/>
-                <a:ea typeface="Cambria" pitchFamily="34" charset="-122"/>
-                <a:cs typeface="Cambria" pitchFamily="34" charset="-120"/>
-              </a:rPr>
-              <a:t>61% điều luật dài hơn giới hạn của mô hình, nên phải chia đoạn</a:t>
-            </a:r>
-            <a:endParaRPr lang="en-US" sz="2800" dirty="0"/>
-          </a:p>
-        </p:txBody>
-      </p:sp>
-      <p:sp>
-        <p:nvSpPr>
-          <p:cNvPr id="4" name="Text 2"/>
-          <p:cNvSpPr txBox="1"/>
-          <p:nvPr/>
-        </p:nvSpPr>
-        <p:spPr>
-          <a:xfrm>
-            <a:off x="594360" y="6473952"/>
-            <a:ext cx="7315200" cy="219456"/>
-          </a:xfrm>
-          <a:prstGeom prst="rect">
-            <a:avLst/>
-          </a:prstGeom>
-          <a:noFill/>
-          <a:ln/>
-        </p:spPr>
-        <p:txBody>
-          <a:bodyPr wrap="square" lIns="0" tIns="0" rIns="0" bIns="0" rtlCol="0" anchor="ctr"/>
-          <a:lstStyle/>
-          <a:p>
-            <a:pPr marL="0" indent="0">
-              <a:buNone/>
-            </a:pPr>
-            <a:r>
-              <a:rPr lang="en-US" sz="1000" dirty="0">
-                <a:solidFill>
-                  <a:srgbClr val="77858E"/>
-                </a:solidFill>
-                <a:latin typeface="Calibri" pitchFamily="34" charset="0"/>
-                <a:ea typeface="Calibri" pitchFamily="34" charset="-122"/>
-                <a:cs typeface="Calibri" pitchFamily="34" charset="-120"/>
-              </a:rPr>
-              <a:t>Nhóm 08  ·  Tìm kiếm điều luật tiếng Việt cho câu hỏi gõ thiếu dấu</a:t>
-            </a:r>
-            <a:endParaRPr lang="en-US" sz="1000" dirty="0"/>
-          </a:p>
-        </p:txBody>
-      </p:sp>
-      <p:sp>
-        <p:nvSpPr>
-          <p:cNvPr id="5" name="Text 3"/>
-          <p:cNvSpPr txBox="1"/>
-          <p:nvPr/>
-        </p:nvSpPr>
-        <p:spPr>
-          <a:xfrm>
-            <a:off x="10225735" y="6473952"/>
-            <a:ext cx="1371600" cy="219456"/>
-          </a:xfrm>
-          <a:prstGeom prst="rect">
-            <a:avLst/>
-          </a:prstGeom>
-          <a:noFill/>
-          <a:ln/>
-        </p:spPr>
-        <p:txBody>
-          <a:bodyPr wrap="square" lIns="0" tIns="0" rIns="0" bIns="0" rtlCol="0" anchor="ctr"/>
-          <a:lstStyle/>
-          <a:p>
-            <a:pPr marL="0" indent="0" algn="r">
-              <a:buNone/>
-            </a:pPr>
-            <a:r>
-              <a:rPr lang="en-US" sz="1000" dirty="0">
-                <a:solidFill>
-                  <a:srgbClr val="77858E"/>
-                </a:solidFill>
-                <a:latin typeface="Consolas" pitchFamily="34" charset="0"/>
-                <a:ea typeface="Consolas" pitchFamily="34" charset="-122"/>
-                <a:cs typeface="Consolas" pitchFamily="34" charset="-120"/>
-              </a:rPr>
-              <a:t>09 / 17</a:t>
-            </a:r>
-            <a:endParaRPr lang="en-US" sz="1000" dirty="0"/>
-          </a:p>
-        </p:txBody>
-      </p:sp>
-      <p:graphicFrame>
-        <p:nvGraphicFramePr>
-          <p:cNvPr id="7" name="Chart 0"/>
-          <p:cNvGraphicFramePr/>
-          <p:nvPr/>
-        </p:nvGraphicFramePr>
-        <p:xfrm>
-          <a:off x="594360" y="1645920"/>
-          <a:ext cx="7498080" cy="4343400"/>
-        </p:xfrm>
-        <a:graphic>
-          <a:graphicData uri="http://schemas.openxmlformats.org/drawingml/2006/chart">
-            <c:chart xmlns:c="http://schemas.openxmlformats.org/drawingml/2006/chart" xmlns:r="http://schemas.openxmlformats.org/officeDocument/2006/relationships" r:id="rId3"/>
-          </a:graphicData>
-        </a:graphic>
-      </p:graphicFrame>
-      <p:sp>
-        <p:nvSpPr>
-          <p:cNvPr id="8" name="Text 4"/>
-          <p:cNvSpPr txBox="1"/>
-          <p:nvPr/>
-        </p:nvSpPr>
-        <p:spPr>
-          <a:xfrm>
-            <a:off x="8503920" y="1828800"/>
-            <a:ext cx="3093415" cy="731520"/>
-          </a:xfrm>
-          <a:prstGeom prst="rect">
-            <a:avLst/>
-          </a:prstGeom>
-          <a:noFill/>
-          <a:ln/>
-        </p:spPr>
-        <p:txBody>
-          <a:bodyPr wrap="square" lIns="0" tIns="0" rIns="0" bIns="0" rtlCol="0" anchor="ctr"/>
-          <a:lstStyle/>
-          <a:p>
-            <a:pPr marL="0" indent="0">
-              <a:buNone/>
-            </a:pPr>
-            <a:r>
-              <a:rPr lang="en-US" sz="4800" b="1" dirty="0">
-                <a:solidFill>
-                  <a:srgbClr val="A8202B"/>
-                </a:solidFill>
-                <a:latin typeface="Cambria" pitchFamily="34" charset="0"/>
-                <a:ea typeface="Cambria" pitchFamily="34" charset="-122"/>
-                <a:cs typeface="Cambria" pitchFamily="34" charset="-120"/>
-              </a:rPr>
-              <a:t>61,1%</a:t>
-            </a:r>
-            <a:endParaRPr lang="en-US" sz="4800" dirty="0"/>
-          </a:p>
-        </p:txBody>
-      </p:sp>
-      <p:sp>
-        <p:nvSpPr>
-          <p:cNvPr id="9" name="Text 5"/>
-          <p:cNvSpPr txBox="1"/>
-          <p:nvPr/>
-        </p:nvSpPr>
-        <p:spPr>
-          <a:xfrm>
-            <a:off x="8503920" y="2615184"/>
-            <a:ext cx="3093415" cy="566928"/>
-          </a:xfrm>
-          <a:prstGeom prst="rect">
-            <a:avLst/>
-          </a:prstGeom>
-          <a:noFill/>
-          <a:ln/>
-        </p:spPr>
-        <p:txBody>
-          <a:bodyPr wrap="square" lIns="0" tIns="0" rIns="0" bIns="0" rtlCol="0" anchor="t"/>
-          <a:lstStyle/>
-          <a:p>
-            <a:pPr marL="0" indent="0">
-              <a:buNone/>
-            </a:pPr>
-            <a:r>
-              <a:rPr lang="en-US" sz="1300" dirty="0">
-                <a:solidFill>
-                  <a:srgbClr val="46545F"/>
-                </a:solidFill>
-                <a:latin typeface="Calibri" pitchFamily="34" charset="0"/>
-                <a:ea typeface="Calibri" pitchFamily="34" charset="-122"/>
-                <a:cs typeface="Calibri" pitchFamily="34" charset="-120"/>
-              </a:rPr>
-              <a:t>điều luật dài hơn 256 token (khoảng 140 từ)</a:t>
-            </a:r>
-            <a:endParaRPr lang="en-US" sz="1300" dirty="0"/>
-          </a:p>
-        </p:txBody>
-      </p:sp>
-      <p:sp>
-        <p:nvSpPr>
-          <p:cNvPr id="10" name="Text 6"/>
-          <p:cNvSpPr txBox="1"/>
-          <p:nvPr/>
-        </p:nvSpPr>
-        <p:spPr>
-          <a:xfrm>
-            <a:off x="8503920" y="3429000"/>
-            <a:ext cx="3093415" cy="1234440"/>
-          </a:xfrm>
-          <a:prstGeom prst="rect">
-            <a:avLst/>
-          </a:prstGeom>
-          <a:noFill/>
-          <a:ln/>
-        </p:spPr>
-        <p:txBody>
-          <a:bodyPr wrap="square" lIns="0" tIns="0" rIns="0" bIns="0" rtlCol="0" anchor="t"/>
-          <a:lstStyle/>
-          <a:p>
-            <a:pPr marL="0" indent="0">
-              <a:buNone/>
-            </a:pPr>
-            <a:r>
-              <a:rPr lang="en-US" sz="2400" b="1" dirty="0">
-                <a:solidFill>
-                  <a:srgbClr val="16222C"/>
-                </a:solidFill>
-                <a:latin typeface="Cambria" pitchFamily="34" charset="0"/>
-                <a:ea typeface="Cambria" pitchFamily="34" charset="-122"/>
-                <a:cs typeface="Cambria" pitchFamily="34" charset="-120"/>
-              </a:rPr>
-              <a:t>61.425</a:t>
-            </a:r>
-            <a:r>
-              <a:rPr lang="en-US" sz="2400" dirty="0">
-                <a:solidFill>
-                  <a:srgbClr val="16222C"/>
-                </a:solidFill>
-                <a:latin typeface="Cambria" pitchFamily="34" charset="0"/>
-                <a:ea typeface="Cambria" pitchFamily="34" charset="-122"/>
-                <a:cs typeface="Cambria" pitchFamily="34" charset="-120"/>
-              </a:rPr>
-              <a:t> điều</a:t>
-            </a:r>
-            <a:endParaRPr lang="en-US" sz="2400" dirty="0"/>
-          </a:p>
-          <a:p>
-            <a:pPr marL="0" indent="0">
-              <a:buNone/>
-            </a:pPr>
-            <a:r>
-              <a:rPr lang="en-US" sz="2400" dirty="0">
-                <a:solidFill>
-                  <a:srgbClr val="77858E"/>
-                </a:solidFill>
-                <a:latin typeface="Cambria" pitchFamily="34" charset="0"/>
-                <a:ea typeface="Cambria" pitchFamily="34" charset="-122"/>
-                <a:cs typeface="Cambria" pitchFamily="34" charset="-120"/>
-              </a:rPr>
-              <a:t>↓</a:t>
-            </a:r>
-            <a:endParaRPr lang="en-US" sz="2400" dirty="0"/>
-          </a:p>
-          <a:p>
-            <a:pPr marL="0" indent="0">
-              <a:buNone/>
-            </a:pPr>
-            <a:r>
-              <a:rPr lang="en-US" sz="2400" b="1" dirty="0">
-                <a:solidFill>
-                  <a:srgbClr val="16222C"/>
-                </a:solidFill>
-                <a:latin typeface="Cambria" pitchFamily="34" charset="0"/>
-                <a:ea typeface="Cambria" pitchFamily="34" charset="-122"/>
-                <a:cs typeface="Cambria" pitchFamily="34" charset="-120"/>
-              </a:rPr>
-              <a:t>154.176</a:t>
-            </a:r>
-            <a:r>
-              <a:rPr lang="en-US" sz="2400" dirty="0">
-                <a:solidFill>
-                  <a:srgbClr val="16222C"/>
-                </a:solidFill>
-                <a:latin typeface="Cambria" pitchFamily="34" charset="0"/>
-                <a:ea typeface="Cambria" pitchFamily="34" charset="-122"/>
-                <a:cs typeface="Cambria" pitchFamily="34" charset="-120"/>
-              </a:rPr>
-              <a:t> đoạn</a:t>
-            </a:r>
-            <a:endParaRPr lang="en-US" sz="2400" dirty="0"/>
-          </a:p>
-        </p:txBody>
-      </p:sp>
-      <p:sp>
-        <p:nvSpPr>
-          <p:cNvPr id="11" name="Text 7"/>
-          <p:cNvSpPr txBox="1"/>
-          <p:nvPr/>
-        </p:nvSpPr>
-        <p:spPr>
-          <a:xfrm>
-            <a:off x="8503920" y="4754880"/>
-            <a:ext cx="3093415" cy="822960"/>
-          </a:xfrm>
-          <a:prstGeom prst="rect">
-            <a:avLst/>
-          </a:prstGeom>
-          <a:noFill/>
-          <a:ln/>
-        </p:spPr>
-        <p:txBody>
-          <a:bodyPr wrap="square" lIns="0" tIns="0" rIns="0" bIns="0" rtlCol="0" anchor="t"/>
-          <a:lstStyle/>
-          <a:p>
-            <a:pPr marL="0" indent="0">
-              <a:buNone/>
-            </a:pPr>
-            <a:r>
-              <a:rPr lang="en-US" sz="1300" dirty="0" err="1">
-                <a:solidFill>
-                  <a:srgbClr val="46545F"/>
-                </a:solidFill>
-                <a:latin typeface="Calibri" pitchFamily="34" charset="0"/>
-                <a:ea typeface="Calibri" pitchFamily="34" charset="-122"/>
-                <a:cs typeface="Calibri" pitchFamily="34" charset="-120"/>
-              </a:rPr>
-              <a:t>Cắt theo từng khoản, khoản quá dài thì chia nhỏ tiếp. Đoạn nào cũng kèm tên điều.</a:t>
             </a:r>
             <a:endParaRPr lang="en-US" sz="1300" dirty="0"/>
           </a:p>

</xml_diff>

<commit_message>
slides: doi ten phan 1 thanh Ly do chon de tai
</commit_message>
<xml_diff>
--- a/docs/slides/Nhom08_XLNNTN_BaoCao.pptx
+++ b/docs/slides/Nhom08_XLNNTN_BaoCao.pptx
@@ -5,27 +5,27 @@
     <p:sldMasterId id="2147483648" r:id="rId1"/>
   </p:sldMasterIdLst>
   <p:notesMasterIdLst>
-    <p:notesMasterId r:id="rId18"/>
+    <p:notesMasterId r:id="rId20"/>
   </p:notesMasterIdLst>
   <p:sldIdLst>
     <p:sldId id="256" r:id="rId2"/>
-    <p:sldId id="273" r:id="rId24"/>
-    <p:sldId id="257" r:id="rId3"/>
-    <p:sldId id="258" r:id="rId4"/>
-    <p:sldId id="259" r:id="rId5"/>
-    <p:sldId id="260" r:id="rId6"/>
-    <p:sldId id="261" r:id="rId7"/>
-    <p:sldId id="262" r:id="rId8"/>
-    <p:sldId id="263" r:id="rId9"/>
-    <p:sldId id="264" r:id="rId10"/>
-    <p:sldId id="265" r:id="rId11"/>
-    <p:sldId id="266" r:id="rId12"/>
-    <p:sldId id="267" r:id="rId13"/>
-    <p:sldId id="268" r:id="rId14"/>
-    <p:sldId id="269" r:id="rId15"/>
-    <p:sldId id="270" r:id="rId16"/>
-    <p:sldId id="271" r:id="rId17"/>
-    <p:sldId id="272" r:id="rId23"/>
+    <p:sldId id="273" r:id="rId3"/>
+    <p:sldId id="257" r:id="rId4"/>
+    <p:sldId id="258" r:id="rId5"/>
+    <p:sldId id="259" r:id="rId6"/>
+    <p:sldId id="260" r:id="rId7"/>
+    <p:sldId id="261" r:id="rId8"/>
+    <p:sldId id="262" r:id="rId9"/>
+    <p:sldId id="263" r:id="rId10"/>
+    <p:sldId id="264" r:id="rId11"/>
+    <p:sldId id="265" r:id="rId12"/>
+    <p:sldId id="266" r:id="rId13"/>
+    <p:sldId id="267" r:id="rId14"/>
+    <p:sldId id="268" r:id="rId15"/>
+    <p:sldId id="269" r:id="rId16"/>
+    <p:sldId id="270" r:id="rId17"/>
+    <p:sldId id="271" r:id="rId18"/>
+    <p:sldId id="272" r:id="rId19"/>
   </p:sldIdLst>
   <p:sldSz cx="12192000" cy="6858000"/>
   <p:notesSz cx="6858000" cy="12192000"/>
@@ -2996,13 +2996,9 @@
           <a:p>
             <a:r>
               <a:rPr lang="en-US" dirty="0"/>
-              <a:t>Lê Thị Tuấn Anh  ·  khoảng 45 giây
-Đến câu hỏi thứ nhất. Trên 788 câu test có dấu, Recall@10 của BM25 là 85,22, ngữ nghĩa 97,21, hợp nhất 97,72 phần trăm.
-Hợp nhất hơn ngữ nghĩa 0,51 điểm, đếm ra chỉ 4 câu. Có cải thiện nhưng rất nhỏ, và mỗi cấu hình nhóm chỉ chạy một lần nên không dám nói là đáng kể. Nhóm cũng thử một cách ghép khác là RRF, chỉ dựa vào thứ hạng, thì ở tỷ lệ đúng hạng 1 còn kém cả mô hình ngữ nghĩa dùng một mình. Em xin chuyển cho bạn Thư.
-Nếu thầy hỏi: bkai điểm cao hơn, sao không dùng?
-bkai đạt 97,46 nhưng đã học tập test, như slide 7, nên không so với các hệ sạch.
-Nếu thầy hỏi: F2 sao thấp?
-Nhóm cố định lấy 10 kết quả nên precision cao nhất chỉ 0,1. Zalo cho trả về số kết quả tùy ý, nên không so với bảng xếp hạng được.</a:t>
+              <a:t>Lê Thị Tuấn Anh  ·  khoảng 35 giây
+Vì sao phải chia đoạn? Mô hình chỉ đọc được 256 token, khoảng 140 chữ. Phần màu đỏ là các điều dài hơn thế, chiếm 61,1 phần trăm. Cắt cụt thì mất phần đuôi, mà đuôi điều luật hay là mức phạt và các ngoại lệ.
+Nên nhóm cắt mỗi điều ra theo từng khoản. Khoản nào vẫn dài quá thì chia nhỏ thêm. Đoạn nào cũng ghi tên điều ở đầu, để mô hình biết đoạn đó đang nói về chuyện gì. Cắt xong, 61.425 điều thành 154.176 đoạn.</a:t>
             </a:r>
           </a:p>
         </p:txBody>
@@ -3089,11 +3085,13 @@
           <a:p>
             <a:r>
               <a:rPr lang="en-US" dirty="0"/>
-              <a:t>Đoàn Mậu Thiên Thư  ·  khoảng 40 giây
-Dạ. Vì sao hợp nhất giúp ít như vậy? Đối chiếu từng câu thì 669 câu cả hai nhánh đều tìm đúng, 98 câu chỉ ngữ nghĩa đúng, còn BM25 đúng mà ngữ nghĩa sai thì chỉ có 3 câu.
-Vậy có bỏ BM25 không? Nhóm vẫn giữ, vì nó nhanh hơn khoảng 700 lần, chỉ mục nhỏ hơn gần mười lần, và chỉ ra được từ nào đã khớp để người dùng kiểm lại. Ở phần sau BM25 còn có vai trò khác.
-Nếu thầy hỏi: Hệ vẫn sai ở những câu nào?
-Hệ hợp nhất sai 17 câu, nhóm đọc tay cả 17: 10 ca thiếu ngữ cảnh pháp lý như câu nướng bắp, 5 ca nhiều điều cùng đúng mà nhãn ghi một, 2 ca nhãn đáng ngờ.</a:t>
+              <a:t>Lê Thị Tuấn Anh  ·  khoảng 45 giây
+Đến câu hỏi thứ nhất. Trên 788 câu test có dấu, Recall@10 của BM25 là 85,22, ngữ nghĩa 97,21, hợp nhất 97,72 phần trăm.
+Hợp nhất hơn ngữ nghĩa 0,51 điểm, đếm ra chỉ 4 câu. Có cải thiện nhưng rất nhỏ, và mỗi cấu hình nhóm chỉ chạy một lần nên không dám nói là đáng kể. Nhóm cũng thử một cách ghép khác là RRF, chỉ dựa vào thứ hạng, thì ở tỷ lệ đúng hạng 1 còn kém cả mô hình ngữ nghĩa dùng một mình. Em xin chuyển cho bạn Thư.
+Nếu thầy hỏi: bkai điểm cao hơn, sao không dùng?
+bkai đạt 97,46 nhưng đã học tập test, như slide 7, nên không so với các hệ sạch.
+Nếu thầy hỏi: F2 sao thấp?
+Nhóm cố định lấy 10 kết quả nên precision cao nhất chỉ 0,1. Zalo cho trả về số kết quả tùy ý, nên không so với bảng xếp hạng được.</a:t>
             </a:r>
           </a:p>
         </p:txBody>
@@ -3180,13 +3178,11 @@
           <a:p>
             <a:r>
               <a:rPr lang="en-US" dirty="0"/>
-              <a:t>Đoàn Mậu Thiên Thư  ·  khoảng 45 giây
-Câu hỏi thứ hai. Nhóm lấy đúng 788 câu test đó, bỏ hết dấu bằng máy, giữ nguyên nhãn rồi chạy lại. Mô hình ngữ nghĩa từ 97,21 rơi xuống 12,44. BM25 còn 6,22, hợp nhất cũng chỉ 14,47. Gần như không dùng được.
-BM25 hỏng vì phat và phạt không khớp nhau. Còn mô hình ngữ nghĩa, nhóm đoán là do nó học chủ yếu văn bản có dấu, cái này chưa kiểm chứng. Nếu bỏ dấu luôn cả kho luật rồi tìm bằng BM25 thì lên lại 74,30, nhưng vẫn còn xa.
-Nếu thầy hỏi: Câu không dấu do máy tạo, có giống người gõ thật không?
-Chưa giống hẳn: người thật còn gõ tắt, sai chính tả. Nhóm chọn cách này vì giữ nguyên được nhãn nên đo sạch. Đây là giới hạn lớn nhất.
-Nếu thầy hỏi: BM25 bỏ dấu giảm là do bỏ dấu hay do đổi cách tách từ?
-Cả hai. Đo riêng trên val: đổi cách tách từ mất 0,047, bỏ dấu mất thêm 0,137.</a:t>
+              <a:t>Đoàn Mậu Thiên Thư  ·  khoảng 40 giây
+Dạ. Vì sao hợp nhất giúp ít như vậy? Đối chiếu từng câu thì 669 câu cả hai nhánh đều tìm đúng, 98 câu chỉ ngữ nghĩa đúng, còn BM25 đúng mà ngữ nghĩa sai thì chỉ có 3 câu.
+Vậy có bỏ BM25 không? Nhóm vẫn giữ, vì nó nhanh hơn khoảng 700 lần, chỉ mục nhỏ hơn gần mười lần, và chỉ ra được từ nào đã khớp để người dùng kiểm lại. Ở phần sau BM25 còn có vai trò khác.
+Nếu thầy hỏi: Hệ vẫn sai ở những câu nào?
+Hệ hợp nhất sai 17 câu, nhóm đọc tay cả 17: 10 ca thiếu ngữ cảnh pháp lý như câu nướng bắp, 5 ca nhiều điều cùng đúng mà nhãn ghi một, 2 ca nhãn đáng ngờ.</a:t>
             </a:r>
           </a:p>
         </p:txBody>
@@ -3274,10 +3270,12 @@
             <a:r>
               <a:rPr lang="en-US" dirty="0"/>
               <a:t>Đoàn Mậu Thiên Thư  ·  khoảng 45 giây
-Cách nhóm sửa là phục hồi dấu trước khi tìm. Nhóm đếm các cặp âm tiết đi liền nhau trong 18,6 triệu âm tiết của chính kho luật. Mỗi âm tiết không dấu có vài ứng viên, như nghi có thể là nghỉ, nghị, nghĩ, rồi thuật toán Viterbi chọn chuỗi có xác suất cao nhất.
-Kết quả đúng 98,45 phần trăm âm tiết, mỗi câu chưa tới một mili giây, học xong trong 15 giây trên CPU. Hệ từ 14,47 lên 96,70, chỉ kém câu có dấu 1,02 điểm.
-Nếu thầy hỏi: Sao không dùng mô hình phục hồi dấu có sẵn hoặc LLM?
-Nhóm chưa so trên cùng bộ dữ liệu nên không nói hơn kém. Bigram có lợi là không phải tải thêm mô hình, chạy trên CPU, và học đúng từ vựng luật.</a:t>
+Câu hỏi thứ hai. Nhóm lấy đúng 788 câu test đó, bỏ hết dấu bằng máy, giữ nguyên nhãn rồi chạy lại. Mô hình ngữ nghĩa từ 97,21 rơi xuống 12,44. BM25 còn 6,22, hợp nhất cũng chỉ 14,47. Gần như không dùng được.
+BM25 hỏng vì phat và phạt không khớp nhau. Còn mô hình ngữ nghĩa, nhóm đoán là do nó học chủ yếu văn bản có dấu, cái này chưa kiểm chứng. Nếu bỏ dấu luôn cả kho luật rồi tìm bằng BM25 thì lên lại 74,30, nhưng vẫn còn xa.
+Nếu thầy hỏi: Câu không dấu do máy tạo, có giống người gõ thật không?
+Chưa giống hẳn: người thật còn gõ tắt, sai chính tả. Nhóm chọn cách này vì giữ nguyên được nhãn nên đo sạch. Đây là giới hạn lớn nhất.
+Nếu thầy hỏi: BM25 bỏ dấu giảm là do bỏ dấu hay do đổi cách tách từ?
+Cả hai. Đo riêng trên val: đổi cách tách từ mất 0,047, bỏ dấu mất thêm 0,137.</a:t>
             </a:r>
           </a:p>
         </p:txBody>
@@ -3364,9 +3362,11 @@
           <a:p>
             <a:r>
               <a:rPr lang="en-US" dirty="0"/>
-              <a:t>Đoàn Mậu Thiên Thư  ·  khoảng 35 giây
-Phục hồi vẫn sai, chủ yếu ở từ nói thường mà luật không dùng, như tài xế thành tải xe, máu thành mẫu. Có 166 câu sai ít nhất một âm tiết, trong đó mất 9 câu tìm đúng và được lại 1 câu.
-Bên phải là câu gõ dấu một nửa, chữ có dấu chữ không. Vì chữ đã có dấu được giữ nguyên nên câu nửa dấu từ 74,81 lên 97,21, còn câu vốn đủ dấu đi qua bước này vẫn giữ nguyên 97,72.</a:t>
+              <a:t>Đoàn Mậu Thiên Thư  ·  khoảng 45 giây
+Cách nhóm sửa là phục hồi dấu trước khi tìm. Nhóm đếm các cặp âm tiết đi liền nhau trong 18,6 triệu âm tiết của chính kho luật. Mỗi âm tiết không dấu có vài ứng viên, như nghi có thể là nghỉ, nghị, nghĩ, rồi thuật toán Viterbi chọn chuỗi có xác suất cao nhất.
+Kết quả đúng 98,45 phần trăm âm tiết, mỗi câu chưa tới một mili giây, học xong trong 15 giây trên CPU. Hệ từ 14,47 lên 96,70, chỉ kém câu có dấu 1,02 điểm.
+Nếu thầy hỏi: Sao không dùng mô hình phục hồi dấu có sẵn hoặc LLM?
+Nhóm chưa so trên cùng bộ dữ liệu nên không nói hơn kém. Bigram có lợi là không phải tải thêm mô hình, chạy trên CPU, và học đúng từ vựng luật.</a:t>
             </a:r>
           </a:p>
         </p:txBody>
@@ -3454,8 +3454,8 @@
             <a:r>
               <a:rPr lang="en-US" dirty="0"/>
               <a:t>Đoàn Mậu Thiên Thư  ·  khoảng 35 giây
-Nhóm rút ra ba điều. Một, với câu có dấu, hợp nhất chỉ hơn ngữ nghĩa 4 câu, BM25 đáng giữ vì nhanh và giải thích được. Hai, khi mất dấu thì hệ sụp, và một mô hình bigram nhỏ học từ kho luật kéo lại gần hết. Ba, chống rò rỉ phải kiểm cả mô hình tải về, không dừng ở chia lại tập.
-Giới hạn lớn nhất là câu không dấu do máy tạo, chưa có câu người thật gõ. Em xin hết phần trình bày, nhóm xin chuyển sang demo.</a:t>
+Phục hồi vẫn sai, chủ yếu ở từ nói thường mà luật không dùng, như tài xế thành tải xe, máu thành mẫu. Có 166 câu sai ít nhất một âm tiết, trong đó mất 9 câu tìm đúng và được lại 1 câu.
+Bên phải là câu gõ dấu một nửa, chữ có dấu chữ không. Vì chữ đã có dấu được giữ nguyên nên câu nửa dấu từ 74,81 lên 97,21, còn câu vốn đủ dấu đi qua bước này vẫn giữ nguyên 97,72.</a:t>
             </a:r>
           </a:p>
         </p:txBody>
@@ -3542,7 +3542,9 @@
           <a:p>
             <a:r>
               <a:rPr lang="en-US" dirty="0"/>
-              <a:t>Không trình bày.</a:t>
+              <a:t>Đoàn Mậu Thiên Thư  ·  khoảng 35 giây
+Nhóm rút ra ba điều. Một, với câu có dấu, hợp nhất chỉ hơn ngữ nghĩa 4 câu, BM25 đáng giữ vì nhanh và giải thích được. Hai, khi mất dấu thì hệ sụp, và một mô hình bigram nhỏ học từ kho luật kéo lại gần hết. Ba, chống rò rỉ phải kiểm cả mô hình tải về, không dừng ở chia lại tập.
+Giới hạn lớn nhất là câu không dấu do máy tạo, chưa có câu người thật gõ. Em xin hết phần trình bày, nhóm xin chuyển sang demo.</a:t>
             </a:r>
           </a:p>
         </p:txBody>
@@ -3584,7 +3586,7 @@
 </file>
 
 <file path=ppt/notesSlides/notesSlide17.xml><?xml version="1.0" encoding="utf-8"?>
-<p:notes xmlns:a="http://schemas.openxmlformats.org/drawingml/2006/main" xmlns:p="http://schemas.openxmlformats.org/presentationml/2006/main" xmlns:r="http://schemas.openxmlformats.org/officeDocument/2006/relationships">
+<p:notes xmlns:a="http://schemas.openxmlformats.org/drawingml/2006/main" xmlns:r="http://schemas.openxmlformats.org/officeDocument/2006/relationships" xmlns:p="http://schemas.openxmlformats.org/presentationml/2006/main">
   <p:cSld>
     <p:spTree>
       <p:nvGrpSpPr>
@@ -3602,6 +3604,18 @@
       </p:grpSpPr>
       <p:sp>
         <p:nvSpPr>
+          <p:cNvPr id="2" name="Slide Image Placeholder 1"/>
+          <p:cNvSpPr>
+            <a:spLocks noGrp="1" noRot="1" noChangeAspect="1"/>
+          </p:cNvSpPr>
+          <p:nvPr>
+            <p:ph type="sldImg"/>
+          </p:nvPr>
+        </p:nvSpPr>
+        <p:spPr/>
+      </p:sp>
+      <p:sp>
+        <p:nvSpPr>
           <p:cNvPr id="3" name="Notes Placeholder 2"/>
           <p:cNvSpPr>
             <a:spLocks noGrp="1"/>
@@ -3616,18 +3630,41 @@
           <a:lstStyle/>
           <a:p>
             <a:r>
-              <a:t>Cả nhóm  ·  khoảng 5 giây</a:t>
-            </a:r>
-          </a:p>
-          <a:p/>
-          <a:p>
-            <a:r>
-              <a:t>Nhóm em xin cảm ơn thầy và các bạn đã lắng nghe.</a:t>
-            </a:r>
+              <a:rPr lang="en-US" dirty="0"/>
+              <a:t>Không trình bày.</a:t>
+            </a:r>
+          </a:p>
+        </p:txBody>
+      </p:sp>
+      <p:sp>
+        <p:nvSpPr>
+          <p:cNvPr id="4" name="Slide Number Placeholder 3"/>
+          <p:cNvSpPr>
+            <a:spLocks noGrp="1"/>
+          </p:cNvSpPr>
+          <p:nvPr>
+            <p:ph type="sldNum" sz="quarter" idx="10"/>
+          </p:nvPr>
+        </p:nvSpPr>
+        <p:spPr/>
+        <p:txBody>
+          <a:bodyPr/>
+          <a:lstStyle/>
+          <a:p>
+            <a:fld id="{F7021451-1387-4CA6-816F-3879F97B5CBC}" type="slidenum">
+              <a:rPr lang="en-US"/>
+              <a:t>17</a:t>
+            </a:fld>
+            <a:endParaRPr lang="en-US"/>
           </a:p>
         </p:txBody>
       </p:sp>
     </p:spTree>
+    <p:extLst>
+      <p:ext uri="{BB962C8B-B14F-4D97-AF65-F5344CB8AC3E}">
+        <p14:creationId xmlns:p14="http://schemas.microsoft.com/office/powerpoint/2010/main" val="1024086991"/>
+      </p:ext>
+    </p:extLst>
   </p:cSld>
   <p:clrMapOvr>
     <a:masterClrMapping/>
@@ -3636,7 +3673,7 @@
 </file>
 
 <file path=ppt/notesSlides/notesSlide18.xml><?xml version="1.0" encoding="utf-8"?>
-<p:notes xmlns:a="http://schemas.openxmlformats.org/drawingml/2006/main" xmlns:p="http://schemas.openxmlformats.org/presentationml/2006/main" xmlns:r="http://schemas.openxmlformats.org/officeDocument/2006/relationships">
+<p:notes xmlns:a="http://schemas.openxmlformats.org/drawingml/2006/main" xmlns:r="http://schemas.openxmlformats.org/officeDocument/2006/relationships" xmlns:p="http://schemas.openxmlformats.org/presentationml/2006/main">
   <p:cSld>
     <p:spTree>
       <p:nvGrpSpPr>
@@ -3668,13 +3705,15 @@
           <a:lstStyle/>
           <a:p>
             <a:r>
-              <a:t>Lê Hoàng Lộc  ·  khoảng 10 giây</a:t>
-            </a:r>
-          </a:p>
-          <a:p/>
-          <a:p>
-            <a:r>
-              <a:t>Bài trình bày của em gồm năm phần: bài toán, dữ liệu, phương pháp, kết quả, và cuối cùng là kết luận kèm demo.</a:t>
+              <a:t>Cả nhóm  ·  khoảng 5 giây</a:t>
+            </a:r>
+          </a:p>
+          <a:p>
+            <a:endParaRPr/>
+          </a:p>
+          <a:p>
+            <a:r>
+              <a:t>Nhóm em xin cảm ơn thầy và các bạn đã lắng nghe.</a:t>
             </a:r>
           </a:p>
         </p:txBody>
@@ -3706,18 +3745,6 @@
       </p:grpSpPr>
       <p:sp>
         <p:nvSpPr>
-          <p:cNvPr id="2" name="Slide Image Placeholder 1"/>
-          <p:cNvSpPr>
-            <a:spLocks noGrp="1" noRot="1" noChangeAspect="1"/>
-          </p:cNvSpPr>
-          <p:nvPr>
-            <p:ph type="sldImg"/>
-          </p:nvPr>
-        </p:nvSpPr>
-        <p:spPr/>
-      </p:sp>
-      <p:sp>
-        <p:nvSpPr>
           <p:cNvPr id="3" name="Notes Placeholder 2"/>
           <p:cNvSpPr>
             <a:spLocks noGrp="1"/>
@@ -3732,44 +3759,20 @@
           <a:lstStyle/>
           <a:p>
             <a:r>
-              <a:rPr lang="en-US" dirty="0"/>
-              <a:t>Lê Hoàng Lộc  ·  khoảng 40 giây
-Bài toán là: người dân gõ một câu hỏi pháp luật, hệ thống trả về điều luật liên quan trong 61.425 điều của 3.271 văn bản.
-Khó ở hai chỗ. Một là người hỏi dùng lời thường còn luật dùng thuật ngữ, như câu nướng bắp trên cầu này, điều luật đúng không trùng với câu hỏi chữ nào.
-Hai, cũng là chỗ nhóm tập trung, là nhiều người gõ không dấu, nhất là khi nhắn trên điện thoại. Với máy thì chữ phạt có dấu và chữ phat không dấu là hai chữ khác hẳn nhau.</a:t>
-            </a:r>
-          </a:p>
-        </p:txBody>
-      </p:sp>
-      <p:sp>
-        <p:nvSpPr>
-          <p:cNvPr id="4" name="Slide Number Placeholder 3"/>
-          <p:cNvSpPr>
-            <a:spLocks noGrp="1"/>
-          </p:cNvSpPr>
-          <p:nvPr>
-            <p:ph type="sldNum" sz="quarter" idx="10"/>
-          </p:nvPr>
-        </p:nvSpPr>
-        <p:spPr/>
-        <p:txBody>
-          <a:bodyPr/>
-          <a:lstStyle/>
-          <a:p>
-            <a:fld id="{F7021451-1387-4CA6-816F-3879F97B5CBC}" type="slidenum">
-              <a:rPr lang="en-US"/>
-              <a:t>2</a:t>
-            </a:fld>
-            <a:endParaRPr lang="en-US"/>
+              <a:t>Lê Hoàng Lộc  ·  khoảng 10 giây</a:t>
+            </a:r>
+          </a:p>
+          <a:p>
+            <a:endParaRPr/>
+          </a:p>
+          <a:p>
+            <a:r>
+              <a:t>Bài trình bày của em gồm năm phần: bài toán, dữ liệu, phương pháp, kết quả, và cuối cùng là kết luận kèm demo.</a:t>
+            </a:r>
           </a:p>
         </p:txBody>
       </p:sp>
     </p:spTree>
-    <p:extLst>
-      <p:ext uri="{BB962C8B-B14F-4D97-AF65-F5344CB8AC3E}">
-        <p14:creationId xmlns:p14="http://schemas.microsoft.com/office/powerpoint/2010/main" val="1024086991"/>
-      </p:ext>
-    </p:extLst>
   </p:cSld>
   <p:clrMapOvr>
     <a:masterClrMapping/>
@@ -3824,10 +3827,9 @@
             <a:r>
               <a:rPr lang="en-US" dirty="0"/>
               <a:t>Lê Hoàng Lộc  ·  khoảng 40 giây
-Nhóm có đọc lại các nghiên cứu trước. Ghép tìm theo từ khóa với tìm theo ngữ nghĩa thì từ các đội thi Zalo 2021 đến bài ở hội nghị EACL năm nay đều làm rồi, và đều thấy ghép tốt hơn dùng riêng. Nhóm chỉ lặp lại phép so đó thì không có gì mới.
-Dòng màu đỏ mới là chỗ nhóm để ý: phục hồi dấu tiếng Việt đã đạt khoảng 97 phần trăm, nhưng người ta đo nó như một bài toán riêng, chưa ai đo xem nó giúp tìm luật được bao nhiêu.
-Nếu thầy hỏi: Nhóm đọc hết các bài đó chưa?
-Nhóm đọc phần tóm tắt, mã nguồn và model card, không đọc hết toàn văn. Danh sách 27 nguồn ở slide 16.</a:t>
+Bài toán là: người dân gõ một câu hỏi pháp luật, hệ thống trả về điều luật liên quan trong 61.425 điều của 3.271 văn bản.
+Khó ở hai chỗ. Một là người hỏi dùng lời thường còn luật dùng thuật ngữ, như câu nướng bắp trên cầu này, điều luật đúng không trùng với câu hỏi chữ nào.
+Hai, cũng là chỗ nhóm tập trung, là nhiều người gõ không dấu, nhất là khi nhắn trên điện thoại. Với máy thì chữ phạt có dấu và chữ phat không dấu là hai chữ khác hẳn nhau.</a:t>
             </a:r>
           </a:p>
         </p:txBody>
@@ -3915,10 +3917,10 @@
             <a:r>
               <a:rPr lang="en-US" dirty="0"/>
               <a:t>Lê Hoàng Lộc  ·  khoảng 40 giây
-Xếp lại thì ra cái bảng này. Tìm luật trên câu có dấu thì làm nhiều rồi, phục hồi dấu cũng làm rồi. Còn ô đỏ, tìm luật khi câu hỏi mất dấu, thì trong các nguồn nhóm đọc chưa ai đo. Đó là câu hỏi thứ hai.
-Câu hỏi thứ nhất là đo xem hệ tìm tốt tới đâu khi câu hỏi có dấu, với dữ liệu đã làm sạch và mô hình chưa từng thấy đề, và ghép thêm BM25 thì được thêm bao nhiêu. Có con số đó làm mốc thì mới biết mất dấu làm hệ tụt bao nhiêu.
-Nếu thầy hỏi: Chắc chắn chưa ai làm?
-Nhóm chỉ nói trong phạm vi các nguồn đã đối chiếu, không dám khẳng định cho mọi công trình.</a:t>
+Nhóm có đọc lại các nghiên cứu trước. Ghép tìm theo từ khóa với tìm theo ngữ nghĩa thì từ các đội thi Zalo 2021 đến bài ở hội nghị EACL năm nay đều làm rồi, và đều thấy ghép tốt hơn dùng riêng. Nhóm chỉ lặp lại phép so đó thì không có gì mới.
+Dòng màu đỏ mới là chỗ nhóm để ý: phục hồi dấu tiếng Việt đã đạt khoảng 97 phần trăm, nhưng người ta đo nó như một bài toán riêng, chưa ai đo xem nó giúp tìm luật được bao nhiêu.
+Nếu thầy hỏi: Nhóm đọc hết các bài đó chưa?
+Nhóm đọc phần tóm tắt, mã nguồn và model card, không đọc hết toàn văn. Danh sách 27 nguồn ở slide 16.</a:t>
             </a:r>
           </a:p>
         </p:txBody>
@@ -4006,10 +4008,10 @@
             <a:r>
               <a:rPr lang="en-US" dirty="0"/>
               <a:t>Lê Hoàng Lộc  ·  khoảng 40 giây
-Dữ liệu là bộ Zalo AI Challenge 2021, bản trên HuggingFace, đã được đưa vào bộ đánh giá MTEB. Bộ gốc chỉ có train và test, không có tập val, nên nhóm tự cắt val ra từ train.
-Bộ này đã công bố nhưng nhóm vẫn kiểm tra lại, ra sáu vấn đề như biểu đồ. Có 780 điều bị nhân đôi chỉ vì mã văn bản viết nd hay nđ, tức là chuyện dấu đã gây lỗi ngay trong dữ liệu. Nặng nhất là thanh cuối: 26 câu hỏi nằm ở cả train lẫn test. Phần này bạn Tuấn Anh nói tiếp.
-Nếu thầy hỏi: Sao không xóa các điều trùng?
-Kho luật thật có điều trùng thật, và các nhóm trùng đều nằm ở những văn bản khác nhau. Xóa đi thì bài toán dễ đi một cách giả tạo, nên nhóm chỉ báo cáo.</a:t>
+Xếp lại thì ra cái bảng này. Tìm luật trên câu có dấu thì làm nhiều rồi, phục hồi dấu cũng làm rồi. Còn ô đỏ, tìm luật khi câu hỏi mất dấu, thì trong các nguồn nhóm đọc chưa ai đo. Đó là câu hỏi thứ hai.
+Câu hỏi thứ nhất là đo xem hệ tìm tốt tới đâu khi câu hỏi có dấu, với dữ liệu đã làm sạch và mô hình chưa từng thấy đề, và ghép thêm BM25 thì được thêm bao nhiêu. Có con số đó làm mốc thì mới biết mất dấu làm hệ tụt bao nhiêu.
+Nếu thầy hỏi: Chắc chắn chưa ai làm?
+Nhóm chỉ nói trong phạm vi các nguồn đã đối chiếu, không dám khẳng định cho mọi công trình.</a:t>
             </a:r>
           </a:p>
         </p:txBody>
@@ -4096,12 +4098,11 @@
           <a:p>
             <a:r>
               <a:rPr lang="en-US" dirty="0"/>
-              <a:t>Lê Thị Tuấn Anh  ·  khoảng 45 giây
-Dạ, trong 26 câu đó có 24 câu trùng đúng mã câu hỏi. Tưởng là dòng bị lặp, nhưng đọc kỹ thì cả 24 câu đều mang nhãn khác nhau: tệp train chỉ sang một điều luật, tệp test chỉ sang điều khác.
-Như câu đầu, bị thương tật 25 phần trăm có bị khởi tố không, train ghi luật sửa đổi Bộ luật Hình sự, test ghi Bộ luật Tố tụng Hình sự. Điều nào cũng liên quan. Tức là một câu hỏi có thể đúng với nhiều điều mà nhãn chỉ ghi một, nên mọi con số Recall nhóm báo cáo đều là cận dưới.
-Nhóm bỏ các câu này khỏi tập train và giữ nguyên tập test gốc của bộ dữ liệu.
-Nếu thầy hỏi: Sao không gộp nhãn train vào test cho đủ?
-Gộp vào là tự sửa nhãn của tập test bằng phỏng đoán của nhóm. Bản chạy đầu có gộp nhầm, test phình từ 793 lên 818 cặp, nhóm phát hiện khi đối chiếu số dòng với tệp gốc và đã sửa.</a:t>
+              <a:t>Lê Hoàng Lộc  ·  khoảng 40 giây
+Dữ liệu là bộ Zalo AI Challenge 2021, bản trên HuggingFace, đã được đưa vào bộ đánh giá MTEB. Bộ gốc chỉ có train và test, không có tập val, nên nhóm tự cắt val ra từ train.
+Bộ này đã công bố nhưng nhóm vẫn kiểm tra lại, ra sáu vấn đề như biểu đồ. Có 780 điều bị nhân đôi chỉ vì mã văn bản viết nd hay nđ, tức là chuyện dấu đã gây lỗi ngay trong dữ liệu. Nặng nhất là thanh cuối: 26 câu hỏi nằm ở cả train lẫn test. Phần này bạn Tuấn Anh nói tiếp.
+Nếu thầy hỏi: Sao không xóa các điều trùng?
+Kho luật thật có điều trùng thật, và các nhóm trùng đều nằm ở những văn bản khác nhau. Xóa đi thì bài toán dễ đi một cách giả tạo, nên nhóm chỉ báo cáo.</a:t>
             </a:r>
           </a:p>
         </p:txBody>
@@ -4189,10 +4190,11 @@
             <a:r>
               <a:rPr lang="en-US" dirty="0"/>
               <a:t>Lê Thị Tuấn Anh  ·  khoảng 45 giây
-Rò rỉ còn nằm ở chỗ khó thấy hơn, là trong mô hình. Nhóm định dùng bkai, mô hình ngữ nghĩa tiếng Việt được dùng nhiều nhất. Nhưng trang giới thiệu mô hình ghi đã huấn luyện trên 80 phần trăm tập train của Zalo 2021, mà tập test của nhóm lại cắt ra từ đúng tập đó. Tức là mô hình đã xem đề và đáp án trước khi thi.
-Nên nhóm chuyển sang AITeamVN, model card ghi rõ không học bộ này, và dùng nó cho mọi con số chính thức. bkai vẫn chạy để so nhưng gắn nhãn nhiễm bẩn. Chia lại xong, nhóm có 1.925 câu train, 481 câu val để chỉnh tham số, và 788 câu test chỉ chạy đúng một lần.
-Nếu thầy hỏi: Sao tin model card của AITeamVN?
-Nhóm không kiểm chứng trực tiếp được, nên ghi rõ đó là lời của tác giả mô hình, không phải kết quả nhóm tự đo.</a:t>
+Dạ, trong 26 câu đó có 24 câu trùng đúng mã câu hỏi. Tưởng là dòng bị lặp, nhưng đọc kỹ thì cả 24 câu đều mang nhãn khác nhau: tệp train chỉ sang một điều luật, tệp test chỉ sang điều khác.
+Như câu đầu, bị thương tật 25 phần trăm có bị khởi tố không, train ghi luật sửa đổi Bộ luật Hình sự, test ghi Bộ luật Tố tụng Hình sự. Điều nào cũng liên quan. Tức là một câu hỏi có thể đúng với nhiều điều mà nhãn chỉ ghi một, nên mọi con số Recall nhóm báo cáo đều là cận dưới.
+Nhóm bỏ các câu này khỏi tập train và giữ nguyên tập test gốc của bộ dữ liệu.
+Nếu thầy hỏi: Sao không gộp nhãn train vào test cho đủ?
+Gộp vào là tự sửa nhãn của tập test bằng phỏng đoán của nhóm. Bản chạy đầu có gộp nhầm, test phình từ 793 lên 818 cặp, nhóm phát hiện khi đối chiếu số dòng với tệp gốc và đã sửa.</a:t>
             </a:r>
           </a:p>
         </p:txBody>
@@ -4280,11 +4282,10 @@
             <a:r>
               <a:rPr lang="en-US" dirty="0"/>
               <a:t>Lê Thị Tuấn Anh  ·  khoảng 45 giây
-Đây là kiến trúc. Câu hỏi nào cũng đi qua khâu phục hồi dấu trước, không cần biết nó có dấu hay chưa, vì chữ đã có dấu thì giữ nguyên.
-Sau đó chia hai nhánh. Nhánh trên là BM25, tìm theo từ khóa trên cả điều luật, mạnh ở số hiệu và thuật ngữ. Nhánh dưới là mô hình ngữ nghĩa, tìm trên các đoạn nhỏ, điều nào có đoạn điểm cao nhất thì lấy điểm đó. Mỗi nhánh lấy 100 điều tốt nhất, rồi cộng điểm hai nhánh lại, nhánh ngữ nghĩa nặng hơn, trọng số 0,75 chọn trên tập val.
-Cuối cùng hệ đưa ra đúng khoản luật tìm được, y như trong văn bản, chứ không tự viết câu trả lời, nên không bịa được.
-Nếu thầy hỏi: Sao lấy điểm cao nhất mà không lấy trung bình các đoạn?
-Câu trả lời thường nằm gọn trong một khoản, lấy trung bình thì các khoản khác kéo điểm xuống. Đo trên val: max 0,9563, trung bình 0,9127.</a:t>
+Rò rỉ còn nằm ở chỗ khó thấy hơn, là trong mô hình. Nhóm định dùng bkai, mô hình ngữ nghĩa tiếng Việt được dùng nhiều nhất. Nhưng trang giới thiệu mô hình ghi đã huấn luyện trên 80 phần trăm tập train của Zalo 2021, mà tập test của nhóm lại cắt ra từ đúng tập đó. Tức là mô hình đã xem đề và đáp án trước khi thi.
+Nên nhóm chuyển sang AITeamVN, model card ghi rõ không học bộ này, và dùng nó cho mọi con số chính thức. bkai vẫn chạy để so nhưng gắn nhãn nhiễm bẩn. Chia lại xong, nhóm có 1.925 câu train, 481 câu val để chỉnh tham số, và 788 câu test chỉ chạy đúng một lần.
+Nếu thầy hỏi: Sao tin model card của AITeamVN?
+Nhóm không kiểm chứng trực tiếp được, nên ghi rõ đó là lời của tác giả mô hình, không phải kết quả nhóm tự đo.</a:t>
             </a:r>
           </a:p>
         </p:txBody>
@@ -4371,9 +4372,12 @@
           <a:p>
             <a:r>
               <a:rPr lang="en-US" dirty="0"/>
-              <a:t>Lê Thị Tuấn Anh  ·  khoảng 35 giây
-Vì sao phải chia đoạn? Mô hình chỉ đọc được 256 token, khoảng 140 chữ. Phần màu đỏ là các điều dài hơn thế, chiếm 61,1 phần trăm. Cắt cụt thì mất phần đuôi, mà đuôi điều luật hay là mức phạt và các ngoại lệ.
-Nên nhóm cắt mỗi điều ra theo từng khoản. Khoản nào vẫn dài quá thì chia nhỏ thêm. Đoạn nào cũng ghi tên điều ở đầu, để mô hình biết đoạn đó đang nói về chuyện gì. Cắt xong, 61.425 điều thành 154.176 đoạn.</a:t>
+              <a:t>Lê Thị Tuấn Anh  ·  khoảng 45 giây
+Đây là kiến trúc. Câu hỏi nào cũng đi qua khâu phục hồi dấu trước, không cần biết nó có dấu hay chưa, vì chữ đã có dấu thì giữ nguyên.
+Sau đó chia hai nhánh. Nhánh trên là BM25, tìm theo từ khóa trên cả điều luật, mạnh ở số hiệu và thuật ngữ. Nhánh dưới là mô hình ngữ nghĩa, tìm trên các đoạn nhỏ, điều nào có đoạn điểm cao nhất thì lấy điểm đó. Mỗi nhánh lấy 100 điều tốt nhất, rồi cộng điểm hai nhánh lại, nhánh ngữ nghĩa nặng hơn, trọng số 0,75 chọn trên tập val.
+Cuối cùng hệ đưa ra đúng khoản luật tìm được, y như trong văn bản, chứ không tự viết câu trả lời, nên không bịa được.
+Nếu thầy hỏi: Sao lấy điểm cao nhất mà không lấy trung bình các đoạn?
+Câu trả lời thường nằm gọn trong một khoản, lấy trung bình thì các khoản khác kéo điểm xuống. Đo trên val: max 0,9563, trung bình 0,9127.</a:t>
             </a:r>
           </a:p>
         </p:txBody>
@@ -5161,16 +5165,7 @@
                 </a:solidFill>
                 <a:latin typeface="Cambria"/>
               </a:rPr>
-              <a:t>Phần 3</a:t>
-            </a:r>
-            <a:r>
-              <a:rPr sz="1400" b="0">
-                <a:solidFill>
-                  <a:srgbClr val="77858E"/>
-                </a:solidFill>
-                <a:latin typeface="Cambria"/>
-              </a:rPr>
-              <a:t>   |   </a:t>
+              <a:t>Phần 3   |   </a:t>
             </a:r>
             <a:r>
               <a:rPr sz="1500" b="0">
@@ -5597,16 +5592,7 @@
                 </a:solidFill>
                 <a:latin typeface="Cambria"/>
               </a:rPr>
-              <a:t>Phần 4</a:t>
-            </a:r>
-            <a:r>
-              <a:rPr sz="1400" b="0">
-                <a:solidFill>
-                  <a:srgbClr val="77858E"/>
-                </a:solidFill>
-                <a:latin typeface="Cambria"/>
-              </a:rPr>
-              <a:t>   |   </a:t>
+              <a:t>Phần 4   |   </a:t>
             </a:r>
             <a:r>
               <a:rPr sz="1500" b="0">
@@ -6016,16 +6002,7 @@
                 </a:solidFill>
                 <a:latin typeface="Cambria"/>
               </a:rPr>
-              <a:t>Phần 4</a:t>
-            </a:r>
-            <a:r>
-              <a:rPr sz="1400" b="0">
-                <a:solidFill>
-                  <a:srgbClr val="77858E"/>
-                </a:solidFill>
-                <a:latin typeface="Cambria"/>
-              </a:rPr>
-              <a:t>   |   </a:t>
+              <a:t>Phần 4   |   </a:t>
             </a:r>
             <a:r>
               <a:rPr sz="1500" b="0">
@@ -6955,16 +6932,7 @@
                 </a:solidFill>
                 <a:latin typeface="Cambria"/>
               </a:rPr>
-              <a:t>Phần 4</a:t>
-            </a:r>
-            <a:r>
-              <a:rPr sz="1400" b="0">
-                <a:solidFill>
-                  <a:srgbClr val="77858E"/>
-                </a:solidFill>
-                <a:latin typeface="Cambria"/>
-              </a:rPr>
-              <a:t>   |   </a:t>
+              <a:t>Phần 4   |   </a:t>
             </a:r>
             <a:r>
               <a:rPr sz="1500" b="0">
@@ -7379,16 +7347,7 @@
                 </a:solidFill>
                 <a:latin typeface="Cambria"/>
               </a:rPr>
-              <a:t>Phần 4</a:t>
-            </a:r>
-            <a:r>
-              <a:rPr sz="1400" b="0">
-                <a:solidFill>
-                  <a:srgbClr val="77858E"/>
-                </a:solidFill>
-                <a:latin typeface="Cambria"/>
-              </a:rPr>
-              <a:t>   |   </a:t>
+              <a:t>Phần 4   |   </a:t>
             </a:r>
             <a:r>
               <a:rPr sz="1500" b="0">
@@ -8156,16 +8115,7 @@
                 </a:solidFill>
                 <a:latin typeface="Cambria"/>
               </a:rPr>
-              <a:t>Phần 4</a:t>
-            </a:r>
-            <a:r>
-              <a:rPr sz="1400" b="0">
-                <a:solidFill>
-                  <a:srgbClr val="77858E"/>
-                </a:solidFill>
-                <a:latin typeface="Cambria"/>
-              </a:rPr>
-              <a:t>   |   </a:t>
+              <a:t>Phần 4   |   </a:t>
             </a:r>
             <a:r>
               <a:rPr sz="1500" b="0">
@@ -8887,16 +8837,7 @@
                 </a:solidFill>
                 <a:latin typeface="Cambria"/>
               </a:rPr>
-              <a:t>Phần 5</a:t>
-            </a:r>
-            <a:r>
-              <a:rPr sz="1400" b="0">
-                <a:solidFill>
-                  <a:srgbClr val="9AA8B2"/>
-                </a:solidFill>
-                <a:latin typeface="Cambria"/>
-              </a:rPr>
-              <a:t>   |   </a:t>
+              <a:t>Phần 5   |   </a:t>
             </a:r>
             <a:r>
               <a:rPr sz="1500" b="0">
@@ -9482,16 +9423,7 @@
                 </a:solidFill>
                 <a:latin typeface="Cambria"/>
               </a:rPr>
-              <a:t>Phụ lục</a:t>
-            </a:r>
-            <a:r>
-              <a:rPr sz="1400" b="0">
-                <a:solidFill>
-                  <a:srgbClr val="77858E"/>
-                </a:solidFill>
-                <a:latin typeface="Cambria"/>
-              </a:rPr>
-              <a:t>   |   </a:t>
+              <a:t>Phụ lục   |   </a:t>
             </a:r>
             <a:r>
               <a:rPr sz="1500" b="0">
@@ -10659,6 +10591,7 @@
           <a:lstStyle/>
           <a:p>
             <a:pPr algn="ctr"/>
+            <a:endParaRPr/>
           </a:p>
         </p:txBody>
       </p:sp>
@@ -10699,7 +10632,7 @@
           </a:fontRef>
         </p:style>
         <p:txBody>
-          <a:bodyPr rtlCol="0" anchor="ctr" lIns="0" rIns="0" tIns="0" bIns="0"/>
+          <a:bodyPr lIns="0" tIns="0" rIns="0" bIns="0" rtlCol="0" anchor="ctr"/>
           <a:lstStyle/>
           <a:p>
             <a:pPr algn="ctr"/>
@@ -10724,28 +10657,79 @@
         <p:spPr>
           <a:xfrm>
             <a:off x="822960" y="3063240"/>
-            <a:ext cx="1605686" cy="457200"/>
-          </a:xfrm>
-          <a:prstGeom prst="rect">
-            <a:avLst/>
-          </a:prstGeom>
-          <a:noFill/>
-        </p:spPr>
-        <p:txBody>
-          <a:bodyPr wrap="square" lIns="0" rIns="0" tIns="0" bIns="0">
+            <a:ext cx="1605686" cy="246221"/>
+          </a:xfrm>
+          <a:prstGeom prst="rect">
+            <a:avLst/>
+          </a:prstGeom>
+          <a:noFill/>
+        </p:spPr>
+        <p:txBody>
+          <a:bodyPr wrap="square" lIns="0" tIns="0" rIns="0" bIns="0">
             <a:spAutoFit/>
           </a:bodyPr>
           <a:lstStyle/>
           <a:p>
             <a:r>
-              <a:rPr sz="2000" b="1">
+              <a:rPr lang="en-US" sz="1600" b="1" dirty="0">
                 <a:solidFill>
                   <a:srgbClr val="16222C"/>
                 </a:solidFill>
                 <a:latin typeface="Cambria"/>
               </a:rPr>
-              <a:t>Bài toán</a:t>
-            </a:r>
+              <a:t>Lý do </a:t>
+            </a:r>
+            <a:r>
+              <a:rPr lang="en-US" sz="1600" b="1" dirty="0" err="1">
+                <a:solidFill>
+                  <a:srgbClr val="16222C"/>
+                </a:solidFill>
+                <a:latin typeface="Cambria"/>
+              </a:rPr>
+              <a:t>chọn</a:t>
+            </a:r>
+            <a:r>
+              <a:rPr lang="en-US" sz="1600" b="1" dirty="0">
+                <a:solidFill>
+                  <a:srgbClr val="16222C"/>
+                </a:solidFill>
+                <a:latin typeface="Cambria"/>
+              </a:rPr>
+              <a:t> </a:t>
+            </a:r>
+            <a:r>
+              <a:rPr lang="en-US" sz="1600" b="1" dirty="0" err="1">
+                <a:solidFill>
+                  <a:srgbClr val="16222C"/>
+                </a:solidFill>
+                <a:latin typeface="Cambria"/>
+              </a:rPr>
+              <a:t>đề</a:t>
+            </a:r>
+            <a:r>
+              <a:rPr lang="en-US" sz="1600" b="1" dirty="0">
+                <a:solidFill>
+                  <a:srgbClr val="16222C"/>
+                </a:solidFill>
+                <a:latin typeface="Cambria"/>
+              </a:rPr>
+              <a:t> </a:t>
+            </a:r>
+            <a:r>
+              <a:rPr lang="en-US" sz="1600" b="1" dirty="0" err="1">
+                <a:solidFill>
+                  <a:srgbClr val="16222C"/>
+                </a:solidFill>
+                <a:latin typeface="Cambria"/>
+              </a:rPr>
+              <a:t>tài</a:t>
+            </a:r>
+            <a:endParaRPr sz="1600" b="1" dirty="0">
+              <a:solidFill>
+                <a:srgbClr val="16222C"/>
+              </a:solidFill>
+              <a:latin typeface="Cambria"/>
+            </a:endParaRPr>
           </a:p>
         </p:txBody>
       </p:sp>
@@ -10766,7 +10750,7 @@
           <a:noFill/>
         </p:spPr>
         <p:txBody>
-          <a:bodyPr wrap="square" lIns="0" rIns="0" tIns="0" bIns="0">
+          <a:bodyPr wrap="square" lIns="0" tIns="0" rIns="0" bIns="0">
             <a:spAutoFit/>
           </a:bodyPr>
           <a:lstStyle/>
@@ -10824,6 +10808,7 @@
           <a:lstStyle/>
           <a:p>
             <a:pPr algn="ctr"/>
+            <a:endParaRPr/>
           </a:p>
         </p:txBody>
       </p:sp>
@@ -10864,7 +10849,7 @@
           </a:fontRef>
         </p:style>
         <p:txBody>
-          <a:bodyPr rtlCol="0" anchor="ctr" lIns="0" rIns="0" tIns="0" bIns="0"/>
+          <a:bodyPr lIns="0" tIns="0" rIns="0" bIns="0" rtlCol="0" anchor="ctr"/>
           <a:lstStyle/>
           <a:p>
             <a:pPr algn="ctr"/>
@@ -10897,7 +10882,7 @@
           <a:noFill/>
         </p:spPr>
         <p:txBody>
-          <a:bodyPr wrap="square" lIns="0" rIns="0" tIns="0" bIns="0">
+          <a:bodyPr wrap="square" lIns="0" tIns="0" rIns="0" bIns="0">
             <a:spAutoFit/>
           </a:bodyPr>
           <a:lstStyle/>
@@ -10931,7 +10916,7 @@
           <a:noFill/>
         </p:spPr>
         <p:txBody>
-          <a:bodyPr wrap="square" lIns="0" rIns="0" tIns="0" bIns="0">
+          <a:bodyPr wrap="square" lIns="0" tIns="0" rIns="0" bIns="0">
             <a:spAutoFit/>
           </a:bodyPr>
           <a:lstStyle/>
@@ -10989,6 +10974,7 @@
           <a:lstStyle/>
           <a:p>
             <a:pPr algn="ctr"/>
+            <a:endParaRPr/>
           </a:p>
         </p:txBody>
       </p:sp>
@@ -11029,7 +11015,7 @@
           </a:fontRef>
         </p:style>
         <p:txBody>
-          <a:bodyPr rtlCol="0" anchor="ctr" lIns="0" rIns="0" tIns="0" bIns="0"/>
+          <a:bodyPr lIns="0" tIns="0" rIns="0" bIns="0" rtlCol="0" anchor="ctr"/>
           <a:lstStyle/>
           <a:p>
             <a:pPr algn="ctr"/>
@@ -11062,7 +11048,7 @@
           <a:noFill/>
         </p:spPr>
         <p:txBody>
-          <a:bodyPr wrap="square" lIns="0" rIns="0" tIns="0" bIns="0">
+          <a:bodyPr wrap="square" lIns="0" tIns="0" rIns="0" bIns="0">
             <a:spAutoFit/>
           </a:bodyPr>
           <a:lstStyle/>
@@ -11096,7 +11082,7 @@
           <a:noFill/>
         </p:spPr>
         <p:txBody>
-          <a:bodyPr wrap="square" lIns="0" rIns="0" tIns="0" bIns="0">
+          <a:bodyPr wrap="square" lIns="0" tIns="0" rIns="0" bIns="0">
             <a:spAutoFit/>
           </a:bodyPr>
           <a:lstStyle/>
@@ -11154,6 +11140,7 @@
           <a:lstStyle/>
           <a:p>
             <a:pPr algn="ctr"/>
+            <a:endParaRPr/>
           </a:p>
         </p:txBody>
       </p:sp>
@@ -11194,7 +11181,7 @@
           </a:fontRef>
         </p:style>
         <p:txBody>
-          <a:bodyPr rtlCol="0" anchor="ctr" lIns="0" rIns="0" tIns="0" bIns="0"/>
+          <a:bodyPr lIns="0" tIns="0" rIns="0" bIns="0" rtlCol="0" anchor="ctr"/>
           <a:lstStyle/>
           <a:p>
             <a:pPr algn="ctr"/>
@@ -11227,7 +11214,7 @@
           <a:noFill/>
         </p:spPr>
         <p:txBody>
-          <a:bodyPr wrap="square" lIns="0" rIns="0" tIns="0" bIns="0">
+          <a:bodyPr wrap="square" lIns="0" tIns="0" rIns="0" bIns="0">
             <a:spAutoFit/>
           </a:bodyPr>
           <a:lstStyle/>
@@ -11261,7 +11248,7 @@
           <a:noFill/>
         </p:spPr>
         <p:txBody>
-          <a:bodyPr wrap="square" lIns="0" rIns="0" tIns="0" bIns="0">
+          <a:bodyPr wrap="square" lIns="0" tIns="0" rIns="0" bIns="0">
             <a:spAutoFit/>
           </a:bodyPr>
           <a:lstStyle/>
@@ -11319,6 +11306,7 @@
           <a:lstStyle/>
           <a:p>
             <a:pPr algn="ctr"/>
+            <a:endParaRPr/>
           </a:p>
         </p:txBody>
       </p:sp>
@@ -11359,7 +11347,7 @@
           </a:fontRef>
         </p:style>
         <p:txBody>
-          <a:bodyPr rtlCol="0" anchor="ctr" lIns="0" rIns="0" tIns="0" bIns="0"/>
+          <a:bodyPr lIns="0" tIns="0" rIns="0" bIns="0" rtlCol="0" anchor="ctr"/>
           <a:lstStyle/>
           <a:p>
             <a:pPr algn="ctr"/>
@@ -11392,7 +11380,7 @@
           <a:noFill/>
         </p:spPr>
         <p:txBody>
-          <a:bodyPr wrap="square" lIns="0" rIns="0" tIns="0" bIns="0">
+          <a:bodyPr wrap="square" lIns="0" tIns="0" rIns="0" bIns="0">
             <a:spAutoFit/>
           </a:bodyPr>
           <a:lstStyle/>
@@ -11426,7 +11414,7 @@
           <a:noFill/>
         </p:spPr>
         <p:txBody>
-          <a:bodyPr wrap="square" lIns="0" rIns="0" tIns="0" bIns="0">
+          <a:bodyPr wrap="square" lIns="0" tIns="0" rIns="0" bIns="0">
             <a:spAutoFit/>
           </a:bodyPr>
           <a:lstStyle/>
@@ -11501,31 +11489,76 @@
               <a:buNone/>
             </a:pPr>
             <a:r>
-              <a:rPr sz="1400" b="0">
+              <a:rPr sz="1400" b="0" dirty="0" err="1">
                 <a:solidFill>
                   <a:srgbClr val="77858E"/>
                 </a:solidFill>
                 <a:latin typeface="Cambria"/>
               </a:rPr>
-              <a:t>Phần 1</a:t>
-            </a:r>
-            <a:r>
-              <a:rPr sz="1400" b="0">
+              <a:t>Phần</a:t>
+            </a:r>
+            <a:r>
+              <a:rPr sz="1400" b="0" dirty="0">
                 <a:solidFill>
                   <a:srgbClr val="77858E"/>
                 </a:solidFill>
                 <a:latin typeface="Cambria"/>
               </a:rPr>
-              <a:t>   |   </a:t>
-            </a:r>
-            <a:r>
-              <a:rPr sz="1500" b="0">
+              <a:t> 1   |   </a:t>
+            </a:r>
+            <a:r>
+              <a:rPr lang="en-US" sz="1500" b="0" dirty="0">
                 <a:solidFill>
                   <a:srgbClr val="16222C"/>
                 </a:solidFill>
                 <a:latin typeface="Cambria"/>
               </a:rPr>
-              <a:t>Bài toán</a:t>
+              <a:t>Lý do </a:t>
+            </a:r>
+            <a:r>
+              <a:rPr lang="en-US" sz="1500" b="0" dirty="0" err="1">
+                <a:solidFill>
+                  <a:srgbClr val="16222C"/>
+                </a:solidFill>
+                <a:latin typeface="Cambria"/>
+              </a:rPr>
+              <a:t>chọn</a:t>
+            </a:r>
+            <a:r>
+              <a:rPr lang="en-US" sz="1500" b="0" dirty="0">
+                <a:solidFill>
+                  <a:srgbClr val="16222C"/>
+                </a:solidFill>
+                <a:latin typeface="Cambria"/>
+              </a:rPr>
+              <a:t> </a:t>
+            </a:r>
+            <a:r>
+              <a:rPr lang="en-US" sz="1500" b="0" dirty="0" err="1">
+                <a:solidFill>
+                  <a:srgbClr val="16222C"/>
+                </a:solidFill>
+                <a:latin typeface="Cambria"/>
+              </a:rPr>
+              <a:t>đề</a:t>
+            </a:r>
+            <a:r>
+              <a:rPr lang="en-US" sz="1500" b="0" dirty="0">
+                <a:solidFill>
+                  <a:srgbClr val="16222C"/>
+                </a:solidFill>
+                <a:latin typeface="Cambria"/>
+              </a:rPr>
+              <a:t> </a:t>
+            </a:r>
+            <a:r>
+              <a:rPr lang="en-US" sz="1500" b="0" dirty="0" err="1">
+                <a:solidFill>
+                  <a:srgbClr val="16222C"/>
+                </a:solidFill>
+                <a:latin typeface="Cambria"/>
+              </a:rPr>
+              <a:t>tài</a:t>
             </a:r>
             <a:endParaRPr lang="en-US" sz="1100" dirty="0"/>
           </a:p>
@@ -12276,16 +12309,7 @@
                 </a:solidFill>
                 <a:latin typeface="Cambria"/>
               </a:rPr>
-              <a:t>Phần 1</a:t>
-            </a:r>
-            <a:r>
-              <a:rPr sz="1400" b="0">
-                <a:solidFill>
-                  <a:srgbClr val="77858E"/>
-                </a:solidFill>
-                <a:latin typeface="Cambria"/>
-              </a:rPr>
-              <a:t>   |   </a:t>
+              <a:t>Phần 1   |   </a:t>
             </a:r>
             <a:r>
               <a:rPr sz="1500" b="0">
@@ -13838,16 +13862,7 @@
                 </a:solidFill>
                 <a:latin typeface="Cambria"/>
               </a:rPr>
-              <a:t>Phần 1</a:t>
-            </a:r>
-            <a:r>
-              <a:rPr sz="1400" b="0">
-                <a:solidFill>
-                  <a:srgbClr val="77858E"/>
-                </a:solidFill>
-                <a:latin typeface="Cambria"/>
-              </a:rPr>
-              <a:t>   |   </a:t>
+              <a:t>Phần 1   |   </a:t>
             </a:r>
             <a:r>
               <a:rPr sz="1500" b="0">
@@ -14826,16 +14841,7 @@
                 </a:solidFill>
                 <a:latin typeface="Cambria"/>
               </a:rPr>
-              <a:t>Phần 2</a:t>
-            </a:r>
-            <a:r>
-              <a:rPr sz="1400" b="0">
-                <a:solidFill>
-                  <a:srgbClr val="77858E"/>
-                </a:solidFill>
-                <a:latin typeface="Cambria"/>
-              </a:rPr>
-              <a:t>   |   </a:t>
+              <a:t>Phần 2   |   </a:t>
             </a:r>
             <a:r>
               <a:rPr sz="1500" b="0">
@@ -15401,16 +15407,7 @@
                 </a:solidFill>
                 <a:latin typeface="Cambria"/>
               </a:rPr>
-              <a:t>Phần 2</a:t>
-            </a:r>
-            <a:r>
-              <a:rPr sz="1400" b="0">
-                <a:solidFill>
-                  <a:srgbClr val="77858E"/>
-                </a:solidFill>
-                <a:latin typeface="Cambria"/>
-              </a:rPr>
-              <a:t>   |   </a:t>
+              <a:t>Phần 2   |   </a:t>
             </a:r>
             <a:r>
               <a:rPr sz="1500" b="0">
@@ -15553,8 +15550,8 @@
         </p:nvSpPr>
         <p:spPr>
           <a:xfrm>
-            <a:off x="594360" y="1783080"/>
-            <a:ext cx="3291840" cy="1371600"/>
+            <a:off x="594360" y="1909412"/>
+            <a:ext cx="2425566" cy="551046"/>
           </a:xfrm>
           <a:prstGeom prst="rect">
             <a:avLst/>
@@ -15570,7 +15567,7 @@
               <a:buNone/>
             </a:pPr>
             <a:r>
-              <a:rPr lang="en-US" sz="8800" b="1" dirty="0">
+              <a:rPr lang="en-US" sz="5400" b="1" dirty="0">
                 <a:solidFill>
                   <a:srgbClr val="A8202B"/>
                 </a:solidFill>
@@ -15580,7 +15577,7 @@
               </a:rPr>
               <a:t>07 / 18</a:t>
             </a:r>
-            <a:endParaRPr lang="en-US" sz="8800" dirty="0"/>
+            <a:endParaRPr lang="en-US" sz="5400" dirty="0"/>
           </a:p>
         </p:txBody>
       </p:sp>
@@ -16649,16 +16646,7 @@
                 </a:solidFill>
                 <a:latin typeface="Cambria"/>
               </a:rPr>
-              <a:t>Phần 2</a:t>
-            </a:r>
-            <a:r>
-              <a:rPr sz="1400" b="0">
-                <a:solidFill>
-                  <a:srgbClr val="77858E"/>
-                </a:solidFill>
-                <a:latin typeface="Cambria"/>
-              </a:rPr>
-              <a:t>   |   </a:t>
+              <a:t>Phần 2   |   </a:t>
             </a:r>
             <a:r>
               <a:rPr sz="1500" b="0">
@@ -17583,16 +17571,7 @@
                 </a:solidFill>
                 <a:latin typeface="Cambria"/>
               </a:rPr>
-              <a:t>Phần 3</a:t>
-            </a:r>
-            <a:r>
-              <a:rPr sz="1400" b="0">
-                <a:solidFill>
-                  <a:srgbClr val="77858E"/>
-                </a:solidFill>
-                <a:latin typeface="Cambria"/>
-              </a:rPr>
-              <a:t>   |   </a:t>
+              <a:t>Phần 3   |   </a:t>
             </a:r>
             <a:r>
               <a:rPr sz="1500" b="0">

</xml_diff>